<commit_message>
Add known-answer simulation, the local-sigma fix and an inference package
- Known-answer simulation of the paper's own PIN model with prices
  (src/vpin/simulation.py, scripts/simulation.py): closes the gap in
  the paper's Monte Carlo, which never runs bulk classification.
  Pre-registered rules D1, D2 and D4 hold; D3 does not and is reported.
- The one-day-sigma fix of bulk classification on real data (rule D5,
  scripts/local_sigma.py): tracks true-label VPIN better on BTC and
  removes most of VPIN's link to future volatility.
- Inference package (scripts/inference.py): direction-shuffled placebo,
  leave-one-year-out stability, power, and a ledger of every test with
  Benjamini-Hochberg and Bonferroni corrections and a claimed direction.
- The paper's in-sample method on all 41 two-year windows
  (scripts/windows.py, exploratory).
- README, slides (21 main + 5 backup) and the guide regenerated from
  results; the guide build now verifies that every text block is in
  the PDF.
</commit_message>
<xml_diff>
--- a/docs/presentation.pptx
+++ b/docs/presentation.pptx
@@ -13,22 +13,28 @@
     <p:sldId id="257" r:id="rId13"/>
     <p:sldId id="258" r:id="rId14"/>
     <p:sldId id="259" r:id="rId15"/>
-    <p:sldId id="260" r:id="rId16"/>
     <p:sldId id="261" r:id="rId17"/>
     <p:sldId id="262" r:id="rId18"/>
     <p:sldId id="263" r:id="rId19"/>
     <p:sldId id="264" r:id="rId20"/>
     <p:sldId id="265" r:id="rId21"/>
-    <p:sldId id="266" r:id="rId22"/>
+    <p:sldId id="275" r:id="rId31"/>
     <p:sldId id="267" r:id="rId23"/>
     <p:sldId id="268" r:id="rId11"/>
     <p:sldId id="269" r:id="rId10"/>
     <p:sldId id="270" r:id="rId9"/>
+    <p:sldId id="276" r:id="rId32"/>
+    <p:sldId id="277" r:id="rId33"/>
+    <p:sldId id="278" r:id="rId34"/>
+    <p:sldId id="279" r:id="rId35"/>
+    <p:sldId id="280" r:id="rId36"/>
+    <p:sldId id="273" r:id="rId29"/>
+    <p:sldId id="281" r:id="rId37"/>
+    <p:sldId id="260" r:id="rId16"/>
+    <p:sldId id="266" r:id="rId22"/>
     <p:sldId id="271" r:id="rId8"/>
     <p:sldId id="272" r:id="rId28"/>
-    <p:sldId id="273" r:id="rId29"/>
     <p:sldId id="274" r:id="rId30"/>
-    <p:sldId id="275" r:id="rId31"/>
   </p:sldIdLst>
   <p:sldSz cy="6858000" cx="12192000"/>
   <p:notesSz cx="6858000" cy="9144000"/>
@@ -1981,7 +1987,7 @@
           <a:lstStyle/>
           <a:p>
             <a:r>
-              <a:t>Upgrade, ~1 min. One data source (BTC), three signals. Lift = hit rate divided by how often the alarm is on; a signal that is always on has lift 1. With true labels VPIN has no positive link to future volatility; with BVC it does, because BVC turns price moves into imbalance. Trailing volatility beats both. Andersen and Bondarenko (2014) argued this from equity data; we confirm it with ground truth. Sources: btc_signal_comparison.csv, regressions.csv.</a:t>
+              <a:t>Upgrade, ~1 min. One data source (BTC), three signals. Lift = hit rate divided by how often the alarm is on; a signal that is always on has lift 1. With true labels VPIN has no positive link to future volatility; with BVC it does, because BVC turns price moves into imbalance. Trailing volatility beats both. Andersen and Bondarenko (2014) made this argument; we confirm it with ground truth. Sources: btc_signal_comparison.csv, regressions.csv.</a:t>
             </a:r>
           </a:p>
         </p:txBody>
@@ -2332,6 +2338,426 @@
           <a:p>
             <a:r>
               <a:t>Problem, ~1 min. Market makers earn the spread; adverse selection = trading with someone who knows more. Toxic flow drains them; they withdraw; liquidity vanishes; prices gap. The paper's question: can we see this coming from the trade record alone?</a:t>
+            </a:r>
+          </a:p>
+        </p:txBody>
+      </p:sp>
+      <p:sp>
+        <p:nvSpPr>
+          <p:cNvPr id="4" name="Slide Number Placeholder 3"/>
+          <p:cNvSpPr>
+            <a:spLocks noGrp="1"/>
+          </p:cNvSpPr>
+          <p:nvPr>
+            <p:ph type="sldNum" idx="12"/>
+          </p:nvPr>
+        </p:nvSpPr>
+        <p:spPr/>
+      </p:sp>
+    </p:spTree>
+  </p:cSld>
+  <p:clrMapOvr>
+    <a:masterClrMapping/>
+  </p:clrMapOvr>
+</p:notes>
+</file>
+
+<file path=ppt/notesSlides/notesSlide20.xml><?xml version="1.0" encoding="utf-8"?>
+<p:notes xmlns:a="http://schemas.openxmlformats.org/drawingml/2006/main" xmlns:p="http://schemas.openxmlformats.org/presentationml/2006/main" xmlns:r="http://schemas.openxmlformats.org/officeDocument/2006/relationships">
+  <p:cSld>
+    <p:spTree>
+      <p:nvGrpSpPr>
+        <p:cNvPr id="1" name=""/>
+        <p:cNvGrpSpPr/>
+        <p:nvPr/>
+      </p:nvGrpSpPr>
+      <p:grpSpPr>
+        <a:xfrm>
+          <a:off x="0" y="0"/>
+          <a:ext cx="0" cy="0"/>
+          <a:chOff x="0" y="0"/>
+          <a:chExt cx="0" cy="0"/>
+        </a:xfrm>
+      </p:grpSpPr>
+      <p:sp>
+        <p:nvSpPr>
+          <p:cNvPr id="2" name="Slide Image Placeholder 1"/>
+          <p:cNvSpPr>
+            <a:spLocks noGrp="1"/>
+          </p:cNvSpPr>
+          <p:nvPr>
+            <p:ph type="sldImg" idx="3"/>
+          </p:nvPr>
+        </p:nvSpPr>
+        <p:spPr/>
+      </p:sp>
+      <p:sp>
+        <p:nvSpPr>
+          <p:cNvPr id="3" name="Notes Placeholder 2"/>
+          <p:cNvSpPr>
+            <a:spLocks noGrp="1"/>
+          </p:cNvSpPr>
+          <p:nvPr>
+            <p:ph type="body" idx="1"/>
+          </p:nvPr>
+        </p:nvSpPr>
+        <p:spPr/>
+        <p:txBody>
+          <a:bodyPr/>
+          <a:lstStyle/>
+          <a:p>
+            <a:r>
+              <a:t>Results, ~45 s. The paper's exact in-sample method on every two-year window, starting each January and July: 31 windows of IVE, 10 of BTC. Every window is shown; none was selected. This analysis was run once as an exploration before we wrote the pre-registration, and we say so. Not a power problem: the reproduction can detect any correlation of 0.13 or more with 80% power. Source: results/extensions/windows/.</a:t>
+            </a:r>
+          </a:p>
+        </p:txBody>
+      </p:sp>
+      <p:sp>
+        <p:nvSpPr>
+          <p:cNvPr id="4" name="Slide Number Placeholder 3"/>
+          <p:cNvSpPr>
+            <a:spLocks noGrp="1"/>
+          </p:cNvSpPr>
+          <p:nvPr>
+            <p:ph type="sldNum" idx="12"/>
+          </p:nvPr>
+        </p:nvSpPr>
+        <p:spPr/>
+      </p:sp>
+    </p:spTree>
+  </p:cSld>
+  <p:clrMapOvr>
+    <a:masterClrMapping/>
+  </p:clrMapOvr>
+</p:notes>
+</file>
+
+<file path=ppt/notesSlides/notesSlide21.xml><?xml version="1.0" encoding="utf-8"?>
+<p:notes xmlns:a="http://schemas.openxmlformats.org/drawingml/2006/main" xmlns:p="http://schemas.openxmlformats.org/presentationml/2006/main" xmlns:r="http://schemas.openxmlformats.org/officeDocument/2006/relationships">
+  <p:cSld>
+    <p:spTree>
+      <p:nvGrpSpPr>
+        <p:cNvPr id="1" name=""/>
+        <p:cNvGrpSpPr/>
+        <p:nvPr/>
+      </p:nvGrpSpPr>
+      <p:grpSpPr>
+        <a:xfrm>
+          <a:off x="0" y="0"/>
+          <a:ext cx="0" cy="0"/>
+          <a:chOff x="0" y="0"/>
+          <a:chExt cx="0" cy="0"/>
+        </a:xfrm>
+      </p:grpSpPr>
+      <p:sp>
+        <p:nvSpPr>
+          <p:cNvPr id="2" name="Slide Image Placeholder 1"/>
+          <p:cNvSpPr>
+            <a:spLocks noGrp="1"/>
+          </p:cNvSpPr>
+          <p:nvPr>
+            <p:ph type="sldImg" idx="3"/>
+          </p:nvPr>
+        </p:nvSpPr>
+        <p:spPr/>
+      </p:sp>
+      <p:sp>
+        <p:nvSpPr>
+          <p:cNvPr id="3" name="Notes Placeholder 2"/>
+          <p:cNvSpPr>
+            <a:spLocks noGrp="1"/>
+          </p:cNvSpPr>
+          <p:nvPr>
+            <p:ph type="body" idx="1"/>
+          </p:nvPr>
+        </p:nvSpPr>
+        <p:spPr/>
+        <p:txBody>
+          <a:bodyPr/>
+          <a:lstStyle/>
+          <a:p>
+            <a:r>
+              <a:t>Upgrade, ~1 min. The gap: the paper validates VPIN (Appendix A.2) with buys and sells drawn straight from the PIN model: correct labels, no prices. Its empirical VPIN uses bulk classification, which needs prices, so that validation does not cover the method it uses. We simulate the paper's own model with a price and run the exact pipeline where the truth is known. Hypotheses, metrics and decision rules were written in docs/preregistration.md before the first run; its hash is in the run manifest.</a:t>
+            </a:r>
+          </a:p>
+        </p:txBody>
+      </p:sp>
+      <p:sp>
+        <p:nvSpPr>
+          <p:cNvPr id="4" name="Slide Number Placeholder 3"/>
+          <p:cNvSpPr>
+            <a:spLocks noGrp="1"/>
+          </p:cNvSpPr>
+          <p:nvPr>
+            <p:ph type="sldNum" idx="12"/>
+          </p:nvPr>
+        </p:nvSpPr>
+        <p:spPr/>
+      </p:sp>
+    </p:spTree>
+  </p:cSld>
+  <p:clrMapOvr>
+    <a:masterClrMapping/>
+  </p:clrMapOvr>
+</p:notes>
+</file>
+
+<file path=ppt/notesSlides/notesSlide22.xml><?xml version="1.0" encoding="utf-8"?>
+<p:notes xmlns:a="http://schemas.openxmlformats.org/drawingml/2006/main" xmlns:p="http://schemas.openxmlformats.org/presentationml/2006/main" xmlns:r="http://schemas.openxmlformats.org/officeDocument/2006/relationships">
+  <p:cSld>
+    <p:spTree>
+      <p:nvGrpSpPr>
+        <p:cNvPr id="1" name=""/>
+        <p:cNvGrpSpPr/>
+        <p:nvPr/>
+      </p:nvGrpSpPr>
+      <p:grpSpPr>
+        <a:xfrm>
+          <a:off x="0" y="0"/>
+          <a:ext cx="0" cy="0"/>
+          <a:chOff x="0" y="0"/>
+          <a:chExt cx="0" cy="0"/>
+        </a:xfrm>
+      </p:grpSpPr>
+      <p:sp>
+        <p:nvSpPr>
+          <p:cNvPr id="2" name="Slide Image Placeholder 1"/>
+          <p:cNvSpPr>
+            <a:spLocks noGrp="1"/>
+          </p:cNvSpPr>
+          <p:nvPr>
+            <p:ph type="sldImg" idx="3"/>
+          </p:nvPr>
+        </p:nvSpPr>
+        <p:spPr/>
+      </p:sp>
+      <p:sp>
+        <p:nvSpPr>
+          <p:cNvPr id="3" name="Notes Placeholder 2"/>
+          <p:cNvSpPr>
+            <a:spLocks noGrp="1"/>
+          </p:cNvSpPr>
+          <p:nvPr>
+            <p:ph type="body" idx="1"/>
+          </p:nvPr>
+        </p:nvSpPr>
+        <p:spPr/>
+        <p:txBody>
+          <a:bodyPr/>
+          <a:lstStyle/>
+          <a:p>
+            <a:r>
+              <a:t>Upgrade, ~1 min. D2: in world V the paper's VPIN raises more alarms in volatile blocks, although informed trading never changes; true-label VPIN goes the other way (extra uninformed volume dilutes informed trading), the same sign as on real BTC. In world V the paper's VPIN tracks the true informed share at corr ~0.03. D3 did not hold: the paper's predictive statistic is not fooled in this calibration, because two effects cancel. D4: one-day sigma fixes the bias and keeps detection. ± = Monte Carlo s.e. Source: results/extensions/simulation/.</a:t>
+            </a:r>
+          </a:p>
+        </p:txBody>
+      </p:sp>
+      <p:sp>
+        <p:nvSpPr>
+          <p:cNvPr id="4" name="Slide Number Placeholder 3"/>
+          <p:cNvSpPr>
+            <a:spLocks noGrp="1"/>
+          </p:cNvSpPr>
+          <p:nvPr>
+            <p:ph type="sldNum" idx="12"/>
+          </p:nvPr>
+        </p:nvSpPr>
+        <p:spPr/>
+      </p:sp>
+    </p:spTree>
+  </p:cSld>
+  <p:clrMapOvr>
+    <a:masterClrMapping/>
+  </p:clrMapOvr>
+</p:notes>
+</file>
+
+<file path=ppt/notesSlides/notesSlide23.xml><?xml version="1.0" encoding="utf-8"?>
+<p:notes xmlns:a="http://schemas.openxmlformats.org/drawingml/2006/main" xmlns:p="http://schemas.openxmlformats.org/presentationml/2006/main" xmlns:r="http://schemas.openxmlformats.org/officeDocument/2006/relationships">
+  <p:cSld>
+    <p:spTree>
+      <p:nvGrpSpPr>
+        <p:cNvPr id="1" name=""/>
+        <p:cNvGrpSpPr/>
+        <p:nvPr/>
+      </p:nvGrpSpPr>
+      <p:grpSpPr>
+        <a:xfrm>
+          <a:off x="0" y="0"/>
+          <a:ext cx="0" cy="0"/>
+          <a:chOff x="0" y="0"/>
+          <a:chExt cx="0" cy="0"/>
+        </a:xfrm>
+      </p:grpSpPr>
+      <p:sp>
+        <p:nvSpPr>
+          <p:cNvPr id="2" name="Slide Image Placeholder 1"/>
+          <p:cNvSpPr>
+            <a:spLocks noGrp="1"/>
+          </p:cNvSpPr>
+          <p:nvPr>
+            <p:ph type="sldImg" idx="3"/>
+          </p:nvPr>
+        </p:nvSpPr>
+        <p:spPr/>
+      </p:sp>
+      <p:sp>
+        <p:nvSpPr>
+          <p:cNvPr id="3" name="Notes Placeholder 2"/>
+          <p:cNvSpPr>
+            <a:spLocks noGrp="1"/>
+          </p:cNvSpPr>
+          <p:nvPr>
+            <p:ph type="body" idx="1"/>
+          </p:nvPr>
+        </p:nvSpPr>
+        <p:spPr/>
+        <p:txBody>
+          <a:bodyPr/>
+          <a:lstStyle/>
+          <a:p>
+            <a:r>
+              <a:t>Upgrade, ~1 min. Pre-registered rule D5, run because D4 held. Bulk classification with sigma from the previous day only, in the same real-time buckets. On BTC, where the truth is known, it tracks true-label VPIN better. And once the volatility bias is gone, most of VPIN's correlation with future volatility disappears: the paper's predictive power came from the bias. A small signal beyond volatility remains on IVE, none on BTC. Source: results/extensions/local_sigma/.</a:t>
+            </a:r>
+          </a:p>
+        </p:txBody>
+      </p:sp>
+      <p:sp>
+        <p:nvSpPr>
+          <p:cNvPr id="4" name="Slide Number Placeholder 3"/>
+          <p:cNvSpPr>
+            <a:spLocks noGrp="1"/>
+          </p:cNvSpPr>
+          <p:nvPr>
+            <p:ph type="sldNum" idx="12"/>
+          </p:nvPr>
+        </p:nvSpPr>
+        <p:spPr/>
+      </p:sp>
+    </p:spTree>
+  </p:cSld>
+  <p:clrMapOvr>
+    <a:masterClrMapping/>
+  </p:clrMapOvr>
+</p:notes>
+</file>
+
+<file path=ppt/notesSlides/notesSlide24.xml><?xml version="1.0" encoding="utf-8"?>
+<p:notes xmlns:a="http://schemas.openxmlformats.org/drawingml/2006/main" xmlns:p="http://schemas.openxmlformats.org/presentationml/2006/main" xmlns:r="http://schemas.openxmlformats.org/officeDocument/2006/relationships">
+  <p:cSld>
+    <p:spTree>
+      <p:nvGrpSpPr>
+        <p:cNvPr id="1" name=""/>
+        <p:cNvGrpSpPr/>
+        <p:nvPr/>
+      </p:nvGrpSpPr>
+      <p:grpSpPr>
+        <a:xfrm>
+          <a:off x="0" y="0"/>
+          <a:ext cx="0" cy="0"/>
+          <a:chOff x="0" y="0"/>
+          <a:chExt cx="0" cy="0"/>
+        </a:xfrm>
+      </p:grpSpPr>
+      <p:sp>
+        <p:nvSpPr>
+          <p:cNvPr id="2" name="Slide Image Placeholder 1"/>
+          <p:cNvSpPr>
+            <a:spLocks noGrp="1"/>
+          </p:cNvSpPr>
+          <p:nvPr>
+            <p:ph type="sldImg" idx="3"/>
+          </p:nvPr>
+        </p:nvSpPr>
+        <p:spPr/>
+      </p:sp>
+      <p:sp>
+        <p:nvSpPr>
+          <p:cNvPr id="3" name="Notes Placeholder 2"/>
+          <p:cNvSpPr>
+            <a:spLocks noGrp="1"/>
+          </p:cNvSpPr>
+          <p:nvPr>
+            <p:ph type="body" idx="1"/>
+          </p:nvPr>
+        </p:nvSpPr>
+        <p:spPr/>
+        <p:txBody>
+          <a:bodyPr/>
+          <a:lstStyle/>
+          <a:p>
+            <a:r>
+              <a:t>Upgrade, ~1 min. The placebo keeps each one-minute imbalance's size and draws its direction at random. If VPIN's predictive power came from informed traders on one side, the placebo would lose it; it keeps ~100%. On IVE 2011-26 the real VPIN is detectably better by 0.002 — still 97% kept. Ledger: a claim counts as supported only if significant and on the claimed side. Sources: results/extensions/inference/, results/report/ledger.csv, docs/preregistration.md.</a:t>
+            </a:r>
+          </a:p>
+        </p:txBody>
+      </p:sp>
+      <p:sp>
+        <p:nvSpPr>
+          <p:cNvPr id="4" name="Slide Number Placeholder 3"/>
+          <p:cNvSpPr>
+            <a:spLocks noGrp="1"/>
+          </p:cNvSpPr>
+          <p:nvPr>
+            <p:ph type="sldNum" idx="12"/>
+          </p:nvPr>
+        </p:nvSpPr>
+        <p:spPr/>
+      </p:sp>
+    </p:spTree>
+  </p:cSld>
+  <p:clrMapOvr>
+    <a:masterClrMapping/>
+  </p:clrMapOvr>
+</p:notes>
+</file>
+
+<file path=ppt/notesSlides/notesSlide25.xml><?xml version="1.0" encoding="utf-8"?>
+<p:notes xmlns:a="http://schemas.openxmlformats.org/drawingml/2006/main" xmlns:p="http://schemas.openxmlformats.org/presentationml/2006/main" xmlns:r="http://schemas.openxmlformats.org/officeDocument/2006/relationships">
+  <p:cSld>
+    <p:spTree>
+      <p:nvGrpSpPr>
+        <p:cNvPr id="1" name=""/>
+        <p:cNvGrpSpPr/>
+        <p:nvPr/>
+      </p:nvGrpSpPr>
+      <p:grpSpPr>
+        <a:xfrm>
+          <a:off x="0" y="0"/>
+          <a:ext cx="0" cy="0"/>
+          <a:chOff x="0" y="0"/>
+          <a:chExt cx="0" cy="0"/>
+        </a:xfrm>
+      </p:grpSpPr>
+      <p:sp>
+        <p:nvSpPr>
+          <p:cNvPr id="2" name="Slide Image Placeholder 1"/>
+          <p:cNvSpPr>
+            <a:spLocks noGrp="1"/>
+          </p:cNvSpPr>
+          <p:nvPr>
+            <p:ph type="sldImg" idx="3"/>
+          </p:nvPr>
+        </p:nvSpPr>
+        <p:spPr/>
+      </p:sp>
+      <p:sp>
+        <p:nvSpPr>
+          <p:cNvPr id="3" name="Notes Placeholder 2"/>
+          <p:cNvSpPr>
+            <a:spLocks noGrp="1"/>
+          </p:cNvSpPr>
+          <p:nvPr>
+            <p:ph type="body" idx="1"/>
+          </p:nvPr>
+        </p:nvSpPr>
+        <p:spPr/>
+        <p:txBody>
+          <a:bodyPr/>
+          <a:lstStyle/>
+          <a:p>
+            <a:r>
+              <a:t>~1 min. Be explicit about what is new and what confirms others. The ground-truth and volatility critiques confirm Andersen and Bondarenko (2014, 2015; the latter uses perfect trade classification on E-mini) and Chakrabarty, Pascual and Shkilko (2015, bulk vs trade-by-trade classification), on new data. The known-answer simulation that closes the paper's own validation gap, and the one-day-sigma fix tested against ground truth, are our additions, as far as we know.</a:t>
             </a:r>
           </a:p>
         </p:txBody>
@@ -36174,7 +36600,7 @@
           <a:lstStyle/>
           <a:p>
             <a:r>
-              <a:t>Result 4: high VPIN and large moves (Tables 4 and 5)</a:t>
+              <a:t>Backup: high VPIN and large moves (Tables 4 and 5)</a:t>
             </a:r>
           </a:p>
         </p:txBody>
@@ -39595,7 +40021,7 @@
           <a:lstStyle/>
           <a:p>
             <a:r>
-              <a:t>Extension 3: real-time VPIN out of sample, IVE 2011–2026</a:t>
+              <a:t>Backup: real-time VPIN out of sample, year by year</a:t>
             </a:r>
           </a:p>
         </p:txBody>
@@ -39781,7 +40207,7 @@
           <a:lstStyle/>
           <a:p>
             <a:r>
-              <a:t>Extension 4: crashes after the paper</a:t>
+              <a:t>Backup: crashes after the paper</a:t>
             </a:r>
           </a:p>
         </p:txBody>
@@ -42184,7 +42610,7 @@
           <a:lstStyle/>
           <a:p>
             <a:r>
-              <a:t>Repository: how to run it</a:t>
+              <a:t>Backup: repository and how to run it</a:t>
             </a:r>
           </a:p>
         </p:txBody>
@@ -43164,6 +43590,3055 @@
 </file>
 
 <file path=ppt/slides/slide20.xml><?xml version="1.0" encoding="utf-8"?>
+<p:sld xmlns:a="http://schemas.openxmlformats.org/drawingml/2006/main" xmlns:p="http://schemas.openxmlformats.org/presentationml/2006/main" xmlns:r="http://schemas.openxmlformats.org/officeDocument/2006/relationships">
+  <p:cSld>
+    <p:spTree>
+      <p:nvGrpSpPr>
+        <p:cNvPr id="1" name=""/>
+        <p:cNvGrpSpPr/>
+        <p:nvPr/>
+      </p:nvGrpSpPr>
+      <p:grpSpPr/>
+      <p:sp>
+        <p:nvSpPr>
+          <p:cNvPr id="2" name="Title 1"/>
+          <p:cNvSpPr>
+            <a:spLocks noGrp="1"/>
+          </p:cNvSpPr>
+          <p:nvPr>
+            <p:ph type="title"/>
+          </p:nvPr>
+        </p:nvSpPr>
+        <p:spPr/>
+        <p:txBody>
+          <a:bodyPr/>
+          <a:lstStyle/>
+          <a:p>
+            <a:r>
+              <a:t>Result 4: the paper's predictive claims on every two-year window</a:t>
+            </a:r>
+          </a:p>
+        </p:txBody>
+      </p:sp>
+      <p:sp>
+        <p:nvSpPr>
+          <p:cNvPr id="4" name="Text Placeholder 3"/>
+          <p:cNvSpPr>
+            <a:spLocks noGrp="1"/>
+          </p:cNvSpPr>
+          <p:nvPr>
+            <p:ph type="body" idx="2"/>
+          </p:nvPr>
+        </p:nvSpPr>
+        <p:spPr/>
+        <p:txBody>
+          <a:bodyPr/>
+          <a:lstStyle/>
+          <a:p>
+            <a:r>
+              <a:t>Research Seminar</a:t>
+            </a:r>
+          </a:p>
+        </p:txBody>
+      </p:sp>
+      <p:pic>
+        <p:nvPicPr>
+          <p:cNvPr id="5" name="Picture 4" descr="windows.png"/>
+          <p:cNvPicPr>
+            <a:picLocks noChangeAspect="1"/>
+          </p:cNvPicPr>
+          <p:nvPr/>
+        </p:nvPicPr>
+        <p:blipFill>
+          <a:blip r:embed="rId3"/>
+          <a:stretch>
+            <a:fillRect/>
+          </a:stretch>
+        </p:blipFill>
+        <p:spPr>
+          <a:xfrm>
+            <a:off x="365760" y="2266160"/>
+            <a:ext cx="7680960" cy="2462839"/>
+          </a:xfrm>
+          <a:prstGeom prst="rect">
+            <a:avLst/>
+          </a:prstGeom>
+        </p:spPr>
+      </p:pic>
+      <p:sp>
+        <p:nvSpPr>
+          <p:cNvPr id="6" name="TextBox 5"/>
+          <p:cNvSpPr txBox="1"/>
+          <p:nvPr/>
+        </p:nvSpPr>
+        <p:spPr>
+          <a:xfrm>
+            <a:off x="585216" y="4983480"/>
+            <a:ext cx="7498079" cy="1463040"/>
+          </a:xfrm>
+          <a:prstGeom prst="rect">
+            <a:avLst/>
+          </a:prstGeom>
+          <a:noFill/>
+        </p:spPr>
+        <p:txBody>
+          <a:bodyPr wrap="square" anchor="t" lIns="45720" rIns="45720">
+            <a:spAutoFit/>
+          </a:bodyPr>
+          <a:lstStyle/>
+          <a:p>
+            <a:pPr algn="l">
+              <a:spcAft>
+                <a:spcPts val="500"/>
+              </a:spcAft>
+            </a:pPr>
+            <a:r>
+              <a:rPr sz="1300" b="0">
+                <a:solidFill>
+                  <a:srgbClr val="222222"/>
+                </a:solidFill>
+              </a:rPr>
+              <a:t>• IVE: corr 0.00 to 0.24; P(top quartile | big move) 19% to 76%.</a:t>
+            </a:r>
+          </a:p>
+          <a:p>
+            <a:pPr algn="l">
+              <a:spcAft>
+                <a:spcPts val="500"/>
+              </a:spcAft>
+            </a:pPr>
+            <a:r>
+              <a:rPr sz="1300" b="0">
+                <a:solidFill>
+                  <a:srgbClr val="222222"/>
+                </a:solidFill>
+              </a:rPr>
+              <a:t>• BTC: corr 0.01 to 0.16; P(top quartile | big move) 27% to 48%. Big moves are routine on BTC, so low VPIN scores as many true positives.</a:t>
+            </a:r>
+          </a:p>
+        </p:txBody>
+      </p:sp>
+      <p:sp>
+        <p:nvSpPr>
+          <p:cNvPr id="7" name="TextBox 6"/>
+          <p:cNvSpPr txBox="1"/>
+          <p:nvPr/>
+        </p:nvSpPr>
+        <p:spPr>
+          <a:xfrm>
+            <a:off x="8321040" y="2240280"/>
+            <a:ext cx="3657600" cy="1463040"/>
+          </a:xfrm>
+          <a:prstGeom prst="rect">
+            <a:avLst/>
+          </a:prstGeom>
+          <a:noFill/>
+        </p:spPr>
+        <p:txBody>
+          <a:bodyPr wrap="square" anchor="t" lIns="45720" rIns="45720">
+            <a:spAutoFit/>
+          </a:bodyPr>
+          <a:lstStyle/>
+          <a:p>
+            <a:pPr algn="l">
+              <a:spcAft>
+                <a:spcPts val="600"/>
+              </a:spcAft>
+            </a:pPr>
+            <a:r>
+              <a:rPr sz="1400" b="1">
+                <a:solidFill>
+                  <a:srgbClr val="0F2C68"/>
+                </a:solidFill>
+              </a:rPr>
+              <a:t>Paper reports (E-mini, 2008–11)</a:t>
+            </a:r>
+          </a:p>
+          <a:p>
+            <a:pPr algn="l">
+              <a:spcAft>
+                <a:spcPts val="600"/>
+              </a:spcAft>
+            </a:pPr>
+            <a:r>
+              <a:rPr sz="1300" b="0">
+                <a:solidFill>
+                  <a:srgbClr val="222222"/>
+                </a:solidFill>
+              </a:rPr>
+              <a:t>• corr 0.40; P(top quartile | big move) &gt; 84%</a:t>
+            </a:r>
+          </a:p>
+        </p:txBody>
+      </p:sp>
+      <p:sp>
+        <p:nvSpPr>
+          <p:cNvPr id="8" name="TextBox 7"/>
+          <p:cNvSpPr txBox="1"/>
+          <p:nvPr/>
+        </p:nvSpPr>
+        <p:spPr>
+          <a:xfrm>
+            <a:off x="8321040" y="3840480"/>
+            <a:ext cx="3657600" cy="2560320"/>
+          </a:xfrm>
+          <a:prstGeom prst="rect">
+            <a:avLst/>
+          </a:prstGeom>
+          <a:noFill/>
+        </p:spPr>
+        <p:txBody>
+          <a:bodyPr wrap="square" anchor="t" lIns="45720" rIns="45720">
+            <a:spAutoFit/>
+          </a:bodyPr>
+          <a:lstStyle/>
+          <a:p>
+            <a:pPr algn="l">
+              <a:spcAft>
+                <a:spcPts val="600"/>
+              </a:spcAft>
+            </a:pPr>
+            <a:r>
+              <a:rPr sz="1400" b="1">
+                <a:solidFill>
+                  <a:srgbClr val="0F2C68"/>
+                </a:solidFill>
+              </a:rPr>
+              <a:t>Our reading</a:t>
+            </a:r>
+          </a:p>
+          <a:p>
+            <a:pPr algn="l">
+              <a:spcAft>
+                <a:spcPts val="600"/>
+              </a:spcAft>
+            </a:pPr>
+            <a:r>
+              <a:rPr sz="1300" b="0">
+                <a:solidFill>
+                  <a:srgbClr val="222222"/>
+                </a:solidFill>
+              </a:rPr>
+              <a:t>• No window on either market reaches the paper's numbers.</a:t>
+            </a:r>
+          </a:p>
+          <a:p>
+            <a:pPr algn="l">
+              <a:spcAft>
+                <a:spcPts val="600"/>
+              </a:spcAft>
+            </a:pPr>
+            <a:r>
+              <a:rPr sz="1300" b="0">
+                <a:solidFill>
+                  <a:srgbClr val="222222"/>
+                </a:solidFill>
+              </a:rPr>
+              <a:t>• Our reproduction could detect any correlation ≥ 0.13 (80% power): the gap is not a matter of power.</a:t>
+            </a:r>
+          </a:p>
+        </p:txBody>
+      </p:sp>
+    </p:spTree>
+  </p:cSld>
+  <p:clrMapOvr>
+    <a:masterClrMapping/>
+  </p:clrMapOvr>
+</p:sld>
+</file>
+
+<file path=ppt/slides/slide21.xml><?xml version="1.0" encoding="utf-8"?>
+<p:sld xmlns:a="http://schemas.openxmlformats.org/drawingml/2006/main" xmlns:p="http://schemas.openxmlformats.org/presentationml/2006/main" xmlns:r="http://schemas.openxmlformats.org/officeDocument/2006/relationships">
+  <p:cSld>
+    <p:spTree>
+      <p:nvGrpSpPr>
+        <p:cNvPr id="1" name=""/>
+        <p:cNvGrpSpPr/>
+        <p:nvPr/>
+      </p:nvGrpSpPr>
+      <p:grpSpPr/>
+      <p:sp>
+        <p:nvSpPr>
+          <p:cNvPr id="2" name="Title 1"/>
+          <p:cNvSpPr>
+            <a:spLocks noGrp="1"/>
+          </p:cNvSpPr>
+          <p:nvPr>
+            <p:ph type="title"/>
+          </p:nvPr>
+        </p:nvSpPr>
+        <p:spPr/>
+        <p:txBody>
+          <a:bodyPr/>
+          <a:lstStyle/>
+          <a:p>
+            <a:r>
+              <a:t>Extension 3: a known-answer test of VPIN — design (pre-registered)</a:t>
+            </a:r>
+          </a:p>
+        </p:txBody>
+      </p:sp>
+      <p:sp>
+        <p:nvSpPr>
+          <p:cNvPr id="4" name="Text Placeholder 3"/>
+          <p:cNvSpPr>
+            <a:spLocks noGrp="1"/>
+          </p:cNvSpPr>
+          <p:nvPr>
+            <p:ph type="body" idx="2"/>
+          </p:nvPr>
+        </p:nvSpPr>
+        <p:spPr/>
+        <p:txBody>
+          <a:bodyPr/>
+          <a:lstStyle/>
+          <a:p>
+            <a:r>
+              <a:t>Research Seminar</a:t>
+            </a:r>
+          </a:p>
+        </p:txBody>
+      </p:sp>
+      <p:sp>
+        <p:nvSpPr>
+          <p:cNvPr id="5" name="TextBox 4"/>
+          <p:cNvSpPr txBox="1"/>
+          <p:nvPr/>
+        </p:nvSpPr>
+        <p:spPr>
+          <a:xfrm>
+            <a:off x="585216" y="2194560"/>
+            <a:ext cx="5669280" cy="4297680"/>
+          </a:xfrm>
+          <a:prstGeom prst="rect">
+            <a:avLst/>
+          </a:prstGeom>
+          <a:noFill/>
+        </p:spPr>
+        <p:txBody>
+          <a:bodyPr wrap="square" anchor="t" lIns="45720" rIns="45720">
+            <a:spAutoFit/>
+          </a:bodyPr>
+          <a:lstStyle/>
+          <a:p>
+            <a:pPr algn="l">
+              <a:spcAft>
+                <a:spcPts val="800"/>
+              </a:spcAft>
+            </a:pPr>
+            <a:r>
+              <a:rPr sz="1400" b="0">
+                <a:solidFill>
+                  <a:srgbClr val="222222"/>
+                </a:solidFill>
+              </a:rPr>
+              <a:t>• </a:t>
+            </a:r>
+            <a:r>
+              <a:rPr sz="1400" b="1">
+                <a:solidFill>
+                  <a:srgbClr val="222222"/>
+                </a:solidFill>
+              </a:rPr>
+              <a:t>Gap in the paper:</a:t>
+            </a:r>
+            <a:r>
+              <a:rPr sz="1400" b="0">
+                <a:solidFill>
+                  <a:srgbClr val="222222"/>
+                </a:solidFill>
+              </a:rPr>
+              <a:t> its Monte Carlo (Appendix A.2) uses correctly labelled trades and no prices; its VPIN uses bulk classification, which needs prices.</a:t>
+            </a:r>
+          </a:p>
+          <a:p>
+            <a:pPr algn="l">
+              <a:spcAft>
+                <a:spcPts val="800"/>
+              </a:spcAft>
+            </a:pPr>
+            <a:r>
+              <a:rPr sz="1400" b="0">
+                <a:solidFill>
+                  <a:srgbClr val="222222"/>
+                </a:solidFill>
+              </a:rPr>
+              <a:t>• </a:t>
+            </a:r>
+            <a:r>
+              <a:rPr sz="1400" b="1">
+                <a:solidFill>
+                  <a:srgbClr val="222222"/>
+                </a:solidFill>
+              </a:rPr>
+              <a:t>Our model:</a:t>
+            </a:r>
+            <a:r>
+              <a:rPr sz="1400" b="0">
+                <a:solidFill>
+                  <a:srgbClr val="222222"/>
+                </a:solidFill>
+              </a:rPr>
+              <a:t> the paper's PIN model, plus a price: Δp = λ (buys − sells) + public noise. Informed flow moves the price; public noise does not involve any trader.</a:t>
+            </a:r>
+          </a:p>
+          <a:p>
+            <a:pPr algn="l">
+              <a:spcAft>
+                <a:spcPts val="800"/>
+              </a:spcAft>
+            </a:pPr>
+            <a:r>
+              <a:rPr sz="1400" b="0">
+                <a:solidFill>
+                  <a:srgbClr val="222222"/>
+                </a:solidFill>
+              </a:rPr>
+              <a:t>• </a:t>
+            </a:r>
+            <a:r>
+              <a:rPr sz="1400" b="1">
+                <a:solidFill>
+                  <a:srgbClr val="222222"/>
+                </a:solidFill>
+              </a:rPr>
+              <a:t>Worlds:</a:t>
+            </a:r>
+            <a:r>
+              <a:rPr sz="1400" b="0">
+                <a:solidFill>
+                  <a:srgbClr val="222222"/>
+                </a:solidFill>
+              </a:rPr>
+              <a:t> T = more informed trading in some blocks; V = more volatility and uninformed volume, informed trading unchanged; TV = both; 0 = neither.</a:t>
+            </a:r>
+          </a:p>
+          <a:p>
+            <a:pPr algn="l">
+              <a:spcAft>
+                <a:spcPts val="800"/>
+              </a:spcAft>
+            </a:pPr>
+            <a:r>
+              <a:rPr sz="1400" b="0">
+                <a:solidFill>
+                  <a:srgbClr val="222222"/>
+                </a:solidFill>
+              </a:rPr>
+              <a:t>• </a:t>
+            </a:r>
+            <a:r>
+              <a:rPr sz="1400" b="1">
+                <a:solidFill>
+                  <a:srgbClr val="222222"/>
+                </a:solidFill>
+              </a:rPr>
+              <a:t>Same pipeline</a:t>
+            </a:r>
+            <a:r>
+              <a:rPr sz="1400" b="0">
+                <a:solidFill>
+                  <a:srgbClr val="222222"/>
+                </a:solidFill>
+              </a:rPr>
+              <a:t>, truth known, 200 replications per world, rules fixed before running.</a:t>
+            </a:r>
+          </a:p>
+        </p:txBody>
+      </p:sp>
+      <p:pic>
+        <p:nvPicPr>
+          <p:cNvPr id="6" name="Picture 5" descr="example_V.png"/>
+          <p:cNvPicPr>
+            <a:picLocks noChangeAspect="1"/>
+          </p:cNvPicPr>
+          <p:nvPr/>
+        </p:nvPicPr>
+        <p:blipFill>
+          <a:blip r:embed="rId3"/>
+          <a:stretch>
+            <a:fillRect/>
+          </a:stretch>
+        </p:blipFill>
+        <p:spPr>
+          <a:xfrm>
+            <a:off x="6400800" y="2763749"/>
+            <a:ext cx="5577840" cy="2244900"/>
+          </a:xfrm>
+          <a:prstGeom prst="rect">
+            <a:avLst/>
+          </a:prstGeom>
+        </p:spPr>
+      </p:pic>
+      <p:sp>
+        <p:nvSpPr>
+          <p:cNvPr id="7" name="TextBox 6"/>
+          <p:cNvSpPr txBox="1"/>
+          <p:nvPr/>
+        </p:nvSpPr>
+        <p:spPr>
+          <a:xfrm>
+            <a:off x="6400800" y="5577840"/>
+            <a:ext cx="5577840" cy="822960"/>
+          </a:xfrm>
+          <a:prstGeom prst="rect">
+            <a:avLst/>
+          </a:prstGeom>
+          <a:noFill/>
+        </p:spPr>
+        <p:txBody>
+          <a:bodyPr wrap="square" anchor="t" lIns="45720" rIns="45720">
+            <a:spAutoFit/>
+          </a:bodyPr>
+          <a:lstStyle/>
+          <a:p>
+            <a:pPr algn="l">
+              <a:spcAft>
+                <a:spcPts val="600"/>
+              </a:spcAft>
+            </a:pPr>
+            <a:r>
+              <a:rPr sz="1100" b="0">
+                <a:solidFill>
+                  <a:srgbClr val="595959"/>
+                </a:solidFill>
+              </a:rPr>
+              <a:t>World V: the paper's VPIN (blue) stays high in volatile blocks while the true informed share (dashed) falls.</a:t>
+            </a:r>
+          </a:p>
+        </p:txBody>
+      </p:sp>
+    </p:spTree>
+  </p:cSld>
+  <p:clrMapOvr>
+    <a:masterClrMapping/>
+  </p:clrMapOvr>
+</p:sld>
+</file>
+
+<file path=ppt/slides/slide22.xml><?xml version="1.0" encoding="utf-8"?>
+<p:sld xmlns:a="http://schemas.openxmlformats.org/drawingml/2006/main" xmlns:p="http://schemas.openxmlformats.org/presentationml/2006/main" xmlns:r="http://schemas.openxmlformats.org/officeDocument/2006/relationships">
+  <p:cSld>
+    <p:spTree>
+      <p:nvGrpSpPr>
+        <p:cNvPr id="1" name=""/>
+        <p:cNvGrpSpPr/>
+        <p:nvPr/>
+      </p:nvGrpSpPr>
+      <p:grpSpPr/>
+      <p:sp>
+        <p:nvSpPr>
+          <p:cNvPr id="2" name="Title 1"/>
+          <p:cNvSpPr>
+            <a:spLocks noGrp="1"/>
+          </p:cNvSpPr>
+          <p:nvPr>
+            <p:ph type="title"/>
+          </p:nvPr>
+        </p:nvSpPr>
+        <p:spPr/>
+        <p:txBody>
+          <a:bodyPr/>
+          <a:lstStyle/>
+          <a:p>
+            <a:r>
+              <a:t>Extension 3: results of the known-answer test</a:t>
+            </a:r>
+          </a:p>
+        </p:txBody>
+      </p:sp>
+      <p:sp>
+        <p:nvSpPr>
+          <p:cNvPr id="4" name="Text Placeholder 3"/>
+          <p:cNvSpPr>
+            <a:spLocks noGrp="1"/>
+          </p:cNvSpPr>
+          <p:nvPr>
+            <p:ph type="body" idx="2"/>
+          </p:nvPr>
+        </p:nvSpPr>
+        <p:spPr/>
+        <p:txBody>
+          <a:bodyPr/>
+          <a:lstStyle/>
+          <a:p>
+            <a:r>
+              <a:t>Research Seminar</a:t>
+            </a:r>
+          </a:p>
+        </p:txBody>
+      </p:sp>
+      <p:pic>
+        <p:nvPicPr>
+          <p:cNvPr id="5" name="Picture 4" descr="metrics.png"/>
+          <p:cNvPicPr>
+            <a:picLocks noChangeAspect="1"/>
+          </p:cNvPicPr>
+          <p:nvPr/>
+        </p:nvPicPr>
+        <p:blipFill>
+          <a:blip r:embed="rId3"/>
+          <a:stretch>
+            <a:fillRect/>
+          </a:stretch>
+        </p:blipFill>
+        <p:spPr>
+          <a:xfrm>
+            <a:off x="365760" y="2156639"/>
+            <a:ext cx="7680960" cy="2407561"/>
+          </a:xfrm>
+          <a:prstGeom prst="rect">
+            <a:avLst/>
+          </a:prstGeom>
+        </p:spPr>
+      </p:pic>
+      <p:graphicFrame>
+        <p:nvGraphicFramePr>
+          <p:cNvPr id="6" name="Table 5"/>
+          <p:cNvGraphicFramePr>
+            <a:graphicFrameLocks noGrp="1"/>
+          </p:cNvGraphicFramePr>
+          <p:nvPr/>
+        </p:nvGraphicFramePr>
+        <p:xfrm>
+          <a:off x="585216" y="4754880"/>
+          <a:ext cx="7406640" cy="1737360"/>
+        </p:xfrm>
+        <a:graphic>
+          <a:graphicData uri="http://schemas.openxmlformats.org/drawingml/2006/table">
+            <a:tbl>
+              <a:tblPr firstRow="1" bandRow="1">
+                <a:tableStyleId>{5C22544A-7EE6-4342-B048-85BDC9FD1C3A}</a:tableStyleId>
+              </a:tblPr>
+              <a:tblGrid>
+                <a:gridCol w="548640"/>
+                <a:gridCol w="3566160"/>
+                <a:gridCol w="2011680"/>
+                <a:gridCol w="1280160"/>
+              </a:tblGrid>
+              <a:tr h="347472">
+                <a:tc>
+                  <a:txBody>
+                    <a:bodyPr/>
+                    <a:lstStyle/>
+                    <a:p>
+                      <a:r>
+                        <a:rPr sz="1100" b="1">
+                          <a:solidFill>
+                            <a:srgbClr val="FFFFFF"/>
+                          </a:solidFill>
+                        </a:rPr>
+                        <a:t>Rule</a:t>
+                      </a:r>
+                    </a:p>
+                  </a:txBody>
+                  <a:tcPr marL="54864" marR="54864" marT="27432" marB="27432" anchor="ctr">
+                    <a:solidFill>
+                      <a:srgbClr val="0F2C68"/>
+                    </a:solidFill>
+                  </a:tcPr>
+                </a:tc>
+                <a:tc>
+                  <a:txBody>
+                    <a:bodyPr/>
+                    <a:lstStyle/>
+                    <a:p>
+                      <a:r>
+                        <a:rPr sz="1100" b="1">
+                          <a:solidFill>
+                            <a:srgbClr val="FFFFFF"/>
+                          </a:solidFill>
+                        </a:rPr>
+                        <a:t>Pre-registered statement</a:t>
+                      </a:r>
+                    </a:p>
+                  </a:txBody>
+                  <a:tcPr marL="54864" marR="54864" marT="27432" marB="27432" anchor="ctr">
+                    <a:solidFill>
+                      <a:srgbClr val="0F2C68"/>
+                    </a:solidFill>
+                  </a:tcPr>
+                </a:tc>
+                <a:tc>
+                  <a:txBody>
+                    <a:bodyPr/>
+                    <a:lstStyle/>
+                    <a:p>
+                      <a:r>
+                        <a:rPr sz="1100" b="1">
+                          <a:solidFill>
+                            <a:srgbClr val="FFFFFF"/>
+                          </a:solidFill>
+                        </a:rPr>
+                        <a:t>Result</a:t>
+                      </a:r>
+                    </a:p>
+                  </a:txBody>
+                  <a:tcPr marL="54864" marR="54864" marT="27432" marB="27432" anchor="ctr">
+                    <a:solidFill>
+                      <a:srgbClr val="0F2C68"/>
+                    </a:solidFill>
+                  </a:tcPr>
+                </a:tc>
+                <a:tc>
+                  <a:txBody>
+                    <a:bodyPr/>
+                    <a:lstStyle/>
+                    <a:p>
+                      <a:r>
+                        <a:rPr sz="1100" b="1">
+                          <a:solidFill>
+                            <a:srgbClr val="FFFFFF"/>
+                          </a:solidFill>
+                        </a:rPr>
+                        <a:t>Verdict</a:t>
+                      </a:r>
+                    </a:p>
+                  </a:txBody>
+                  <a:tcPr marL="54864" marR="54864" marT="27432" marB="27432" anchor="ctr">
+                    <a:solidFill>
+                      <a:srgbClr val="0F2C68"/>
+                    </a:solidFill>
+                  </a:tcPr>
+                </a:tc>
+              </a:tr>
+              <a:tr h="347472">
+                <a:tc>
+                  <a:txBody>
+                    <a:bodyPr/>
+                    <a:lstStyle/>
+                    <a:p>
+                      <a:r>
+                        <a:rPr sz="1100" b="0">
+                          <a:solidFill>
+                            <a:srgbClr val="222222"/>
+                          </a:solidFill>
+                        </a:rPr>
+                        <a:t>D1</a:t>
+                      </a:r>
+                    </a:p>
+                  </a:txBody>
+                  <a:tcPr marL="54864" marR="54864" marT="27432" marB="27432" anchor="ctr">
+                    <a:solidFill>
+                      <a:srgbClr val="FFFFFF"/>
+                    </a:solidFill>
+                  </a:tcPr>
+                </a:tc>
+                <a:tc>
+                  <a:txBody>
+                    <a:bodyPr/>
+                    <a:lstStyle/>
+                    <a:p>
+                      <a:r>
+                        <a:rPr sz="1100" b="0">
+                          <a:solidFill>
+                            <a:srgbClr val="222222"/>
+                          </a:solidFill>
+                        </a:rPr>
+                        <a:t>true labels track informed trading</a:t>
+                      </a:r>
+                    </a:p>
+                  </a:txBody>
+                  <a:tcPr marL="54864" marR="54864" marT="27432" marB="27432" anchor="ctr">
+                    <a:solidFill>
+                      <a:srgbClr val="FFFFFF"/>
+                    </a:solidFill>
+                  </a:tcPr>
+                </a:tc>
+                <a:tc>
+                  <a:txBody>
+                    <a:bodyPr/>
+                    <a:lstStyle/>
+                    <a:p>
+                      <a:r>
+                        <a:rPr sz="1100" b="0">
+                          <a:solidFill>
+                            <a:srgbClr val="222222"/>
+                          </a:solidFill>
+                        </a:rPr>
+                        <a:t>0.98</a:t>
+                      </a:r>
+                    </a:p>
+                  </a:txBody>
+                  <a:tcPr marL="54864" marR="54864" marT="27432" marB="27432" anchor="ctr">
+                    <a:solidFill>
+                      <a:srgbClr val="FFFFFF"/>
+                    </a:solidFill>
+                  </a:tcPr>
+                </a:tc>
+                <a:tc>
+                  <a:txBody>
+                    <a:bodyPr/>
+                    <a:lstStyle/>
+                    <a:p>
+                      <a:r>
+                        <a:rPr sz="1100" b="1">
+                          <a:solidFill>
+                            <a:srgbClr val="FFFFFF"/>
+                          </a:solidFill>
+                        </a:rPr>
+                        <a:t>holds</a:t>
+                      </a:r>
+                    </a:p>
+                  </a:txBody>
+                  <a:tcPr marL="54864" marR="54864" marT="27432" marB="27432" anchor="ctr">
+                    <a:solidFill>
+                      <a:srgbClr val="009B64"/>
+                    </a:solidFill>
+                  </a:tcPr>
+                </a:tc>
+              </a:tr>
+              <a:tr h="347472">
+                <a:tc>
+                  <a:txBody>
+                    <a:bodyPr/>
+                    <a:lstStyle/>
+                    <a:p>
+                      <a:r>
+                        <a:rPr sz="1100" b="0">
+                          <a:solidFill>
+                            <a:srgbClr val="222222"/>
+                          </a:solidFill>
+                        </a:rPr>
+                        <a:t>D2</a:t>
+                      </a:r>
+                    </a:p>
+                  </a:txBody>
+                  <a:tcPr marL="54864" marR="54864" marT="27432" marB="27432" anchor="ctr">
+                    <a:solidFill>
+                      <a:srgbClr val="EEF2F8"/>
+                    </a:solidFill>
+                  </a:tcPr>
+                </a:tc>
+                <a:tc>
+                  <a:txBody>
+                    <a:bodyPr/>
+                    <a:lstStyle/>
+                    <a:p>
+                      <a:r>
+                        <a:rPr sz="1100" b="0">
+                          <a:solidFill>
+                            <a:srgbClr val="222222"/>
+                          </a:solidFill>
+                        </a:rPr>
+                        <a:t>paper's VPIN: false alarms from volatility</a:t>
+                      </a:r>
+                    </a:p>
+                  </a:txBody>
+                  <a:tcPr marL="54864" marR="54864" marT="27432" marB="27432" anchor="ctr">
+                    <a:solidFill>
+                      <a:srgbClr val="EEF2F8"/>
+                    </a:solidFill>
+                  </a:tcPr>
+                </a:tc>
+                <a:tc>
+                  <a:txBody>
+                    <a:bodyPr/>
+                    <a:lstStyle/>
+                    <a:p>
+                      <a:r>
+                        <a:rPr sz="1100" b="0">
+                          <a:solidFill>
+                            <a:srgbClr val="222222"/>
+                          </a:solidFill>
+                        </a:rPr>
+                        <a:t>+0.118 ± 0.002</a:t>
+                      </a:r>
+                    </a:p>
+                  </a:txBody>
+                  <a:tcPr marL="54864" marR="54864" marT="27432" marB="27432" anchor="ctr">
+                    <a:solidFill>
+                      <a:srgbClr val="EEF2F8"/>
+                    </a:solidFill>
+                  </a:tcPr>
+                </a:tc>
+                <a:tc>
+                  <a:txBody>
+                    <a:bodyPr/>
+                    <a:lstStyle/>
+                    <a:p>
+                      <a:r>
+                        <a:rPr sz="1100" b="1">
+                          <a:solidFill>
+                            <a:srgbClr val="FFFFFF"/>
+                          </a:solidFill>
+                        </a:rPr>
+                        <a:t>holds</a:t>
+                      </a:r>
+                    </a:p>
+                  </a:txBody>
+                  <a:tcPr marL="54864" marR="54864" marT="27432" marB="27432" anchor="ctr">
+                    <a:solidFill>
+                      <a:srgbClr val="009B64"/>
+                    </a:solidFill>
+                  </a:tcPr>
+                </a:tc>
+              </a:tr>
+              <a:tr h="347472">
+                <a:tc>
+                  <a:txBody>
+                    <a:bodyPr/>
+                    <a:lstStyle/>
+                    <a:p>
+                      <a:r>
+                        <a:rPr sz="1100" b="0">
+                          <a:solidFill>
+                            <a:srgbClr val="222222"/>
+                          </a:solidFill>
+                        </a:rPr>
+                        <a:t>D3</a:t>
+                      </a:r>
+                    </a:p>
+                  </a:txBody>
+                  <a:tcPr marL="54864" marR="54864" marT="27432" marB="27432" anchor="ctr">
+                    <a:solidFill>
+                      <a:srgbClr val="FFFFFF"/>
+                    </a:solidFill>
+                  </a:tcPr>
+                </a:tc>
+                <a:tc>
+                  <a:txBody>
+                    <a:bodyPr/>
+                    <a:lstStyle/>
+                    <a:p>
+                      <a:r>
+                        <a:rPr sz="1100" b="0">
+                          <a:solidFill>
+                            <a:srgbClr val="222222"/>
+                          </a:solidFill>
+                        </a:rPr>
+                        <a:t>paper's predictive test fooled by volatility</a:t>
+                      </a:r>
+                    </a:p>
+                  </a:txBody>
+                  <a:tcPr marL="54864" marR="54864" marT="27432" marB="27432" anchor="ctr">
+                    <a:solidFill>
+                      <a:srgbClr val="FFFFFF"/>
+                    </a:solidFill>
+                  </a:tcPr>
+                </a:tc>
+                <a:tc>
+                  <a:txBody>
+                    <a:bodyPr/>
+                    <a:lstStyle/>
+                    <a:p>
+                      <a:r>
+                        <a:rPr sz="1100" b="0">
+                          <a:solidFill>
+                            <a:srgbClr val="222222"/>
+                          </a:solidFill>
+                        </a:rPr>
+                        <a:t>-0.007 ± 0.001</a:t>
+                      </a:r>
+                    </a:p>
+                  </a:txBody>
+                  <a:tcPr marL="54864" marR="54864" marT="27432" marB="27432" anchor="ctr">
+                    <a:solidFill>
+                      <a:srgbClr val="FFFFFF"/>
+                    </a:solidFill>
+                  </a:tcPr>
+                </a:tc>
+                <a:tc>
+                  <a:txBody>
+                    <a:bodyPr/>
+                    <a:lstStyle/>
+                    <a:p>
+                      <a:r>
+                        <a:rPr sz="1100" b="1">
+                          <a:solidFill>
+                            <a:srgbClr val="FFFFFF"/>
+                          </a:solidFill>
+                        </a:rPr>
+                        <a:t>does not hold</a:t>
+                      </a:r>
+                    </a:p>
+                  </a:txBody>
+                  <a:tcPr marL="54864" marR="54864" marT="27432" marB="27432" anchor="ctr">
+                    <a:solidFill>
+                      <a:srgbClr val="595959"/>
+                    </a:solidFill>
+                  </a:tcPr>
+                </a:tc>
+              </a:tr>
+              <a:tr h="347472">
+                <a:tc>
+                  <a:txBody>
+                    <a:bodyPr/>
+                    <a:lstStyle/>
+                    <a:p>
+                      <a:r>
+                        <a:rPr sz="1100" b="0">
+                          <a:solidFill>
+                            <a:srgbClr val="222222"/>
+                          </a:solidFill>
+                        </a:rPr>
+                        <a:t>D4</a:t>
+                      </a:r>
+                    </a:p>
+                  </a:txBody>
+                  <a:tcPr marL="54864" marR="54864" marT="27432" marB="27432" anchor="ctr">
+                    <a:solidFill>
+                      <a:srgbClr val="EEF2F8"/>
+                    </a:solidFill>
+                  </a:tcPr>
+                </a:tc>
+                <a:tc>
+                  <a:txBody>
+                    <a:bodyPr/>
+                    <a:lstStyle/>
+                    <a:p>
+                      <a:r>
+                        <a:rPr sz="1100" b="0">
+                          <a:solidFill>
+                            <a:srgbClr val="222222"/>
+                          </a:solidFill>
+                        </a:rPr>
+                        <a:t>one-day σ: fewer false alarms, same detection</a:t>
+                      </a:r>
+                    </a:p>
+                  </a:txBody>
+                  <a:tcPr marL="54864" marR="54864" marT="27432" marB="27432" anchor="ctr">
+                    <a:solidFill>
+                      <a:srgbClr val="EEF2F8"/>
+                    </a:solidFill>
+                  </a:tcPr>
+                </a:tc>
+                <a:tc>
+                  <a:txBody>
+                    <a:bodyPr/>
+                    <a:lstStyle/>
+                    <a:p>
+                      <a:r>
+                        <a:rPr sz="1100" b="0">
+                          <a:solidFill>
+                            <a:srgbClr val="222222"/>
+                          </a:solidFill>
+                        </a:rPr>
+                        <a:t>-0.301; AUC 0.992</a:t>
+                      </a:r>
+                    </a:p>
+                  </a:txBody>
+                  <a:tcPr marL="54864" marR="54864" marT="27432" marB="27432" anchor="ctr">
+                    <a:solidFill>
+                      <a:srgbClr val="EEF2F8"/>
+                    </a:solidFill>
+                  </a:tcPr>
+                </a:tc>
+                <a:tc>
+                  <a:txBody>
+                    <a:bodyPr/>
+                    <a:lstStyle/>
+                    <a:p>
+                      <a:r>
+                        <a:rPr sz="1100" b="1">
+                          <a:solidFill>
+                            <a:srgbClr val="FFFFFF"/>
+                          </a:solidFill>
+                        </a:rPr>
+                        <a:t>holds</a:t>
+                      </a:r>
+                    </a:p>
+                  </a:txBody>
+                  <a:tcPr marL="54864" marR="54864" marT="27432" marB="27432" anchor="ctr">
+                    <a:solidFill>
+                      <a:srgbClr val="009B64"/>
+                    </a:solidFill>
+                  </a:tcPr>
+                </a:tc>
+              </a:tr>
+            </a:tbl>
+          </a:graphicData>
+        </a:graphic>
+      </p:graphicFrame>
+      <p:sp>
+        <p:nvSpPr>
+          <p:cNvPr id="7" name="TextBox 6"/>
+          <p:cNvSpPr txBox="1"/>
+          <p:nvPr/>
+        </p:nvSpPr>
+        <p:spPr>
+          <a:xfrm>
+            <a:off x="8321040" y="2194560"/>
+            <a:ext cx="3657600" cy="4206240"/>
+          </a:xfrm>
+          <a:prstGeom prst="rect">
+            <a:avLst/>
+          </a:prstGeom>
+          <a:noFill/>
+        </p:spPr>
+        <p:txBody>
+          <a:bodyPr wrap="square" anchor="t" lIns="45720" rIns="45720">
+            <a:spAutoFit/>
+          </a:bodyPr>
+          <a:lstStyle/>
+          <a:p>
+            <a:pPr algn="l">
+              <a:spcAft>
+                <a:spcPts val="400"/>
+              </a:spcAft>
+            </a:pPr>
+            <a:r>
+              <a:rPr sz="1400" b="1">
+                <a:solidFill>
+                  <a:srgbClr val="0F2C68"/>
+                </a:solidFill>
+              </a:rPr>
+              <a:t>Tracking of the true informed share, world V</a:t>
+            </a:r>
+          </a:p>
+          <a:p>
+            <a:pPr algn="l">
+              <a:spcAft>
+                <a:spcPts val="400"/>
+              </a:spcAft>
+            </a:pPr>
+            <a:r>
+              <a:rPr sz="1400" b="0">
+                <a:solidFill>
+                  <a:srgbClr val="222222"/>
+                </a:solidFill>
+              </a:rPr>
+              <a:t>• paper's VPIN </a:t>
+            </a:r>
+            <a:r>
+              <a:rPr sz="1400" b="1">
+                <a:solidFill>
+                  <a:srgbClr val="222222"/>
+                </a:solidFill>
+              </a:rPr>
+              <a:t>0.03</a:t>
+            </a:r>
+          </a:p>
+          <a:p>
+            <a:pPr algn="l">
+              <a:spcAft>
+                <a:spcPts val="400"/>
+              </a:spcAft>
+            </a:pPr>
+            <a:r>
+              <a:rPr sz="1400" b="0">
+                <a:solidFill>
+                  <a:srgbClr val="222222"/>
+                </a:solidFill>
+              </a:rPr>
+              <a:t>• true labels </a:t>
+            </a:r>
+            <a:r>
+              <a:rPr sz="1400" b="1">
+                <a:solidFill>
+                  <a:srgbClr val="222222"/>
+                </a:solidFill>
+              </a:rPr>
+              <a:t>0.96</a:t>
+            </a:r>
+          </a:p>
+          <a:p>
+            <a:pPr algn="l">
+              <a:spcAft>
+                <a:spcPts val="1200"/>
+              </a:spcAft>
+            </a:pPr>
+            <a:r>
+              <a:rPr sz="1400" b="0">
+                <a:solidFill>
+                  <a:srgbClr val="222222"/>
+                </a:solidFill>
+              </a:rPr>
+              <a:t>• one-day σ (fix) </a:t>
+            </a:r>
+            <a:r>
+              <a:rPr sz="1400" b="1">
+                <a:solidFill>
+                  <a:srgbClr val="222222"/>
+                </a:solidFill>
+              </a:rPr>
+              <a:t>0.83</a:t>
+            </a:r>
+          </a:p>
+          <a:p>
+            <a:pPr algn="l">
+              <a:spcAft>
+                <a:spcPts val="400"/>
+              </a:spcAft>
+            </a:pPr>
+            <a:r>
+              <a:rPr sz="1300" b="1">
+                <a:solidFill>
+                  <a:srgbClr val="0F2C68"/>
+                </a:solidFill>
+              </a:rPr>
+              <a:t>• When volatility changes, the paper's VPIN stops measuring informed trading.</a:t>
+            </a:r>
+          </a:p>
+        </p:txBody>
+      </p:sp>
+    </p:spTree>
+  </p:cSld>
+  <p:clrMapOvr>
+    <a:masterClrMapping/>
+  </p:clrMapOvr>
+</p:sld>
+</file>
+
+<file path=ppt/slides/slide23.xml><?xml version="1.0" encoding="utf-8"?>
+<p:sld xmlns:a="http://schemas.openxmlformats.org/drawingml/2006/main" xmlns:p="http://schemas.openxmlformats.org/presentationml/2006/main" xmlns:r="http://schemas.openxmlformats.org/officeDocument/2006/relationships">
+  <p:cSld>
+    <p:spTree>
+      <p:nvGrpSpPr>
+        <p:cNvPr id="1" name=""/>
+        <p:cNvGrpSpPr/>
+        <p:nvPr/>
+      </p:nvGrpSpPr>
+      <p:grpSpPr/>
+      <p:sp>
+        <p:nvSpPr>
+          <p:cNvPr id="2" name="Title 1"/>
+          <p:cNvSpPr>
+            <a:spLocks noGrp="1"/>
+          </p:cNvSpPr>
+          <p:nvPr>
+            <p:ph type="title"/>
+          </p:nvPr>
+        </p:nvSpPr>
+        <p:spPr/>
+        <p:txBody>
+          <a:bodyPr/>
+          <a:lstStyle/>
+          <a:p>
+            <a:r>
+              <a:t>Extension 4: the fix on real data</a:t>
+            </a:r>
+          </a:p>
+        </p:txBody>
+      </p:sp>
+      <p:sp>
+        <p:nvSpPr>
+          <p:cNvPr id="4" name="Text Placeholder 3"/>
+          <p:cNvSpPr>
+            <a:spLocks noGrp="1"/>
+          </p:cNvSpPr>
+          <p:nvPr>
+            <p:ph type="body" idx="2"/>
+          </p:nvPr>
+        </p:nvSpPr>
+        <p:spPr/>
+        <p:txBody>
+          <a:bodyPr/>
+          <a:lstStyle/>
+          <a:p>
+            <a:r>
+              <a:t>Research Seminar</a:t>
+            </a:r>
+          </a:p>
+        </p:txBody>
+      </p:sp>
+      <p:graphicFrame>
+        <p:nvGraphicFramePr>
+          <p:cNvPr id="5" name="Table 4"/>
+          <p:cNvGraphicFramePr>
+            <a:graphicFrameLocks noGrp="1"/>
+          </p:cNvGraphicFramePr>
+          <p:nvPr/>
+        </p:nvGraphicFramePr>
+        <p:xfrm>
+          <a:off x="585216" y="2194560"/>
+          <a:ext cx="7223760" cy="3291840"/>
+        </p:xfrm>
+        <a:graphic>
+          <a:graphicData uri="http://schemas.openxmlformats.org/drawingml/2006/table">
+            <a:tbl>
+              <a:tblPr firstRow="1" bandRow="1">
+                <a:tableStyleId>{5C22544A-7EE6-4342-B048-85BDC9FD1C3A}</a:tableStyleId>
+              </a:tblPr>
+              <a:tblGrid>
+                <a:gridCol w="2103120"/>
+                <a:gridCol w="2651760"/>
+                <a:gridCol w="1463040"/>
+                <a:gridCol w="1005840"/>
+              </a:tblGrid>
+              <a:tr h="411480">
+                <a:tc>
+                  <a:txBody>
+                    <a:bodyPr/>
+                    <a:lstStyle/>
+                    <a:p>
+                      <a:r>
+                        <a:rPr sz="1100" b="1">
+                          <a:solidFill>
+                            <a:srgbClr val="FFFFFF"/>
+                          </a:solidFill>
+                        </a:rPr>
+                        <a:t>Market (real-time, 50 buckets/day)</a:t>
+                      </a:r>
+                    </a:p>
+                  </a:txBody>
+                  <a:tcPr marL="54864" marR="54864" marT="27432" marB="27432" anchor="ctr">
+                    <a:solidFill>
+                      <a:srgbClr val="0F2C68"/>
+                    </a:solidFill>
+                  </a:tcPr>
+                </a:tc>
+                <a:tc>
+                  <a:txBody>
+                    <a:bodyPr/>
+                    <a:lstStyle/>
+                    <a:p>
+                      <a:r>
+                        <a:rPr sz="1100" b="1">
+                          <a:solidFill>
+                            <a:srgbClr val="FFFFFF"/>
+                          </a:solidFill>
+                        </a:rPr>
+                        <a:t>Signal</a:t>
+                      </a:r>
+                    </a:p>
+                  </a:txBody>
+                  <a:tcPr marL="54864" marR="54864" marT="27432" marB="27432" anchor="ctr">
+                    <a:solidFill>
+                      <a:srgbClr val="0F2C68"/>
+                    </a:solidFill>
+                  </a:tcPr>
+                </a:tc>
+                <a:tc>
+                  <a:txBody>
+                    <a:bodyPr/>
+                    <a:lstStyle/>
+                    <a:p>
+                      <a:r>
+                        <a:rPr sz="1100" b="1">
+                          <a:solidFill>
+                            <a:srgbClr val="FFFFFF"/>
+                          </a:solidFill>
+                        </a:rPr>
+                        <a:t>Corr with next |return|</a:t>
+                      </a:r>
+                    </a:p>
+                  </a:txBody>
+                  <a:tcPr marL="54864" marR="54864" marT="27432" marB="27432" anchor="ctr">
+                    <a:solidFill>
+                      <a:srgbClr val="0F2C68"/>
+                    </a:solidFill>
+                  </a:tcPr>
+                </a:tc>
+                <a:tc>
+                  <a:txBody>
+                    <a:bodyPr/>
+                    <a:lstStyle/>
+                    <a:p>
+                      <a:r>
+                        <a:rPr sz="1100" b="1">
+                          <a:solidFill>
+                            <a:srgbClr val="FFFFFF"/>
+                          </a:solidFill>
+                        </a:rPr>
+                        <a:t>Lift</a:t>
+                      </a:r>
+                    </a:p>
+                  </a:txBody>
+                  <a:tcPr marL="54864" marR="54864" marT="27432" marB="27432" anchor="ctr">
+                    <a:solidFill>
+                      <a:srgbClr val="0F2C68"/>
+                    </a:solidFill>
+                  </a:tcPr>
+                </a:tc>
+              </a:tr>
+              <a:tr h="411480">
+                <a:tc>
+                  <a:txBody>
+                    <a:bodyPr/>
+                    <a:lstStyle/>
+                    <a:p>
+                      <a:r>
+                        <a:rPr sz="1100" b="0">
+                          <a:solidFill>
+                            <a:srgbClr val="222222"/>
+                          </a:solidFill>
+                        </a:rPr>
+                        <a:t>BTC</a:t>
+                      </a:r>
+                    </a:p>
+                  </a:txBody>
+                  <a:tcPr marL="54864" marR="54864" marT="27432" marB="27432" anchor="ctr">
+                    <a:solidFill>
+                      <a:srgbClr val="FFFFFF"/>
+                    </a:solidFill>
+                  </a:tcPr>
+                </a:tc>
+                <a:tc>
+                  <a:txBody>
+                    <a:bodyPr/>
+                    <a:lstStyle/>
+                    <a:p>
+                      <a:r>
+                        <a:rPr sz="1100" b="0">
+                          <a:solidFill>
+                            <a:srgbClr val="222222"/>
+                          </a:solidFill>
+                        </a:rPr>
+                        <a:t>VPIN, standard BVC</a:t>
+                      </a:r>
+                    </a:p>
+                  </a:txBody>
+                  <a:tcPr marL="54864" marR="54864" marT="27432" marB="27432" anchor="ctr">
+                    <a:solidFill>
+                      <a:srgbClr val="FFFFFF"/>
+                    </a:solidFill>
+                  </a:tcPr>
+                </a:tc>
+                <a:tc>
+                  <a:txBody>
+                    <a:bodyPr/>
+                    <a:lstStyle/>
+                    <a:p>
+                      <a:r>
+                        <a:rPr sz="1100" b="0">
+                          <a:solidFill>
+                            <a:srgbClr val="222222"/>
+                          </a:solidFill>
+                        </a:rPr>
+                        <a:t>0.127 ± 0.020</a:t>
+                      </a:r>
+                    </a:p>
+                  </a:txBody>
+                  <a:tcPr marL="54864" marR="54864" marT="27432" marB="27432" anchor="ctr">
+                    <a:solidFill>
+                      <a:srgbClr val="FFFFFF"/>
+                    </a:solidFill>
+                  </a:tcPr>
+                </a:tc>
+                <a:tc>
+                  <a:txBody>
+                    <a:bodyPr/>
+                    <a:lstStyle/>
+                    <a:p>
+                      <a:r>
+                        <a:rPr sz="1100" b="0">
+                          <a:solidFill>
+                            <a:srgbClr val="222222"/>
+                          </a:solidFill>
+                        </a:rPr>
+                        <a:t>1.53 ± 0.08</a:t>
+                      </a:r>
+                    </a:p>
+                  </a:txBody>
+                  <a:tcPr marL="54864" marR="54864" marT="27432" marB="27432" anchor="ctr">
+                    <a:solidFill>
+                      <a:srgbClr val="FFFFFF"/>
+                    </a:solidFill>
+                  </a:tcPr>
+                </a:tc>
+              </a:tr>
+              <a:tr h="411480">
+                <a:tc>
+                  <a:txBody>
+                    <a:bodyPr/>
+                    <a:lstStyle/>
+                    <a:p>
+                      <a:r>
+                        <a:rPr sz="1100" b="0">
+                          <a:solidFill>
+                            <a:srgbClr val="222222"/>
+                          </a:solidFill>
+                        </a:rPr>
+                        <a:t>BTC</a:t>
+                      </a:r>
+                    </a:p>
+                  </a:txBody>
+                  <a:tcPr marL="54864" marR="54864" marT="27432" marB="27432" anchor="ctr">
+                    <a:solidFill>
+                      <a:srgbClr val="EEF2F8"/>
+                    </a:solidFill>
+                  </a:tcPr>
+                </a:tc>
+                <a:tc>
+                  <a:txBody>
+                    <a:bodyPr/>
+                    <a:lstStyle/>
+                    <a:p>
+                      <a:r>
+                        <a:rPr sz="1100" b="1">
+                          <a:solidFill>
+                            <a:srgbClr val="FFFFFF"/>
+                          </a:solidFill>
+                        </a:rPr>
+                        <a:t>VPIN, local-sigma BVC (fix)</a:t>
+                      </a:r>
+                    </a:p>
+                  </a:txBody>
+                  <a:tcPr marL="54864" marR="54864" marT="27432" marB="27432" anchor="ctr">
+                    <a:solidFill>
+                      <a:srgbClr val="EB8C3C"/>
+                    </a:solidFill>
+                  </a:tcPr>
+                </a:tc>
+                <a:tc>
+                  <a:txBody>
+                    <a:bodyPr/>
+                    <a:lstStyle/>
+                    <a:p>
+                      <a:r>
+                        <a:rPr sz="1100" b="0">
+                          <a:solidFill>
+                            <a:srgbClr val="222222"/>
+                          </a:solidFill>
+                        </a:rPr>
+                        <a:t>0.051 ± 0.017</a:t>
+                      </a:r>
+                    </a:p>
+                  </a:txBody>
+                  <a:tcPr marL="54864" marR="54864" marT="27432" marB="27432" anchor="ctr">
+                    <a:solidFill>
+                      <a:srgbClr val="EEF2F8"/>
+                    </a:solidFill>
+                  </a:tcPr>
+                </a:tc>
+                <a:tc>
+                  <a:txBody>
+                    <a:bodyPr/>
+                    <a:lstStyle/>
+                    <a:p>
+                      <a:r>
+                        <a:rPr sz="1100" b="0">
+                          <a:solidFill>
+                            <a:srgbClr val="222222"/>
+                          </a:solidFill>
+                        </a:rPr>
+                        <a:t>1.27 ± 0.07</a:t>
+                      </a:r>
+                    </a:p>
+                  </a:txBody>
+                  <a:tcPr marL="54864" marR="54864" marT="27432" marB="27432" anchor="ctr">
+                    <a:solidFill>
+                      <a:srgbClr val="EEF2F8"/>
+                    </a:solidFill>
+                  </a:tcPr>
+                </a:tc>
+              </a:tr>
+              <a:tr h="411480">
+                <a:tc>
+                  <a:txBody>
+                    <a:bodyPr/>
+                    <a:lstStyle/>
+                    <a:p>
+                      <a:r>
+                        <a:rPr sz="1100" b="0">
+                          <a:solidFill>
+                            <a:srgbClr val="222222"/>
+                          </a:solidFill>
+                        </a:rPr>
+                        <a:t>BTC</a:t>
+                      </a:r>
+                    </a:p>
+                  </a:txBody>
+                  <a:tcPr marL="54864" marR="54864" marT="27432" marB="27432" anchor="ctr">
+                    <a:solidFill>
+                      <a:srgbClr val="FFFFFF"/>
+                    </a:solidFill>
+                  </a:tcPr>
+                </a:tc>
+                <a:tc>
+                  <a:txBody>
+                    <a:bodyPr/>
+                    <a:lstStyle/>
+                    <a:p>
+                      <a:r>
+                        <a:rPr sz="1100" b="0">
+                          <a:solidFill>
+                            <a:srgbClr val="222222"/>
+                          </a:solidFill>
+                        </a:rPr>
+                        <a:t>trailing volatility</a:t>
+                      </a:r>
+                    </a:p>
+                  </a:txBody>
+                  <a:tcPr marL="54864" marR="54864" marT="27432" marB="27432" anchor="ctr">
+                    <a:solidFill>
+                      <a:srgbClr val="FFFFFF"/>
+                    </a:solidFill>
+                  </a:tcPr>
+                </a:tc>
+                <a:tc>
+                  <a:txBody>
+                    <a:bodyPr/>
+                    <a:lstStyle/>
+                    <a:p>
+                      <a:r>
+                        <a:rPr sz="1100" b="0">
+                          <a:solidFill>
+                            <a:srgbClr val="222222"/>
+                          </a:solidFill>
+                        </a:rPr>
+                        <a:t>0.359 ± 0.032</a:t>
+                      </a:r>
+                    </a:p>
+                  </a:txBody>
+                  <a:tcPr marL="54864" marR="54864" marT="27432" marB="27432" anchor="ctr">
+                    <a:solidFill>
+                      <a:srgbClr val="FFFFFF"/>
+                    </a:solidFill>
+                  </a:tcPr>
+                </a:tc>
+                <a:tc>
+                  <a:txBody>
+                    <a:bodyPr/>
+                    <a:lstStyle/>
+                    <a:p>
+                      <a:r>
+                        <a:rPr sz="1100" b="0">
+                          <a:solidFill>
+                            <a:srgbClr val="222222"/>
+                          </a:solidFill>
+                        </a:rPr>
+                        <a:t>3.31 ± 0.28</a:t>
+                      </a:r>
+                    </a:p>
+                  </a:txBody>
+                  <a:tcPr marL="54864" marR="54864" marT="27432" marB="27432" anchor="ctr">
+                    <a:solidFill>
+                      <a:srgbClr val="FFFFFF"/>
+                    </a:solidFill>
+                  </a:tcPr>
+                </a:tc>
+              </a:tr>
+              <a:tr h="411480">
+                <a:tc>
+                  <a:txBody>
+                    <a:bodyPr/>
+                    <a:lstStyle/>
+                    <a:p>
+                      <a:r>
+                        <a:rPr sz="1100" b="0">
+                          <a:solidFill>
+                            <a:srgbClr val="222222"/>
+                          </a:solidFill>
+                        </a:rPr>
+                        <a:t>BTC</a:t>
+                      </a:r>
+                    </a:p>
+                  </a:txBody>
+                  <a:tcPr marL="54864" marR="54864" marT="27432" marB="27432" anchor="ctr">
+                    <a:solidFill>
+                      <a:srgbClr val="EEF2F8"/>
+                    </a:solidFill>
+                  </a:tcPr>
+                </a:tc>
+                <a:tc>
+                  <a:txBody>
+                    <a:bodyPr/>
+                    <a:lstStyle/>
+                    <a:p>
+                      <a:r>
+                        <a:rPr sz="1100" b="0">
+                          <a:solidFill>
+                            <a:srgbClr val="222222"/>
+                          </a:solidFill>
+                        </a:rPr>
+                        <a:t>VPIN, true labels</a:t>
+                      </a:r>
+                    </a:p>
+                  </a:txBody>
+                  <a:tcPr marL="54864" marR="54864" marT="27432" marB="27432" anchor="ctr">
+                    <a:solidFill>
+                      <a:srgbClr val="EEF2F8"/>
+                    </a:solidFill>
+                  </a:tcPr>
+                </a:tc>
+                <a:tc>
+                  <a:txBody>
+                    <a:bodyPr/>
+                    <a:lstStyle/>
+                    <a:p>
+                      <a:r>
+                        <a:rPr sz="1100" b="0">
+                          <a:solidFill>
+                            <a:srgbClr val="222222"/>
+                          </a:solidFill>
+                        </a:rPr>
+                        <a:t>-0.123 ± 0.024</a:t>
+                      </a:r>
+                    </a:p>
+                  </a:txBody>
+                  <a:tcPr marL="54864" marR="54864" marT="27432" marB="27432" anchor="ctr">
+                    <a:solidFill>
+                      <a:srgbClr val="EEF2F8"/>
+                    </a:solidFill>
+                  </a:tcPr>
+                </a:tc>
+                <a:tc>
+                  <a:txBody>
+                    <a:bodyPr/>
+                    <a:lstStyle/>
+                    <a:p>
+                      <a:r>
+                        <a:rPr sz="1100" b="0">
+                          <a:solidFill>
+                            <a:srgbClr val="222222"/>
+                          </a:solidFill>
+                        </a:rPr>
+                        <a:t>0.61 ± 0.08</a:t>
+                      </a:r>
+                    </a:p>
+                  </a:txBody>
+                  <a:tcPr marL="54864" marR="54864" marT="27432" marB="27432" anchor="ctr">
+                    <a:solidFill>
+                      <a:srgbClr val="EEF2F8"/>
+                    </a:solidFill>
+                  </a:tcPr>
+                </a:tc>
+              </a:tr>
+              <a:tr h="411480">
+                <a:tc>
+                  <a:txBody>
+                    <a:bodyPr/>
+                    <a:lstStyle/>
+                    <a:p>
+                      <a:r>
+                        <a:rPr sz="1100" b="0">
+                          <a:solidFill>
+                            <a:srgbClr val="222222"/>
+                          </a:solidFill>
+                        </a:rPr>
+                        <a:t>IVE 2011-26</a:t>
+                      </a:r>
+                    </a:p>
+                  </a:txBody>
+                  <a:tcPr marL="54864" marR="54864" marT="27432" marB="27432" anchor="ctr">
+                    <a:solidFill>
+                      <a:srgbClr val="FFFFFF"/>
+                    </a:solidFill>
+                  </a:tcPr>
+                </a:tc>
+                <a:tc>
+                  <a:txBody>
+                    <a:bodyPr/>
+                    <a:lstStyle/>
+                    <a:p>
+                      <a:r>
+                        <a:rPr sz="1100" b="0">
+                          <a:solidFill>
+                            <a:srgbClr val="222222"/>
+                          </a:solidFill>
+                        </a:rPr>
+                        <a:t>VPIN, standard BVC</a:t>
+                      </a:r>
+                    </a:p>
+                  </a:txBody>
+                  <a:tcPr marL="54864" marR="54864" marT="27432" marB="27432" anchor="ctr">
+                    <a:solidFill>
+                      <a:srgbClr val="FFFFFF"/>
+                    </a:solidFill>
+                  </a:tcPr>
+                </a:tc>
+                <a:tc>
+                  <a:txBody>
+                    <a:bodyPr/>
+                    <a:lstStyle/>
+                    <a:p>
+                      <a:r>
+                        <a:rPr sz="1100" b="0">
+                          <a:solidFill>
+                            <a:srgbClr val="222222"/>
+                          </a:solidFill>
+                        </a:rPr>
+                        <a:t>0.092 ± 0.031</a:t>
+                      </a:r>
+                    </a:p>
+                  </a:txBody>
+                  <a:tcPr marL="54864" marR="54864" marT="27432" marB="27432" anchor="ctr">
+                    <a:solidFill>
+                      <a:srgbClr val="FFFFFF"/>
+                    </a:solidFill>
+                  </a:tcPr>
+                </a:tc>
+                <a:tc>
+                  <a:txBody>
+                    <a:bodyPr/>
+                    <a:lstStyle/>
+                    <a:p>
+                      <a:r>
+                        <a:rPr sz="1100" b="0">
+                          <a:solidFill>
+                            <a:srgbClr val="222222"/>
+                          </a:solidFill>
+                        </a:rPr>
+                        <a:t>1.57 ± 0.20</a:t>
+                      </a:r>
+                    </a:p>
+                  </a:txBody>
+                  <a:tcPr marL="54864" marR="54864" marT="27432" marB="27432" anchor="ctr">
+                    <a:solidFill>
+                      <a:srgbClr val="FFFFFF"/>
+                    </a:solidFill>
+                  </a:tcPr>
+                </a:tc>
+              </a:tr>
+              <a:tr h="411480">
+                <a:tc>
+                  <a:txBody>
+                    <a:bodyPr/>
+                    <a:lstStyle/>
+                    <a:p>
+                      <a:r>
+                        <a:rPr sz="1100" b="0">
+                          <a:solidFill>
+                            <a:srgbClr val="222222"/>
+                          </a:solidFill>
+                        </a:rPr>
+                        <a:t>IVE 2011-26</a:t>
+                      </a:r>
+                    </a:p>
+                  </a:txBody>
+                  <a:tcPr marL="54864" marR="54864" marT="27432" marB="27432" anchor="ctr">
+                    <a:solidFill>
+                      <a:srgbClr val="EEF2F8"/>
+                    </a:solidFill>
+                  </a:tcPr>
+                </a:tc>
+                <a:tc>
+                  <a:txBody>
+                    <a:bodyPr/>
+                    <a:lstStyle/>
+                    <a:p>
+                      <a:r>
+                        <a:rPr sz="1100" b="1">
+                          <a:solidFill>
+                            <a:srgbClr val="FFFFFF"/>
+                          </a:solidFill>
+                        </a:rPr>
+                        <a:t>VPIN, local-sigma BVC (fix)</a:t>
+                      </a:r>
+                    </a:p>
+                  </a:txBody>
+                  <a:tcPr marL="54864" marR="54864" marT="27432" marB="27432" anchor="ctr">
+                    <a:solidFill>
+                      <a:srgbClr val="EB8C3C"/>
+                    </a:solidFill>
+                  </a:tcPr>
+                </a:tc>
+                <a:tc>
+                  <a:txBody>
+                    <a:bodyPr/>
+                    <a:lstStyle/>
+                    <a:p>
+                      <a:r>
+                        <a:rPr sz="1100" b="0">
+                          <a:solidFill>
+                            <a:srgbClr val="222222"/>
+                          </a:solidFill>
+                        </a:rPr>
+                        <a:t>0.007 ± 0.023</a:t>
+                      </a:r>
+                    </a:p>
+                  </a:txBody>
+                  <a:tcPr marL="54864" marR="54864" marT="27432" marB="27432" anchor="ctr">
+                    <a:solidFill>
+                      <a:srgbClr val="EEF2F8"/>
+                    </a:solidFill>
+                  </a:tcPr>
+                </a:tc>
+                <a:tc>
+                  <a:txBody>
+                    <a:bodyPr/>
+                    <a:lstStyle/>
+                    <a:p>
+                      <a:r>
+                        <a:rPr sz="1100" b="0">
+                          <a:solidFill>
+                            <a:srgbClr val="222222"/>
+                          </a:solidFill>
+                        </a:rPr>
+                        <a:t>1.30 ± 0.24</a:t>
+                      </a:r>
+                    </a:p>
+                  </a:txBody>
+                  <a:tcPr marL="54864" marR="54864" marT="27432" marB="27432" anchor="ctr">
+                    <a:solidFill>
+                      <a:srgbClr val="EEF2F8"/>
+                    </a:solidFill>
+                  </a:tcPr>
+                </a:tc>
+              </a:tr>
+              <a:tr h="411480">
+                <a:tc>
+                  <a:txBody>
+                    <a:bodyPr/>
+                    <a:lstStyle/>
+                    <a:p>
+                      <a:r>
+                        <a:rPr sz="1100" b="0">
+                          <a:solidFill>
+                            <a:srgbClr val="222222"/>
+                          </a:solidFill>
+                        </a:rPr>
+                        <a:t>IVE 2011-26</a:t>
+                      </a:r>
+                    </a:p>
+                  </a:txBody>
+                  <a:tcPr marL="54864" marR="54864" marT="27432" marB="27432" anchor="ctr">
+                    <a:solidFill>
+                      <a:srgbClr val="FFFFFF"/>
+                    </a:solidFill>
+                  </a:tcPr>
+                </a:tc>
+                <a:tc>
+                  <a:txBody>
+                    <a:bodyPr/>
+                    <a:lstStyle/>
+                    <a:p>
+                      <a:r>
+                        <a:rPr sz="1100" b="0">
+                          <a:solidFill>
+                            <a:srgbClr val="222222"/>
+                          </a:solidFill>
+                        </a:rPr>
+                        <a:t>trailing volatility</a:t>
+                      </a:r>
+                    </a:p>
+                  </a:txBody>
+                  <a:tcPr marL="54864" marR="54864" marT="27432" marB="27432" anchor="ctr">
+                    <a:solidFill>
+                      <a:srgbClr val="FFFFFF"/>
+                    </a:solidFill>
+                  </a:tcPr>
+                </a:tc>
+                <a:tc>
+                  <a:txBody>
+                    <a:bodyPr/>
+                    <a:lstStyle/>
+                    <a:p>
+                      <a:r>
+                        <a:rPr sz="1100" b="0">
+                          <a:solidFill>
+                            <a:srgbClr val="222222"/>
+                          </a:solidFill>
+                        </a:rPr>
+                        <a:t>0.242 ± 0.018</a:t>
+                      </a:r>
+                    </a:p>
+                  </a:txBody>
+                  <a:tcPr marL="54864" marR="54864" marT="27432" marB="27432" anchor="ctr">
+                    <a:solidFill>
+                      <a:srgbClr val="FFFFFF"/>
+                    </a:solidFill>
+                  </a:tcPr>
+                </a:tc>
+                <a:tc>
+                  <a:txBody>
+                    <a:bodyPr/>
+                    <a:lstStyle/>
+                    <a:p>
+                      <a:r>
+                        <a:rPr sz="1100" b="0">
+                          <a:solidFill>
+                            <a:srgbClr val="222222"/>
+                          </a:solidFill>
+                        </a:rPr>
+                        <a:t>2.76 ± 0.28</a:t>
+                      </a:r>
+                    </a:p>
+                  </a:txBody>
+                  <a:tcPr marL="54864" marR="54864" marT="27432" marB="27432" anchor="ctr">
+                    <a:solidFill>
+                      <a:srgbClr val="FFFFFF"/>
+                    </a:solidFill>
+                  </a:tcPr>
+                </a:tc>
+              </a:tr>
+            </a:tbl>
+          </a:graphicData>
+        </a:graphic>
+      </p:graphicFrame>
+      <p:sp>
+        <p:nvSpPr>
+          <p:cNvPr id="6" name="TextBox 5"/>
+          <p:cNvSpPr txBox="1"/>
+          <p:nvPr/>
+        </p:nvSpPr>
+        <p:spPr>
+          <a:xfrm>
+            <a:off x="8046720" y="2194560"/>
+            <a:ext cx="3931920" cy="4297680"/>
+          </a:xfrm>
+          <a:prstGeom prst="rect">
+            <a:avLst/>
+          </a:prstGeom>
+          <a:noFill/>
+        </p:spPr>
+        <p:txBody>
+          <a:bodyPr wrap="square" anchor="t" lIns="45720" rIns="45720">
+            <a:spAutoFit/>
+          </a:bodyPr>
+          <a:lstStyle/>
+          <a:p>
+            <a:pPr algn="l">
+              <a:spcAft>
+                <a:spcPts val="400"/>
+              </a:spcAft>
+            </a:pPr>
+            <a:r>
+              <a:rPr sz="1400" b="1">
+                <a:solidFill>
+                  <a:srgbClr val="0F2C68"/>
+                </a:solidFill>
+              </a:rPr>
+              <a:t>Closer to the truth (BTC)</a:t>
+            </a:r>
+          </a:p>
+          <a:p>
+            <a:pPr algn="l">
+              <a:spcAft>
+                <a:spcPts val="400"/>
+              </a:spcAft>
+            </a:pPr>
+            <a:r>
+              <a:rPr sz="1300" b="0">
+                <a:solidFill>
+                  <a:srgbClr val="222222"/>
+                </a:solidFill>
+              </a:rPr>
+              <a:t>• corr with true-label VPIN: fix </a:t>
+            </a:r>
+            <a:r>
+              <a:rPr sz="1300" b="1">
+                <a:solidFill>
+                  <a:srgbClr val="222222"/>
+                </a:solidFill>
+              </a:rPr>
+              <a:t>0.47</a:t>
+            </a:r>
+            <a:r>
+              <a:rPr sz="1300" b="0">
+                <a:solidFill>
+                  <a:srgbClr val="222222"/>
+                </a:solidFill>
+              </a:rPr>
+              <a:t> vs standard 0.39 (+0.08 ± 0.02)</a:t>
+            </a:r>
+          </a:p>
+          <a:p>
+            <a:pPr algn="l">
+              <a:spcAft>
+                <a:spcPts val="400"/>
+              </a:spcAft>
+            </a:pPr>
+            <a:r>
+              <a:rPr sz="1400" b="1">
+                <a:solidFill>
+                  <a:srgbClr val="0F2C68"/>
+                </a:solidFill>
+              </a:rPr>
+              <a:t>Less volatility in disguise</a:t>
+            </a:r>
+          </a:p>
+          <a:p>
+            <a:pPr algn="l">
+              <a:spcAft>
+                <a:spcPts val="400"/>
+              </a:spcAft>
+            </a:pPr>
+            <a:r>
+              <a:rPr sz="1300" b="0">
+                <a:solidFill>
+                  <a:srgbClr val="222222"/>
+                </a:solidFill>
+              </a:rPr>
+              <a:t>• its correlation with the next move collapses: the paper's predictive power came from the bias</a:t>
+            </a:r>
+          </a:p>
+          <a:p>
+            <a:pPr algn="l">
+              <a:spcAft>
+                <a:spcPts val="400"/>
+              </a:spcAft>
+            </a:pPr>
+            <a:r>
+              <a:rPr sz="1400" b="1">
+                <a:solidFill>
+                  <a:srgbClr val="0F2C68"/>
+                </a:solidFill>
+              </a:rPr>
+              <a:t>What remains beyond volatility</a:t>
+            </a:r>
+          </a:p>
+          <a:p>
+            <a:pPr algn="l">
+              <a:spcAft>
+                <a:spcPts val="400"/>
+              </a:spcAft>
+            </a:pPr>
+            <a:r>
+              <a:rPr sz="1300" b="0">
+                <a:solidFill>
+                  <a:srgbClr val="222222"/>
+                </a:solidFill>
+              </a:rPr>
+              <a:t>• IVE: t = 8.3, ΔR² = 0.0029; BTC: negative (t = -4.3)</a:t>
+            </a:r>
+          </a:p>
+        </p:txBody>
+      </p:sp>
+    </p:spTree>
+  </p:cSld>
+  <p:clrMapOvr>
+    <a:masterClrMapping/>
+  </p:clrMapOvr>
+</p:sld>
+</file>
+
+<file path=ppt/slides/slide24.xml><?xml version="1.0" encoding="utf-8"?>
+<p:sld xmlns:a="http://schemas.openxmlformats.org/drawingml/2006/main" xmlns:p="http://schemas.openxmlformats.org/presentationml/2006/main" xmlns:r="http://schemas.openxmlformats.org/officeDocument/2006/relationships">
+  <p:cSld>
+    <p:spTree>
+      <p:nvGrpSpPr>
+        <p:cNvPr id="1" name=""/>
+        <p:cNvGrpSpPr/>
+        <p:nvPr/>
+      </p:nvGrpSpPr>
+      <p:grpSpPr/>
+      <p:sp>
+        <p:nvSpPr>
+          <p:cNvPr id="2" name="Title 1"/>
+          <p:cNvSpPr>
+            <a:spLocks noGrp="1"/>
+          </p:cNvSpPr>
+          <p:nvPr>
+            <p:ph type="title"/>
+          </p:nvPr>
+        </p:nvSpPr>
+        <p:spPr/>
+        <p:txBody>
+          <a:bodyPr/>
+          <a:lstStyle/>
+          <a:p>
+            <a:r>
+              <a:t>Inference: placebo, stability, power and every test</a:t>
+            </a:r>
+          </a:p>
+        </p:txBody>
+      </p:sp>
+      <p:sp>
+        <p:nvSpPr>
+          <p:cNvPr id="4" name="Text Placeholder 3"/>
+          <p:cNvSpPr>
+            <a:spLocks noGrp="1"/>
+          </p:cNvSpPr>
+          <p:nvPr>
+            <p:ph type="body" idx="2"/>
+          </p:nvPr>
+        </p:nvSpPr>
+        <p:spPr/>
+        <p:txBody>
+          <a:bodyPr/>
+          <a:lstStyle/>
+          <a:p>
+            <a:r>
+              <a:t>Research Seminar</a:t>
+            </a:r>
+          </a:p>
+        </p:txBody>
+      </p:sp>
+      <p:sp>
+        <p:nvSpPr>
+          <p:cNvPr id="5" name="TextBox 4"/>
+          <p:cNvSpPr txBox="1"/>
+          <p:nvPr/>
+        </p:nvSpPr>
+        <p:spPr>
+          <a:xfrm>
+            <a:off x="585216" y="2103120"/>
+            <a:ext cx="7315200" cy="365760"/>
+          </a:xfrm>
+          <a:prstGeom prst="rect">
+            <a:avLst/>
+          </a:prstGeom>
+          <a:noFill/>
+        </p:spPr>
+        <p:txBody>
+          <a:bodyPr wrap="square" anchor="t" lIns="45720" rIns="45720">
+            <a:spAutoFit/>
+          </a:bodyPr>
+          <a:lstStyle/>
+          <a:p>
+            <a:pPr algn="l">
+              <a:spcAft>
+                <a:spcPts val="600"/>
+              </a:spcAft>
+            </a:pPr>
+            <a:r>
+              <a:rPr sz="1400" b="1">
+                <a:solidFill>
+                  <a:srgbClr val="0F2C68"/>
+                </a:solidFill>
+              </a:rPr>
+              <a:t>Placebo: VPIN with the direction of every imbalance shuffled</a:t>
+            </a:r>
+          </a:p>
+        </p:txBody>
+      </p:sp>
+      <p:graphicFrame>
+        <p:nvGraphicFramePr>
+          <p:cNvPr id="6" name="Table 5"/>
+          <p:cNvGraphicFramePr>
+            <a:graphicFrameLocks noGrp="1"/>
+          </p:cNvGraphicFramePr>
+          <p:nvPr/>
+        </p:nvGraphicFramePr>
+        <p:xfrm>
+          <a:off x="585216" y="2514600"/>
+          <a:ext cx="7315200" cy="1463040"/>
+        </p:xfrm>
+        <a:graphic>
+          <a:graphicData uri="http://schemas.openxmlformats.org/drawingml/2006/table">
+            <a:tbl>
+              <a:tblPr firstRow="1" bandRow="1">
+                <a:tableStyleId>{5C22544A-7EE6-4342-B048-85BDC9FD1C3A}</a:tableStyleId>
+              </a:tblPr>
+              <a:tblGrid>
+                <a:gridCol w="3291840"/>
+                <a:gridCol w="1280160"/>
+                <a:gridCol w="1828800"/>
+                <a:gridCol w="914400"/>
+              </a:tblGrid>
+              <a:tr h="365760">
+                <a:tc>
+                  <a:txBody>
+                    <a:bodyPr/>
+                    <a:lstStyle/>
+                    <a:p>
+                      <a:r>
+                        <a:rPr sz="1100" b="1">
+                          <a:solidFill>
+                            <a:srgbClr val="FFFFFF"/>
+                          </a:solidFill>
+                        </a:rPr>
+                        <a:t>Sample</a:t>
+                      </a:r>
+                    </a:p>
+                  </a:txBody>
+                  <a:tcPr marL="54864" marR="54864" marT="27432" marB="27432" anchor="ctr">
+                    <a:solidFill>
+                      <a:srgbClr val="0F2C68"/>
+                    </a:solidFill>
+                  </a:tcPr>
+                </a:tc>
+                <a:tc>
+                  <a:txBody>
+                    <a:bodyPr/>
+                    <a:lstStyle/>
+                    <a:p>
+                      <a:r>
+                        <a:rPr sz="1100" b="1">
+                          <a:solidFill>
+                            <a:srgbClr val="FFFFFF"/>
+                          </a:solidFill>
+                        </a:rPr>
+                        <a:t>Corr, real VPIN</a:t>
+                      </a:r>
+                    </a:p>
+                  </a:txBody>
+                  <a:tcPr marL="54864" marR="54864" marT="27432" marB="27432" anchor="ctr">
+                    <a:solidFill>
+                      <a:srgbClr val="0F2C68"/>
+                    </a:solidFill>
+                  </a:tcPr>
+                </a:tc>
+                <a:tc>
+                  <a:txBody>
+                    <a:bodyPr/>
+                    <a:lstStyle/>
+                    <a:p>
+                      <a:r>
+                        <a:rPr sz="1100" b="1">
+                          <a:solidFill>
+                            <a:srgbClr val="FFFFFF"/>
+                          </a:solidFill>
+                        </a:rPr>
+                        <a:t>Corr, direction shuffled</a:t>
+                      </a:r>
+                    </a:p>
+                  </a:txBody>
+                  <a:tcPr marL="54864" marR="54864" marT="27432" marB="27432" anchor="ctr">
+                    <a:solidFill>
+                      <a:srgbClr val="0F2C68"/>
+                    </a:solidFill>
+                  </a:tcPr>
+                </a:tc>
+                <a:tc>
+                  <a:txBody>
+                    <a:bodyPr/>
+                    <a:lstStyle/>
+                    <a:p>
+                      <a:r>
+                        <a:rPr sz="1100" b="1">
+                          <a:solidFill>
+                            <a:srgbClr val="FFFFFF"/>
+                          </a:solidFill>
+                        </a:rPr>
+                        <a:t>Kept</a:t>
+                      </a:r>
+                    </a:p>
+                  </a:txBody>
+                  <a:tcPr marL="54864" marR="54864" marT="27432" marB="27432" anchor="ctr">
+                    <a:solidFill>
+                      <a:srgbClr val="0F2C68"/>
+                    </a:solidFill>
+                  </a:tcPr>
+                </a:tc>
+              </a:tr>
+              <a:tr h="365760">
+                <a:tc>
+                  <a:txBody>
+                    <a:bodyPr/>
+                    <a:lstStyle/>
+                    <a:p>
+                      <a:r>
+                        <a:rPr sz="1100" b="0">
+                          <a:solidFill>
+                            <a:srgbClr val="222222"/>
+                          </a:solidFill>
+                        </a:rPr>
+                        <a:t>IVE 2009-11, paper's method (50, 250)</a:t>
+                      </a:r>
+                    </a:p>
+                  </a:txBody>
+                  <a:tcPr marL="54864" marR="54864" marT="27432" marB="27432" anchor="ctr">
+                    <a:solidFill>
+                      <a:srgbClr val="FFFFFF"/>
+                    </a:solidFill>
+                  </a:tcPr>
+                </a:tc>
+                <a:tc>
+                  <a:txBody>
+                    <a:bodyPr/>
+                    <a:lstStyle/>
+                    <a:p>
+                      <a:r>
+                        <a:rPr sz="1100" b="0">
+                          <a:solidFill>
+                            <a:srgbClr val="222222"/>
+                          </a:solidFill>
+                        </a:rPr>
+                        <a:t>0.078</a:t>
+                      </a:r>
+                    </a:p>
+                  </a:txBody>
+                  <a:tcPr marL="54864" marR="54864" marT="27432" marB="27432" anchor="ctr">
+                    <a:solidFill>
+                      <a:srgbClr val="FFFFFF"/>
+                    </a:solidFill>
+                  </a:tcPr>
+                </a:tc>
+                <a:tc>
+                  <a:txBody>
+                    <a:bodyPr/>
+                    <a:lstStyle/>
+                    <a:p>
+                      <a:r>
+                        <a:rPr sz="1100" b="0">
+                          <a:solidFill>
+                            <a:srgbClr val="222222"/>
+                          </a:solidFill>
+                        </a:rPr>
+                        <a:t>0.078 ± 0.002</a:t>
+                      </a:r>
+                    </a:p>
+                  </a:txBody>
+                  <a:tcPr marL="54864" marR="54864" marT="27432" marB="27432" anchor="ctr">
+                    <a:solidFill>
+                      <a:srgbClr val="FFFFFF"/>
+                    </a:solidFill>
+                  </a:tcPr>
+                </a:tc>
+                <a:tc>
+                  <a:txBody>
+                    <a:bodyPr/>
+                    <a:lstStyle/>
+                    <a:p>
+                      <a:r>
+                        <a:rPr sz="1100" b="0">
+                          <a:solidFill>
+                            <a:srgbClr val="222222"/>
+                          </a:solidFill>
+                        </a:rPr>
+                        <a:t>101%</a:t>
+                      </a:r>
+                    </a:p>
+                  </a:txBody>
+                  <a:tcPr marL="54864" marR="54864" marT="27432" marB="27432" anchor="ctr">
+                    <a:solidFill>
+                      <a:srgbClr val="FFFFFF"/>
+                    </a:solidFill>
+                  </a:tcPr>
+                </a:tc>
+              </a:tr>
+              <a:tr h="365760">
+                <a:tc>
+                  <a:txBody>
+                    <a:bodyPr/>
+                    <a:lstStyle/>
+                    <a:p>
+                      <a:r>
+                        <a:rPr sz="1100" b="0">
+                          <a:solidFill>
+                            <a:srgbClr val="222222"/>
+                          </a:solidFill>
+                        </a:rPr>
+                        <a:t>IVE 2011-26 (50, 250)</a:t>
+                      </a:r>
+                    </a:p>
+                  </a:txBody>
+                  <a:tcPr marL="54864" marR="54864" marT="27432" marB="27432" anchor="ctr">
+                    <a:solidFill>
+                      <a:srgbClr val="EEF2F8"/>
+                    </a:solidFill>
+                  </a:tcPr>
+                </a:tc>
+                <a:tc>
+                  <a:txBody>
+                    <a:bodyPr/>
+                    <a:lstStyle/>
+                    <a:p>
+                      <a:r>
+                        <a:rPr sz="1100" b="0">
+                          <a:solidFill>
+                            <a:srgbClr val="222222"/>
+                          </a:solidFill>
+                        </a:rPr>
+                        <a:t>0.092</a:t>
+                      </a:r>
+                    </a:p>
+                  </a:txBody>
+                  <a:tcPr marL="54864" marR="54864" marT="27432" marB="27432" anchor="ctr">
+                    <a:solidFill>
+                      <a:srgbClr val="EEF2F8"/>
+                    </a:solidFill>
+                  </a:tcPr>
+                </a:tc>
+                <a:tc>
+                  <a:txBody>
+                    <a:bodyPr/>
+                    <a:lstStyle/>
+                    <a:p>
+                      <a:r>
+                        <a:rPr sz="1100" b="0">
+                          <a:solidFill>
+                            <a:srgbClr val="222222"/>
+                          </a:solidFill>
+                        </a:rPr>
+                        <a:t>0.090 ± 0.001</a:t>
+                      </a:r>
+                    </a:p>
+                  </a:txBody>
+                  <a:tcPr marL="54864" marR="54864" marT="27432" marB="27432" anchor="ctr">
+                    <a:solidFill>
+                      <a:srgbClr val="EEF2F8"/>
+                    </a:solidFill>
+                  </a:tcPr>
+                </a:tc>
+                <a:tc>
+                  <a:txBody>
+                    <a:bodyPr/>
+                    <a:lstStyle/>
+                    <a:p>
+                      <a:r>
+                        <a:rPr sz="1100" b="0">
+                          <a:solidFill>
+                            <a:srgbClr val="222222"/>
+                          </a:solidFill>
+                        </a:rPr>
+                        <a:t>98%</a:t>
+                      </a:r>
+                    </a:p>
+                  </a:txBody>
+                  <a:tcPr marL="54864" marR="54864" marT="27432" marB="27432" anchor="ctr">
+                    <a:solidFill>
+                      <a:srgbClr val="EEF2F8"/>
+                    </a:solidFill>
+                  </a:tcPr>
+                </a:tc>
+              </a:tr>
+              <a:tr h="365760">
+                <a:tc>
+                  <a:txBody>
+                    <a:bodyPr/>
+                    <a:lstStyle/>
+                    <a:p>
+                      <a:r>
+                        <a:rPr sz="1100" b="0">
+                          <a:solidFill>
+                            <a:srgbClr val="222222"/>
+                          </a:solidFill>
+                        </a:rPr>
+                        <a:t>BTC 2020-26 (50, 50)</a:t>
+                      </a:r>
+                    </a:p>
+                  </a:txBody>
+                  <a:tcPr marL="54864" marR="54864" marT="27432" marB="27432" anchor="ctr">
+                    <a:solidFill>
+                      <a:srgbClr val="FFFFFF"/>
+                    </a:solidFill>
+                  </a:tcPr>
+                </a:tc>
+                <a:tc>
+                  <a:txBody>
+                    <a:bodyPr/>
+                    <a:lstStyle/>
+                    <a:p>
+                      <a:r>
+                        <a:rPr sz="1100" b="0">
+                          <a:solidFill>
+                            <a:srgbClr val="222222"/>
+                          </a:solidFill>
+                        </a:rPr>
+                        <a:t>0.127</a:t>
+                      </a:r>
+                    </a:p>
+                  </a:txBody>
+                  <a:tcPr marL="54864" marR="54864" marT="27432" marB="27432" anchor="ctr">
+                    <a:solidFill>
+                      <a:srgbClr val="FFFFFF"/>
+                    </a:solidFill>
+                  </a:tcPr>
+                </a:tc>
+                <a:tc>
+                  <a:txBody>
+                    <a:bodyPr/>
+                    <a:lstStyle/>
+                    <a:p>
+                      <a:r>
+                        <a:rPr sz="1100" b="0">
+                          <a:solidFill>
+                            <a:srgbClr val="222222"/>
+                          </a:solidFill>
+                        </a:rPr>
+                        <a:t>0.128 ± 0.001</a:t>
+                      </a:r>
+                    </a:p>
+                  </a:txBody>
+                  <a:tcPr marL="54864" marR="54864" marT="27432" marB="27432" anchor="ctr">
+                    <a:solidFill>
+                      <a:srgbClr val="FFFFFF"/>
+                    </a:solidFill>
+                  </a:tcPr>
+                </a:tc>
+                <a:tc>
+                  <a:txBody>
+                    <a:bodyPr/>
+                    <a:lstStyle/>
+                    <a:p>
+                      <a:r>
+                        <a:rPr sz="1100" b="0">
+                          <a:solidFill>
+                            <a:srgbClr val="222222"/>
+                          </a:solidFill>
+                        </a:rPr>
+                        <a:t>101%</a:t>
+                      </a:r>
+                    </a:p>
+                  </a:txBody>
+                  <a:tcPr marL="54864" marR="54864" marT="27432" marB="27432" anchor="ctr">
+                    <a:solidFill>
+                      <a:srgbClr val="FFFFFF"/>
+                    </a:solidFill>
+                  </a:tcPr>
+                </a:tc>
+              </a:tr>
+            </a:tbl>
+          </a:graphicData>
+        </a:graphic>
+      </p:graphicFrame>
+      <p:sp>
+        <p:nvSpPr>
+          <p:cNvPr id="7" name="TextBox 6"/>
+          <p:cNvSpPr txBox="1"/>
+          <p:nvPr/>
+        </p:nvSpPr>
+        <p:spPr>
+          <a:xfrm>
+            <a:off x="585216" y="4206240"/>
+            <a:ext cx="7315200" cy="2194560"/>
+          </a:xfrm>
+          <a:prstGeom prst="rect">
+            <a:avLst/>
+          </a:prstGeom>
+          <a:noFill/>
+        </p:spPr>
+        <p:txBody>
+          <a:bodyPr wrap="square" anchor="t" lIns="45720" rIns="45720">
+            <a:spAutoFit/>
+          </a:bodyPr>
+          <a:lstStyle/>
+          <a:p>
+            <a:pPr algn="l">
+              <a:spcAft>
+                <a:spcPts val="600"/>
+              </a:spcAft>
+            </a:pPr>
+            <a:r>
+              <a:rPr sz="1300" b="0">
+                <a:solidFill>
+                  <a:srgbClr val="222222"/>
+                </a:solidFill>
+              </a:rPr>
+              <a:t>• </a:t>
+            </a:r>
+            <a:r>
+              <a:rPr sz="1300" b="1">
+                <a:solidFill>
+                  <a:srgbClr val="222222"/>
+                </a:solidFill>
+              </a:rPr>
+              <a:t>The direction of trading carries almost none of VPIN's predictive power:</a:t>
+            </a:r>
+            <a:r>
+              <a:rPr sz="1300" b="0">
+                <a:solidFill>
+                  <a:srgbClr val="222222"/>
+                </a:solidFill>
+              </a:rPr>
+              <a:t> the size of price moves does.</a:t>
+            </a:r>
+          </a:p>
+          <a:p>
+            <a:pPr algn="l">
+              <a:spcAft>
+                <a:spcPts val="600"/>
+              </a:spcAft>
+            </a:pPr>
+            <a:r>
+              <a:rPr sz="1300" b="0">
+                <a:solidFill>
+                  <a:srgbClr val="222222"/>
+                </a:solidFill>
+              </a:rPr>
+              <a:t>• </a:t>
+            </a:r>
+            <a:r>
+              <a:rPr sz="1300" b="1">
+                <a:solidFill>
+                  <a:srgbClr val="222222"/>
+                </a:solidFill>
+              </a:rPr>
+              <a:t>Leave one year out:</a:t>
+            </a:r>
+            <a:r>
+              <a:rPr sz="1300" b="0">
+                <a:solidFill>
+                  <a:srgbClr val="222222"/>
+                </a:solidFill>
+              </a:rPr>
+              <a:t> 0 sign flips across 5 signal–sample pairs.</a:t>
+            </a:r>
+          </a:p>
+          <a:p>
+            <a:pPr algn="l">
+              <a:spcAft>
+                <a:spcPts val="600"/>
+              </a:spcAft>
+            </a:pPr>
+            <a:r>
+              <a:rPr sz="1300" b="0">
+                <a:solidFill>
+                  <a:srgbClr val="222222"/>
+                </a:solidFill>
+              </a:rPr>
+              <a:t>• </a:t>
+            </a:r>
+            <a:r>
+              <a:rPr sz="1300" b="1">
+                <a:solidFill>
+                  <a:srgbClr val="222222"/>
+                </a:solidFill>
+              </a:rPr>
+              <a:t>Power:</a:t>
+            </a:r>
+            <a:r>
+              <a:rPr sz="1300" b="0">
+                <a:solidFill>
+                  <a:srgbClr val="222222"/>
+                </a:solidFill>
+              </a:rPr>
+              <a:t> the reproduction detects any correlation ≥ 0.13; the paper's 0.40 would not be missed.</a:t>
+            </a:r>
+          </a:p>
+        </p:txBody>
+      </p:sp>
+      <p:sp>
+        <p:nvSpPr>
+          <p:cNvPr id="8" name="TextBox 7"/>
+          <p:cNvSpPr txBox="1"/>
+          <p:nvPr/>
+        </p:nvSpPr>
+        <p:spPr>
+          <a:xfrm>
+            <a:off x="8138160" y="2103120"/>
+            <a:ext cx="3840480" cy="4297680"/>
+          </a:xfrm>
+          <a:prstGeom prst="rect">
+            <a:avLst/>
+          </a:prstGeom>
+          <a:noFill/>
+        </p:spPr>
+        <p:txBody>
+          <a:bodyPr wrap="square" anchor="t" lIns="45720" rIns="45720">
+            <a:spAutoFit/>
+          </a:bodyPr>
+          <a:lstStyle/>
+          <a:p>
+            <a:pPr algn="l">
+              <a:spcAft>
+                <a:spcPts val="500"/>
+              </a:spcAft>
+            </a:pPr>
+            <a:r>
+              <a:rPr sz="1400" b="1">
+                <a:solidFill>
+                  <a:srgbClr val="0F2C68"/>
+                </a:solidFill>
+              </a:rPr>
+              <a:t>Ledger of every test</a:t>
+            </a:r>
+          </a:p>
+          <a:p>
+            <a:pPr algn="l">
+              <a:spcAft>
+                <a:spcPts val="500"/>
+              </a:spcAft>
+            </a:pPr>
+            <a:r>
+              <a:rPr sz="1300" b="0">
+                <a:solidFill>
+                  <a:srgbClr val="222222"/>
+                </a:solidFill>
+              </a:rPr>
+              <a:t>• 26 tests behind our claims</a:t>
+            </a:r>
+          </a:p>
+          <a:p>
+            <a:pPr algn="l">
+              <a:spcAft>
+                <a:spcPts val="500"/>
+              </a:spcAft>
+            </a:pPr>
+            <a:r>
+              <a:rPr sz="1300" b="0">
+                <a:solidFill>
+                  <a:srgbClr val="222222"/>
+                </a:solidFill>
+              </a:rPr>
+              <a:t>• supported after Benjamini–Hochberg: </a:t>
+            </a:r>
+            <a:r>
+              <a:rPr sz="1300" b="1">
+                <a:solidFill>
+                  <a:srgbClr val="222222"/>
+                </a:solidFill>
+              </a:rPr>
+              <a:t>17</a:t>
+            </a:r>
+          </a:p>
+          <a:p>
+            <a:pPr algn="l">
+              <a:spcAft>
+                <a:spcPts val="500"/>
+              </a:spcAft>
+            </a:pPr>
+            <a:r>
+              <a:rPr sz="1300" b="0">
+                <a:solidFill>
+                  <a:srgbClr val="222222"/>
+                </a:solidFill>
+              </a:rPr>
+              <a:t>• after Bonferroni: </a:t>
+            </a:r>
+            <a:r>
+              <a:rPr sz="1300" b="1">
+                <a:solidFill>
+                  <a:srgbClr val="222222"/>
+                </a:solidFill>
+              </a:rPr>
+              <a:t>13</a:t>
+            </a:r>
+          </a:p>
+          <a:p>
+            <a:pPr algn="l">
+              <a:spcAft>
+                <a:spcPts val="500"/>
+              </a:spcAft>
+            </a:pPr>
+            <a:r>
+              <a:rPr sz="1300" b="0">
+                <a:solidFill>
+                  <a:srgbClr val="222222"/>
+                </a:solidFill>
+              </a:rPr>
+              <a:t>• significant but on the wrong side: </a:t>
+            </a:r>
+            <a:r>
+              <a:rPr sz="1300" b="1">
+                <a:solidFill>
+                  <a:srgbClr val="222222"/>
+                </a:solidFill>
+              </a:rPr>
+              <a:t>3</a:t>
+            </a:r>
+            <a:r>
+              <a:rPr sz="1300" b="0">
+                <a:solidFill>
+                  <a:srgbClr val="222222"/>
+                </a:solidFill>
+              </a:rPr>
+              <a:t> (reported as not supported)</a:t>
+            </a:r>
+          </a:p>
+          <a:p>
+            <a:pPr algn="l">
+              <a:spcAft>
+                <a:spcPts val="500"/>
+              </a:spcAft>
+            </a:pPr>
+            <a:r>
+              <a:rPr sz="1200" b="0">
+                <a:solidFill>
+                  <a:srgbClr val="595959"/>
+                </a:solidFill>
+              </a:rPr>
+              <a:t>• New tests pre-registered before running; every later change logged.</a:t>
+            </a:r>
+          </a:p>
+        </p:txBody>
+      </p:sp>
+    </p:spTree>
+  </p:cSld>
+  <p:clrMapOvr>
+    <a:masterClrMapping/>
+  </p:clrMapOvr>
+</p:sld>
+</file>
+
+<file path=ppt/slides/slide25.xml><?xml version="1.0" encoding="utf-8"?>
+<p:sld xmlns:a="http://schemas.openxmlformats.org/drawingml/2006/main" xmlns:p="http://schemas.openxmlformats.org/presentationml/2006/main" xmlns:r="http://schemas.openxmlformats.org/officeDocument/2006/relationships">
+  <p:cSld>
+    <p:spTree>
+      <p:nvGrpSpPr>
+        <p:cNvPr id="1" name=""/>
+        <p:cNvGrpSpPr/>
+        <p:nvPr/>
+      </p:nvGrpSpPr>
+      <p:grpSpPr/>
+      <p:sp>
+        <p:nvSpPr>
+          <p:cNvPr id="2" name="Title 1"/>
+          <p:cNvSpPr>
+            <a:spLocks noGrp="1"/>
+          </p:cNvSpPr>
+          <p:nvPr>
+            <p:ph type="title"/>
+          </p:nvPr>
+        </p:nvSpPr>
+        <p:spPr/>
+        <p:txBody>
+          <a:bodyPr/>
+          <a:lstStyle/>
+          <a:p>
+            <a:r>
+              <a:t>What our work adds to the paper</a:t>
+            </a:r>
+          </a:p>
+        </p:txBody>
+      </p:sp>
+      <p:sp>
+        <p:nvSpPr>
+          <p:cNvPr id="4" name="Text Placeholder 3"/>
+          <p:cNvSpPr>
+            <a:spLocks noGrp="1"/>
+          </p:cNvSpPr>
+          <p:nvPr>
+            <p:ph type="body" idx="2"/>
+          </p:nvPr>
+        </p:nvSpPr>
+        <p:spPr/>
+        <p:txBody>
+          <a:bodyPr/>
+          <a:lstStyle/>
+          <a:p>
+            <a:r>
+              <a:t>Research Seminar</a:t>
+            </a:r>
+          </a:p>
+        </p:txBody>
+      </p:sp>
+      <p:sp>
+        <p:nvSpPr>
+          <p:cNvPr id="5" name="TextBox 4"/>
+          <p:cNvSpPr txBox="1"/>
+          <p:nvPr/>
+        </p:nvSpPr>
+        <p:spPr>
+          <a:xfrm>
+            <a:off x="585216" y="2148840"/>
+            <a:ext cx="11155680" cy="4297680"/>
+          </a:xfrm>
+          <a:prstGeom prst="rect">
+            <a:avLst/>
+          </a:prstGeom>
+          <a:noFill/>
+        </p:spPr>
+        <p:txBody>
+          <a:bodyPr wrap="square" anchor="t" lIns="45720" rIns="45720">
+            <a:spAutoFit/>
+          </a:bodyPr>
+          <a:lstStyle/>
+          <a:p>
+            <a:pPr algn="l">
+              <a:spcAft>
+                <a:spcPts val="1000"/>
+              </a:spcAft>
+            </a:pPr>
+            <a:r>
+              <a:rPr sz="1500" b="0">
+                <a:solidFill>
+                  <a:srgbClr val="222222"/>
+                </a:solidFill>
+              </a:rPr>
+              <a:t>• </a:t>
+            </a:r>
+            <a:r>
+              <a:rPr sz="1500" b="1">
+                <a:solidFill>
+                  <a:srgbClr val="222222"/>
+                </a:solidFill>
+              </a:rPr>
+              <a:t>1. Closes the paper's validation gap.</a:t>
+            </a:r>
+            <a:r>
+              <a:rPr sz="1500" b="0">
+                <a:solidFill>
+                  <a:srgbClr val="222222"/>
+                </a:solidFill>
+              </a:rPr>
+              <a:t> Its Monte Carlo never runs bulk classification. Our known-answer simulation of its own model shows that VPIN, as the paper computes it, stops measuring informed trading when volatility changes.</a:t>
+            </a:r>
+          </a:p>
+          <a:p>
+            <a:pPr algn="l">
+              <a:spcAft>
+                <a:spcPts val="1000"/>
+              </a:spcAft>
+            </a:pPr>
+            <a:r>
+              <a:rPr sz="1500" b="0">
+                <a:solidFill>
+                  <a:srgbClr val="222222"/>
+                </a:solidFill>
+              </a:rPr>
+              <a:t>• </a:t>
+            </a:r>
+            <a:r>
+              <a:rPr sz="1500" b="1">
+                <a:solidFill>
+                  <a:srgbClr val="222222"/>
+                </a:solidFill>
+              </a:rPr>
+              <a:t>2. Locates where VPIN's predictive power comes from.</a:t>
+            </a:r>
+            <a:r>
+              <a:rPr sz="1500" b="0">
+                <a:solidFill>
+                  <a:srgbClr val="222222"/>
+                </a:solidFill>
+              </a:rPr>
+              <a:t> With true labels VPIN does not predict volatility (BTC); with shuffled directions it predicts as well as the real VPIN (IVE, BTC). It is the size of price moves, not toxicity.</a:t>
+            </a:r>
+          </a:p>
+          <a:p>
+            <a:pPr algn="l">
+              <a:spcAft>
+                <a:spcPts val="1000"/>
+              </a:spcAft>
+            </a:pPr>
+            <a:r>
+              <a:rPr sz="1500" b="0">
+                <a:solidFill>
+                  <a:srgbClr val="222222"/>
+                </a:solidFill>
+              </a:rPr>
+              <a:t>• </a:t>
+            </a:r>
+            <a:r>
+              <a:rPr sz="1500" b="1">
+                <a:solidFill>
+                  <a:srgbClr val="222222"/>
+                </a:solidFill>
+              </a:rPr>
+              <a:t>3. A fix that works where it can be checked.</a:t>
+            </a:r>
+            <a:r>
+              <a:rPr sz="1500" b="0">
+                <a:solidFill>
+                  <a:srgbClr val="222222"/>
+                </a:solidFill>
+              </a:rPr>
+              <a:t> Measuring price changes against the previous day's volatility makes VPIN track true toxicity better on BTC, and removes the volatility artefact.</a:t>
+            </a:r>
+          </a:p>
+          <a:p>
+            <a:pPr algn="l">
+              <a:spcAft>
+                <a:spcPts val="1000"/>
+              </a:spcAft>
+            </a:pPr>
+            <a:r>
+              <a:rPr sz="1500" b="0">
+                <a:solidFill>
+                  <a:srgbClr val="222222"/>
+                </a:solidFill>
+              </a:rPr>
+              <a:t>• </a:t>
+            </a:r>
+            <a:r>
+              <a:rPr sz="1500" b="1">
+                <a:solidFill>
+                  <a:srgbClr val="222222"/>
+                </a:solidFill>
+              </a:rPr>
+              <a:t>4. An honest evaluation.</a:t>
+            </a:r>
+            <a:r>
+              <a:rPr sz="1500" b="0">
+                <a:solidFill>
+                  <a:srgbClr val="222222"/>
+                </a:solidFill>
+              </a:rPr>
+              <a:t> Real-time, out of sample 2011–2026, all 41 two-year windows, pre-registration, ± on every metric, and a ledger with multiple-testing control. The paper's predictive numbers do not appear anywhere.</a:t>
+            </a:r>
+          </a:p>
+          <a:p>
+            <a:pPr algn="l">
+              <a:spcAft>
+                <a:spcPts val="1000"/>
+              </a:spcAft>
+            </a:pPr>
+            <a:r>
+              <a:rPr sz="1200" b="0">
+                <a:solidFill>
+                  <a:srgbClr val="595959"/>
+                </a:solidFill>
+              </a:rPr>
+              <a:t>Confirms on new data: Andersen &amp; Bondarenko (2014, 2015); Chakrabarty, Pascual &amp; Shkilko (2015).</a:t>
+            </a:r>
+          </a:p>
+        </p:txBody>
+      </p:sp>
+    </p:spTree>
+  </p:cSld>
+  <p:clrMapOvr>
+    <a:masterClrMapping/>
+  </p:clrMapOvr>
+</p:sld>
+</file>
+
+<file path=ppt/slides/slide26.xml><?xml version="1.0" encoding="utf-8"?>
 <p:sld xmlns:a="http://schemas.openxmlformats.org/drawingml/2006/main" xmlns:p="http://schemas.openxmlformats.org/presentationml/2006/main" xmlns:r="http://schemas.openxmlformats.org/officeDocument/2006/relationships">
   <p:cSld>
     <p:spTree>
@@ -43692,7 +47167,7 @@
           <a:lstStyle/>
           <a:p>
             <a:r>
-              <a:t>Method: the VPIN metric and how it is read</a:t>
+              <a:t>Backup: the VPIN metric and how it is read</a:t>
             </a:r>
           </a:p>
         </p:txBody>

</xml_diff>

<commit_message>
Shorten the talk to 16 slides without dropping content
- Merge "Data" with "What is estimated, chosen and evaluated", the two
  Extension 3 slides into one, and the inference slide into "What our
  work adds".
- Move three detail slides to backup, each summarised on a main slide:
  the volume clock and stability (scorecard rows 1-2), every two-year
  window (Result 2) and the simulation's metric chart (Extension 3).
- BACKUP_ORDER sets the order of the backups; reorder() raises if a
  slide is in neither list.
- The guide reads every slide number from the deck, including one that
  was typed by hand.
</commit_message>
<xml_diff>
--- a/docs/presentation.pptx
+++ b/docs/presentation.pptx
@@ -15,26 +15,24 @@
     <p:sldId id="259" r:id="rId15"/>
     <p:sldId id="261" r:id="rId17"/>
     <p:sldId id="262" r:id="rId18"/>
-    <p:sldId id="263" r:id="rId19"/>
     <p:sldId id="264" r:id="rId20"/>
-    <p:sldId id="265" r:id="rId21"/>
-    <p:sldId id="275" r:id="rId31"/>
+    <p:sldId id="266" r:id="rId22"/>
     <p:sldId id="267" r:id="rId23"/>
     <p:sldId id="268" r:id="rId11"/>
     <p:sldId id="269" r:id="rId10"/>
-    <p:sldId id="270" r:id="rId9"/>
-    <p:sldId id="276" r:id="rId32"/>
+    <p:sldId id="275" r:id="rId31"/>
     <p:sldId id="277" r:id="rId33"/>
     <p:sldId id="278" r:id="rId34"/>
+    <p:sldId id="272" r:id="rId28"/>
     <p:sldId id="279" r:id="rId35"/>
-    <p:sldId id="280" r:id="rId36"/>
+    <p:sldId id="260" r:id="rId16"/>
+    <p:sldId id="263" r:id="rId19"/>
+    <p:sldId id="265" r:id="rId21"/>
+    <p:sldId id="274" r:id="rId30"/>
+    <p:sldId id="270" r:id="rId9"/>
+    <p:sldId id="271" r:id="rId8"/>
+    <p:sldId id="276" r:id="rId32"/>
     <p:sldId id="273" r:id="rId29"/>
-    <p:sldId id="281" r:id="rId37"/>
-    <p:sldId id="260" r:id="rId16"/>
-    <p:sldId id="266" r:id="rId22"/>
-    <p:sldId id="271" r:id="rId8"/>
-    <p:sldId id="272" r:id="rId28"/>
-    <p:sldId id="274" r:id="rId30"/>
   </p:sldIdLst>
   <p:sldSz cy="6858000" cx="12192000"/>
   <p:notesSz cx="6858000" cy="9144000"/>
@@ -1637,7 +1635,7 @@
           <a:lstStyle/>
           <a:p>
             <a:r>
-              <a:t>Results, ~1 min. Paper Fig. 10 vs the same computation on IVE. Each caption gives its own source's number. The paper's interval (footnote 29) treats buckets as independent; neighbouring VPIN values share almost all of their window, so it is far too narrow. With the same iid formula ours would be [0.07, 0.09]; month blocks give [0.04, 0.22]. Source: results/reproduction/parameter_grid.csv, summary.json.</a:t>
+              <a:t>Results, ~1 min. The heat maps are two separate panels: the paper's Table 4a and ours. Low VPIN does mean calm in both. The warning claims are weaker on IVE; the Table 5 number is consistent with ours only because our interval is wide (few stays in the top quartile at 10 buckets a day). Sources: results/reproduction/table4a.csv, table5.csv, summary.json (uncertainty).</a:t>
             </a:r>
           </a:p>
         </p:txBody>
@@ -1707,7 +1705,7 @@
           <a:lstStyle/>
           <a:p>
             <a:r>
-              <a:t>Results, ~1 min. The heat maps are two separate panels: the paper's Table 4a and ours. Low VPIN does mean calm in both. The warning claims are weaker on IVE; the Table 5 number is consistent with ours only because our interval is wide (few stays in the top quartile at 10 buckets a day). Sources: results/reproduction/table4a.csv, table5.csv, summary.json (uncertainty).</a:t>
+              <a:t>Summary. Left: what the paper reports. Right: what we find on IVE, with ± and a verdict that uses only our own data: reproduced if the paper's value is inside our 95% interval and the effect's direction is significant; inconclusive if inside but not significant; weaker if outside but the direction holds; not reproduced otherwise. Rule in scripts/make_report.py. Sources: results/report/scorecard_*.csv.</a:t>
             </a:r>
           </a:p>
         </p:txBody>
@@ -1777,7 +1775,7 @@
           <a:lstStyle/>
           <a:p>
             <a:r>
-              <a:t>Summary. Left: what the paper reports. Right: what we find on IVE, with ± and a verdict that uses only our own data: reproduced if the paper's value is inside our 95% interval and the effect's direction is significant; inconclusive if inside but not significant; weaker if outside but the direction holds; not reproduced otherwise. Rule in scripts/make_report.py. Sources: results/report/scorecard_*.csv.</a:t>
+              <a:t>Critique, ~1.5 min (required slide). Four ways the paper's numbers can be too good, and our check: a real-time pipeline (sigma, bucket size and CDF from the past only) with parameters frozen on the paper's period and tested on 2011-2026. Error bars are ± one bootstrap standard error. Source: results/extensions/ive_oos_comparison.csv.</a:t>
             </a:r>
           </a:p>
         </p:txBody>
@@ -1847,7 +1845,7 @@
           <a:lstStyle/>
           <a:p>
             <a:r>
-              <a:t>Critique, ~1.5 min (required slide). Four ways the paper's numbers can be too good, and our check: a real-time pipeline (sigma, bucket size and CDF from the past only) with parameters frozen on the paper's period and tested on 2011-2026. Error bars are ± one bootstrap standard error. Source: results/extensions/ive_oos_comparison.csv.</a:t>
+              <a:t>Upgrade, ~1 min. Binance BTCUSDT data mark the aggressor of every trade, so we know the true buy volume that BVC estimates — the paper never could. Same buckets, two classifications. ± by month blocks; the trade-day ranges are across 5 days. Sources: results/extensions/summary.json, btc_bars_bvc_vs_truth.csv, btc_trade_days.csv.</a:t>
             </a:r>
           </a:p>
         </p:txBody>
@@ -1917,7 +1915,7 @@
           <a:lstStyle/>
           <a:p>
             <a:r>
-              <a:t>Upgrade, ~1 min. Binance BTCUSDT data mark the aggressor of every trade, so we know the true buy volume that BVC estimates — the paper never could. Same buckets, two classifications. ± by month blocks; the trade-day ranges are across 5 days. Sources: results/extensions/summary.json, btc_bars_bvc_vs_truth.csv, btc_trade_days.csv.</a:t>
+              <a:t>Upgrade, ~1 min. One data source (BTC), three signals. Lift = hit rate divided by how often the alarm is on; a signal that is always on has lift 1. With true labels VPIN has no positive link to future volatility; with BVC it does, because BVC turns price moves into imbalance. Trailing volatility beats both. Andersen and Bondarenko (2014) made this argument; we confirm it with ground truth. Sources: btc_signal_comparison.csv, regressions.csv.</a:t>
             </a:r>
           </a:p>
         </p:txBody>
@@ -1987,7 +1985,7 @@
           <a:lstStyle/>
           <a:p>
             <a:r>
-              <a:t>Upgrade, ~1 min. One data source (BTC), three signals. Lift = hit rate divided by how often the alarm is on; a signal that is always on has lift 1. With true labels VPIN has no positive link to future volatility; with BVC it does, because BVC turns price moves into imbalance. Trailing volatility beats both. Andersen and Bondarenko (2014) made this argument; we confirm it with ground truth. Sources: btc_signal_comparison.csv, regressions.csv.</a:t>
+              <a:t>Upgrade, ~1 min. Fifteen years after the paper, one data source. Year by year, VPIN's correlation with the next move is small and unstable, trailing volatility is higher almost every year, and the share of time the VPIN alarm is on drifts a lot — a CDF from the past does not fit the future. Source: results/extensions/ive_by_year.csv, ive_oos_comparison.csv.</a:t>
             </a:r>
           </a:p>
         </p:txBody>
@@ -2057,7 +2055,7 @@
           <a:lstStyle/>
           <a:p>
             <a:r>
-              <a:t>Upgrade, ~1 min. Fifteen years after the paper, one data source. Year by year, VPIN's correlation with the next move is small and unstable, trailing volatility is higher almost every year, and the share of time the VPIN alarm is on drifts a lot — a CDF from the past does not fit the future. Source: results/extensions/ive_by_year.csv, ive_oos_comparison.csv.</a:t>
+              <a:t>Upgrade, ~45 s. Was the real-time alarm (CDF &gt;= 0.9) on when each day's largest one-hour fall began? Compare hits with how often the alarm is on overall. The binomial p-value assumes falls are independent draws, which they are not (several fall inside weeks of turmoil, e.g. Aug 2011, Mar 2020), so it is a rough guide. On IVE VPIN's alarm was on at every fall — the extension result most favourable to VPIN. Source: results/extensions/crash_events.csv, crash_alarm_summary.csv.</a:t>
             </a:r>
           </a:p>
         </p:txBody>
@@ -2127,7 +2125,7 @@
           <a:lstStyle/>
           <a:p>
             <a:r>
-              <a:t>Upgrade, ~45 s. Was the real-time alarm (CDF &gt;= 0.9) on when each day's largest one-hour fall began? Compare hits with how often the alarm is on overall. The binomial p-value assumes falls are independent draws, which they are not (several fall inside weeks of turmoil, e.g. Aug 2011, Mar 2020), so it is a rough guide. On IVE VPIN's alarm was on at every fall — the extension result most favourable to VPIN. Source: results/extensions/crash_events.csv, crash_alarm_summary.csv.</a:t>
+              <a:t>Critique ~1 min, next steps ~2 min. Keep it to what we tested. The authors disclose a patent on VPIN and a financial interest in it (title page).</a:t>
             </a:r>
           </a:p>
         </p:txBody>
@@ -2197,7 +2195,7 @@
           <a:lstStyle/>
           <a:p>
             <a:r>
-              <a:t>Critique ~1 min, next steps ~2 min. Keep it to what we tested. The authors disclose a patent on VPIN and a financial interest in it (title page).</a:t>
+              <a:t>Code is ours, written from scratch. One command per stage; every number in the README and these slides is read from results/. Raw data are downloaded by scripts, not committed.</a:t>
             </a:r>
           </a:p>
         </p:txBody>
@@ -2267,7 +2265,7 @@
           <a:lstStyle/>
           <a:p>
             <a:r>
-              <a:t>Code is ours, written from scratch. One command per stage; every number in the README and these slides is read from results/. Raw data are downloaded by scripts, not committed.</a:t>
+              <a:t>Backup; the Result 2 slide summarises it in the talk. The paper's exact in-sample method on every two-year window, starting each January and July: 31 windows of IVE, 10 of BTC. Every window is shown; none was selected. This analysis was run once as an exploration before we wrote the pre-registration, and we say so. Not a power problem: the reproduction can detect any correlation of 0.13 or more with 80% power. Source: results/extensions/windows/.</a:t>
             </a:r>
           </a:p>
         </p:txBody>
@@ -2407,7 +2405,7 @@
           <a:lstStyle/>
           <a:p>
             <a:r>
-              <a:t>Results, ~45 s. The paper's exact in-sample method on every two-year window, starting each January and July: 31 windows of IVE, 10 of BTC. Every window is shown; none was selected. This analysis was run once as an exploration before we wrote the pre-registration, and we say so. Not a power problem: the reproduction can detect any correlation of 0.13 or more with 80% power. Source: results/extensions/windows/.</a:t>
+              <a:t>Upgrade, ~1.5 min. The gap: the paper validates VPIN (Appendix A.2) with buys and sells drawn straight from the PIN model: correct labels, no prices. Its empirical VPIN uses bulk classification, which needs prices, so that validation does not cover the method it uses. We simulate the paper's own model with a price and run the exact pipeline where the truth is known. Hypotheses, metrics and decision rules were written in docs/preregistration.md before the first run; its hash is in the run manifest. D2: in world V the paper's VPIN raises more alarms in volatile blocks, although informed trading never changes; true-label VPIN goes the other way (extra uninformed volume dilutes informed trading), the same sign as on real BTC. In world V the paper's VPIN tracks the true informed share at corr ~0.03. D3 did not hold: the paper's predictive statistic is not fooled in this calibration, because two effects cancel. D4: one-day sigma fixes the bias and keeps detection. ± = Monte Carlo s.e. Every metric with its error bar: backup slide. Source: results/extensions/simulation/.</a:t>
             </a:r>
           </a:p>
         </p:txBody>
@@ -2477,7 +2475,7 @@
           <a:lstStyle/>
           <a:p>
             <a:r>
-              <a:t>Upgrade, ~1 min. The gap: the paper validates VPIN (Appendix A.2) with buys and sells drawn straight from the PIN model: correct labels, no prices. Its empirical VPIN uses bulk classification, which needs prices, so that validation does not cover the method it uses. We simulate the paper's own model with a price and run the exact pipeline where the truth is known. Hypotheses, metrics and decision rules were written in docs/preregistration.md before the first run; its hash is in the run manifest.</a:t>
+              <a:t>Backup for Extension 3. Bars are means over the replications, error bars ± 1.96 Monte Carlo standard errors. Left: D2, false alarms from volatility in world V (alarm rate in high minus low volatility blocks). Middle: detection of toxic episodes in world T (AUC, 0.5 = chance). Right: D3, the paper's predictive statistic where informed trading never changes (world V). Source: results/extensions/simulation/.</a:t>
             </a:r>
           </a:p>
         </p:txBody>
@@ -2547,7 +2545,7 @@
           <a:lstStyle/>
           <a:p>
             <a:r>
-              <a:t>Upgrade, ~1 min. D2: in world V the paper's VPIN raises more alarms in volatile blocks, although informed trading never changes; true-label VPIN goes the other way (extra uninformed volume dilutes informed trading), the same sign as on real BTC. In world V the paper's VPIN tracks the true informed share at corr ~0.03. D3 did not hold: the paper's predictive statistic is not fooled in this calibration, because two effects cancel. D4: one-day sigma fixes the bias and keeps detection. ± = Monte Carlo s.e. Source: results/extensions/simulation/.</a:t>
+              <a:t>Upgrade, ~1 min. Pre-registered rule D5, run because D4 held. Bulk classification with sigma from the previous day only, in the same real-time buckets. On BTC, where the truth is known, it tracks true-label VPIN better. And once the volatility bias is gone, most of VPIN's correlation with future volatility disappears: the paper's predictive power came from the bias. A small signal beyond volatility remains on IVE, none on BTC. Source: results/extensions/local_sigma/.</a:t>
             </a:r>
           </a:p>
         </p:txBody>
@@ -2617,147 +2615,7 @@
           <a:lstStyle/>
           <a:p>
             <a:r>
-              <a:t>Upgrade, ~1 min. Pre-registered rule D5, run because D4 held. Bulk classification with sigma from the previous day only, in the same real-time buckets. On BTC, where the truth is known, it tracks true-label VPIN better. And once the volatility bias is gone, most of VPIN's correlation with future volatility disappears: the paper's predictive power came from the bias. A small signal beyond volatility remains on IVE, none on BTC. Source: results/extensions/local_sigma/.</a:t>
-            </a:r>
-          </a:p>
-        </p:txBody>
-      </p:sp>
-      <p:sp>
-        <p:nvSpPr>
-          <p:cNvPr id="4" name="Slide Number Placeholder 3"/>
-          <p:cNvSpPr>
-            <a:spLocks noGrp="1"/>
-          </p:cNvSpPr>
-          <p:nvPr>
-            <p:ph type="sldNum" idx="12"/>
-          </p:nvPr>
-        </p:nvSpPr>
-        <p:spPr/>
-      </p:sp>
-    </p:spTree>
-  </p:cSld>
-  <p:clrMapOvr>
-    <a:masterClrMapping/>
-  </p:clrMapOvr>
-</p:notes>
-</file>
-
-<file path=ppt/notesSlides/notesSlide24.xml><?xml version="1.0" encoding="utf-8"?>
-<p:notes xmlns:a="http://schemas.openxmlformats.org/drawingml/2006/main" xmlns:p="http://schemas.openxmlformats.org/presentationml/2006/main" xmlns:r="http://schemas.openxmlformats.org/officeDocument/2006/relationships">
-  <p:cSld>
-    <p:spTree>
-      <p:nvGrpSpPr>
-        <p:cNvPr id="1" name=""/>
-        <p:cNvGrpSpPr/>
-        <p:nvPr/>
-      </p:nvGrpSpPr>
-      <p:grpSpPr>
-        <a:xfrm>
-          <a:off x="0" y="0"/>
-          <a:ext cx="0" cy="0"/>
-          <a:chOff x="0" y="0"/>
-          <a:chExt cx="0" cy="0"/>
-        </a:xfrm>
-      </p:grpSpPr>
-      <p:sp>
-        <p:nvSpPr>
-          <p:cNvPr id="2" name="Slide Image Placeholder 1"/>
-          <p:cNvSpPr>
-            <a:spLocks noGrp="1"/>
-          </p:cNvSpPr>
-          <p:nvPr>
-            <p:ph type="sldImg" idx="3"/>
-          </p:nvPr>
-        </p:nvSpPr>
-        <p:spPr/>
-      </p:sp>
-      <p:sp>
-        <p:nvSpPr>
-          <p:cNvPr id="3" name="Notes Placeholder 2"/>
-          <p:cNvSpPr>
-            <a:spLocks noGrp="1"/>
-          </p:cNvSpPr>
-          <p:nvPr>
-            <p:ph type="body" idx="1"/>
-          </p:nvPr>
-        </p:nvSpPr>
-        <p:spPr/>
-        <p:txBody>
-          <a:bodyPr/>
-          <a:lstStyle/>
-          <a:p>
-            <a:r>
-              <a:t>Upgrade, ~1 min. The placebo keeps each one-minute imbalance's size and draws its direction at random. If VPIN's predictive power came from informed traders on one side, the placebo would lose it; it keeps ~100%. On IVE 2011-26 the real VPIN is detectably better by 0.002 — still 97% kept. Ledger: a claim counts as supported only if significant and on the claimed side. Sources: results/extensions/inference/, results/report/ledger.csv, docs/preregistration.md.</a:t>
-            </a:r>
-          </a:p>
-        </p:txBody>
-      </p:sp>
-      <p:sp>
-        <p:nvSpPr>
-          <p:cNvPr id="4" name="Slide Number Placeholder 3"/>
-          <p:cNvSpPr>
-            <a:spLocks noGrp="1"/>
-          </p:cNvSpPr>
-          <p:nvPr>
-            <p:ph type="sldNum" idx="12"/>
-          </p:nvPr>
-        </p:nvSpPr>
-        <p:spPr/>
-      </p:sp>
-    </p:spTree>
-  </p:cSld>
-  <p:clrMapOvr>
-    <a:masterClrMapping/>
-  </p:clrMapOvr>
-</p:notes>
-</file>
-
-<file path=ppt/notesSlides/notesSlide25.xml><?xml version="1.0" encoding="utf-8"?>
-<p:notes xmlns:a="http://schemas.openxmlformats.org/drawingml/2006/main" xmlns:p="http://schemas.openxmlformats.org/presentationml/2006/main" xmlns:r="http://schemas.openxmlformats.org/officeDocument/2006/relationships">
-  <p:cSld>
-    <p:spTree>
-      <p:nvGrpSpPr>
-        <p:cNvPr id="1" name=""/>
-        <p:cNvGrpSpPr/>
-        <p:nvPr/>
-      </p:nvGrpSpPr>
-      <p:grpSpPr>
-        <a:xfrm>
-          <a:off x="0" y="0"/>
-          <a:ext cx="0" cy="0"/>
-          <a:chOff x="0" y="0"/>
-          <a:chExt cx="0" cy="0"/>
-        </a:xfrm>
-      </p:grpSpPr>
-      <p:sp>
-        <p:nvSpPr>
-          <p:cNvPr id="2" name="Slide Image Placeholder 1"/>
-          <p:cNvSpPr>
-            <a:spLocks noGrp="1"/>
-          </p:cNvSpPr>
-          <p:nvPr>
-            <p:ph type="sldImg" idx="3"/>
-          </p:nvPr>
-        </p:nvSpPr>
-        <p:spPr/>
-      </p:sp>
-      <p:sp>
-        <p:nvSpPr>
-          <p:cNvPr id="3" name="Notes Placeholder 2"/>
-          <p:cNvSpPr>
-            <a:spLocks noGrp="1"/>
-          </p:cNvSpPr>
-          <p:nvPr>
-            <p:ph type="body" idx="1"/>
-          </p:nvPr>
-        </p:nvSpPr>
-        <p:spPr/>
-        <p:txBody>
-          <a:bodyPr/>
-          <a:lstStyle/>
-          <a:p>
-            <a:r>
-              <a:t>~1 min. Be explicit about what is new and what confirms others. The ground-truth and volatility critiques confirm Andersen and Bondarenko (2014, 2015; the latter uses perfect trade classification on E-mini) and Chakrabarty, Pascual and Shkilko (2015, bulk vs trade-by-trade classification), on new data. The known-answer simulation that closes the paper's own validation gap, and the one-day-sigma fix tested against ground truth, are our additions, as far as we know.</a:t>
+              <a:t>~1 min. Be explicit about what is new and what confirms others. The ground-truth and volatility critiques confirm Andersen and Bondarenko (2014, 2015; the latter uses perfect trade classification on E-mini) and Chakrabarty, Pascual and Shkilko (2015, bulk vs trade-by-trade classification), on new data. The known-answer simulation that closes the paper's own validation gap, and the one-day-sigma fix tested against ground truth, are our additions, as far as we know. Right column, the inference behind points 2 and 4. The placebo keeps each one-minute imbalance's size and draws its direction at random. If VPIN's predictive power came from informed traders on one side, the placebo would lose it; it keeps ~100%. On IVE 2011-26 the real VPIN is detectably better by 0.002 — still 97% kept. Ledger: a claim counts as supported only if significant and on the claimed side. Sources: results/extensions/inference/, results/report/ledger.csv, docs/preregistration.md.</a:t>
             </a:r>
           </a:p>
         </p:txBody>
@@ -3037,7 +2895,7 @@
           <a:lstStyle/>
           <a:p>
             <a:r>
-              <a:t>Method, ~45 s. Anticipates 'what was the objective?'. VPIN is not trained: it is a moment estimator (average absolute imbalance over volume) of the PIN ratio, so it has no loss function. The only optimisation in the paper is the choice of bucket size and window: they scan grids and report the best cell, i.e. the selection objective IS the evaluation statistic, on the same data. We separate the two: select on 2009-11, evaluate on 2011-26.</a:t>
+              <a:t>Method, ~1 min. Top table, data: CME data are paid, so we use the only free tick history with quotes we found: IVE from Kibot, which covers the flash crash. Binance BTC data give the true aggressor side, which the paper never had. The table compares set-ups, not results. All deviations with reasons: DEVIATIONS.md. Bottom table anticipates 'what was the objective?'. VPIN is not trained: it is a moment estimator (average absolute imbalance over volume) of the PIN ratio, so it has no loss function. The only optimisation in the paper is the choice of bucket size and window: they scan grids and report the best cell, i.e. the selection objective IS the evaluation statistic, on the same data. We separate the two: select on 2009-11, evaluate on 2011-26.</a:t>
             </a:r>
           </a:p>
         </p:txBody>
@@ -3107,7 +2965,7 @@
           <a:lstStyle/>
           <a:p>
             <a:r>
-              <a:t>Data, ~1 min. CME data are paid, so we use the only free tick history with quotes we found: IVE from Kibot, which covers the flash crash. Binance BTC data give the true aggressor side, which the paper never had. This table compares set-ups, not results. All deviations with reasons: DEVIATIONS.md.</a:t>
+              <a:t>Results, ~1 min. Paper Fig. 4(a): CDF(VPIN) crossed 0.9 at least two hours before the crash. Ours, one-minute bars: CDF above 0.9 from 09:40, 4.9 h before 14:32. With 10-second bars it crosses only during the crash, and with Lee-Ready never. One event, so no ± is possible; the point is that the warning depends on the classification choice. Source: results/reproduction/flash_crash.csv.</a:t>
             </a:r>
           </a:p>
         </p:txBody>
@@ -3177,7 +3035,7 @@
           <a:lstStyle/>
           <a:p>
             <a:r>
-              <a:t>Results, ~1 min. Paper Fig. 4(a): CDF(VPIN) crossed 0.9 at least two hours before the crash. Ours, one-minute bars: CDF above 0.9 from 09:40, 4.9 h before 14:32. With 10-second bars it crosses only during the crash, and with Lee-Ready never. One event, so no ± is possible; the point is that the warning depends on the classification choice. Source: results/reproduction/flash_crash.csv.</a:t>
+              <a:t>Backup; rows 1-2 of the scorecard summarise it in the talk. Two separate tables: the paper's Table 1 and ours. Ours drops 6 May 2010 (IVE fell to about half its price for minutes; one change of ~100 sigma sets the kurtosis) and overnight changes (a 24-hour futures market has none). Last column: in how many paired bootstrap replications volume time has the lower value; green = at least 95%. Sources: results/reproduction/table1_*_bootstrap.csv, summary.json (stability).</a:t>
             </a:r>
           </a:p>
         </p:txBody>
@@ -3247,7 +3105,7 @@
           <a:lstStyle/>
           <a:p>
             <a:r>
-              <a:t>Results, ~1 min. Two separate tables: the paper's Table 1 and ours. Ours drops 6 May 2010 (IVE fell to about half its price for minutes; one change of ~100 sigma sets the kurtosis) and overnight changes (a 24-hour futures market has none). Last column: in how many paired bootstrap replications volume time has the lower value; green = at least 95%. Sources: results/reproduction/table1_*_bootstrap.csv, summary.json (stability).</a:t>
+              <a:t>Results, ~1 min. Paper Fig. 10 vs the same computation on IVE. Each caption gives its own source's number. The paper's interval (footnote 29) treats buckets as independent; neighbouring VPIN values share almost all of their window, so it is far too narrow. With the same iid formula ours would be [0.07, 0.09]; month blocks give [0.04, 0.22]. Every window: the paper's exact in-sample method on all 41 two-year windows of IVE and BTC; none reaches the paper's correlation or insurance value (backup slide). Source: results/reproduction/parameter_grid.csv, summary.json, results/extensions/windows/.</a:t>
             </a:r>
           </a:p>
         </p:txBody>
@@ -36333,273 +36191,6 @@
           <a:lstStyle/>
           <a:p>
             <a:r>
-              <a:t>Result 3: does VPIN predict the next bucket's volatility?</a:t>
-            </a:r>
-          </a:p>
-        </p:txBody>
-      </p:sp>
-      <p:sp>
-        <p:nvSpPr>
-          <p:cNvPr id="4" name="Text Placeholder 3"/>
-          <p:cNvSpPr>
-            <a:spLocks noGrp="1"/>
-          </p:cNvSpPr>
-          <p:nvPr>
-            <p:ph type="body" idx="2"/>
-          </p:nvPr>
-        </p:nvSpPr>
-        <p:spPr/>
-        <p:txBody>
-          <a:bodyPr/>
-          <a:lstStyle/>
-          <a:p>
-            <a:r>
-              <a:t>Research Seminar</a:t>
-            </a:r>
-          </a:p>
-        </p:txBody>
-      </p:sp>
-      <p:pic>
-        <p:nvPicPr>
-          <p:cNvPr id="5" name="Picture 4" descr="paper_fig10.png"/>
-          <p:cNvPicPr>
-            <a:picLocks noChangeAspect="1"/>
-          </p:cNvPicPr>
-          <p:nvPr/>
-        </p:nvPicPr>
-        <p:blipFill>
-          <a:blip r:embed="rId3"/>
-          <a:stretch>
-            <a:fillRect/>
-          </a:stretch>
-        </p:blipFill>
-        <p:spPr>
-          <a:xfrm>
-            <a:off x="365760" y="2180953"/>
-            <a:ext cx="5120640" cy="3501933"/>
-          </a:xfrm>
-          <a:prstGeom prst="rect">
-            <a:avLst/>
-          </a:prstGeom>
-        </p:spPr>
-      </p:pic>
-      <p:sp>
-        <p:nvSpPr>
-          <p:cNvPr id="6" name="TextBox 5"/>
-          <p:cNvSpPr txBox="1"/>
-          <p:nvPr/>
-        </p:nvSpPr>
-        <p:spPr>
-          <a:xfrm>
-            <a:off x="365760" y="5715000"/>
-            <a:ext cx="5120640" cy="640080"/>
-          </a:xfrm>
-          <a:prstGeom prst="rect">
-            <a:avLst/>
-          </a:prstGeom>
-          <a:noFill/>
-        </p:spPr>
-        <p:txBody>
-          <a:bodyPr wrap="square" anchor="t" lIns="45720" rIns="45720">
-            <a:spAutoFit/>
-          </a:bodyPr>
-          <a:lstStyle/>
-          <a:p>
-            <a:pPr algn="ctr">
-              <a:spcAft>
-                <a:spcPts val="600"/>
-              </a:spcAft>
-            </a:pPr>
-            <a:r>
-              <a:rPr sz="1200" b="0">
-                <a:solidFill>
-                  <a:srgbClr val="595959"/>
-                </a:solidFill>
-              </a:rPr>
-              <a:t>Paper (E-mini): 0.40 at (50, 250), 95% CI [0.392, 0.408] (iid)</a:t>
-            </a:r>
-          </a:p>
-        </p:txBody>
-      </p:sp>
-      <p:pic>
-        <p:nvPicPr>
-          <p:cNvPr id="7" name="Picture 6" descr="fig10_correlation.png"/>
-          <p:cNvPicPr>
-            <a:picLocks noChangeAspect="1"/>
-          </p:cNvPicPr>
-          <p:nvPr/>
-        </p:nvPicPr>
-        <p:blipFill>
-          <a:blip r:embed="rId4"/>
-          <a:stretch>
-            <a:fillRect/>
-          </a:stretch>
-        </p:blipFill>
-        <p:spPr>
-          <a:xfrm>
-            <a:off x="5669280" y="2358513"/>
-            <a:ext cx="4206240" cy="3146812"/>
-          </a:xfrm>
-          <a:prstGeom prst="rect">
-            <a:avLst/>
-          </a:prstGeom>
-        </p:spPr>
-      </p:pic>
-      <p:sp>
-        <p:nvSpPr>
-          <p:cNvPr id="8" name="TextBox 7"/>
-          <p:cNvSpPr txBox="1"/>
-          <p:nvPr/>
-        </p:nvSpPr>
-        <p:spPr>
-          <a:xfrm>
-            <a:off x="5669280" y="5715000"/>
-            <a:ext cx="4206240" cy="640080"/>
-          </a:xfrm>
-          <a:prstGeom prst="rect">
-            <a:avLst/>
-          </a:prstGeom>
-          <a:noFill/>
-        </p:spPr>
-        <p:txBody>
-          <a:bodyPr wrap="square" anchor="t" lIns="45720" rIns="45720">
-            <a:spAutoFit/>
-          </a:bodyPr>
-          <a:lstStyle/>
-          <a:p>
-            <a:pPr algn="ctr">
-              <a:spcAft>
-                <a:spcPts val="600"/>
-              </a:spcAft>
-            </a:pPr>
-            <a:r>
-              <a:rPr sz="1200" b="0">
-                <a:solidFill>
-                  <a:srgbClr val="595959"/>
-                </a:solidFill>
-              </a:rPr>
-              <a:t>Ours (IVE): 0.08 ± 0.05 at (50, 250), 95% CI [0.04, 0.22]</a:t>
-            </a:r>
-          </a:p>
-        </p:txBody>
-      </p:sp>
-      <p:sp>
-        <p:nvSpPr>
-          <p:cNvPr id="9" name="TextBox 8"/>
-          <p:cNvSpPr txBox="1"/>
-          <p:nvPr/>
-        </p:nvSpPr>
-        <p:spPr>
-          <a:xfrm>
-            <a:off x="9966960" y="2240280"/>
-            <a:ext cx="2057400" cy="4023360"/>
-          </a:xfrm>
-          <a:prstGeom prst="rect">
-            <a:avLst/>
-          </a:prstGeom>
-          <a:noFill/>
-        </p:spPr>
-        <p:txBody>
-          <a:bodyPr wrap="square" anchor="t" lIns="45720" rIns="45720">
-            <a:spAutoFit/>
-          </a:bodyPr>
-          <a:lstStyle/>
-          <a:p>
-            <a:pPr algn="l">
-              <a:spcAft>
-                <a:spcPts val="600"/>
-              </a:spcAft>
-            </a:pPr>
-            <a:r>
-              <a:rPr sz="1500" b="1">
-                <a:solidFill>
-                  <a:srgbClr val="0F2C68"/>
-                </a:solidFill>
-              </a:rPr>
-              <a:t>On IVE</a:t>
-            </a:r>
-          </a:p>
-          <a:p>
-            <a:pPr algn="l">
-              <a:spcAft>
-                <a:spcPts val="1200"/>
-              </a:spcAft>
-            </a:pPr>
-            <a:r>
-              <a:rPr sz="1300" b="0">
-                <a:solidFill>
-                  <a:srgbClr val="222222"/>
-                </a:solidFill>
-              </a:rPr>
-              <a:t>Same sign; 0.40 is outside our interval.</a:t>
-            </a:r>
-          </a:p>
-          <a:p>
-            <a:pPr algn="l">
-              <a:spcAft>
-                <a:spcPts val="600"/>
-              </a:spcAft>
-            </a:pPr>
-            <a:r>
-              <a:rPr sz="1500" b="1">
-                <a:solidFill>
-                  <a:srgbClr val="0F2C68"/>
-                </a:solidFill>
-              </a:rPr>
-              <a:t>About the ±</a:t>
-            </a:r>
-          </a:p>
-          <a:p>
-            <a:pPr algn="l">
-              <a:spcAft>
-                <a:spcPts val="600"/>
-              </a:spcAft>
-            </a:pPr>
-            <a:r>
-              <a:rPr sz="1300" b="0">
-                <a:solidFill>
-                  <a:srgbClr val="222222"/>
-                </a:solidFill>
-              </a:rPr>
-              <a:t>An iid interval would give ours as [0.07, 0.09]: overlapping windows make it far too narrow.</a:t>
-            </a:r>
-          </a:p>
-        </p:txBody>
-      </p:sp>
-    </p:spTree>
-  </p:cSld>
-  <p:clrMapOvr>
-    <a:masterClrMapping/>
-  </p:clrMapOvr>
-</p:sld>
-</file>
-
-<file path=ppt/slides/slide11.xml><?xml version="1.0" encoding="utf-8"?>
-<p:sld xmlns:a="http://schemas.openxmlformats.org/drawingml/2006/main" xmlns:p="http://schemas.openxmlformats.org/presentationml/2006/main" xmlns:r="http://schemas.openxmlformats.org/officeDocument/2006/relationships">
-  <p:cSld>
-    <p:spTree>
-      <p:nvGrpSpPr>
-        <p:cNvPr id="1" name=""/>
-        <p:cNvGrpSpPr/>
-        <p:nvPr/>
-      </p:nvGrpSpPr>
-      <p:grpSpPr/>
-      <p:sp>
-        <p:nvSpPr>
-          <p:cNvPr id="2" name="Title 1"/>
-          <p:cNvSpPr>
-            <a:spLocks noGrp="1"/>
-          </p:cNvSpPr>
-          <p:nvPr>
-            <p:ph type="title"/>
-          </p:nvPr>
-        </p:nvSpPr>
-        <p:spPr/>
-        <p:txBody>
-          <a:bodyPr/>
-          <a:lstStyle/>
-          <a:p>
-            <a:r>
               <a:t>Backup: high VPIN and large moves (Tables 4 and 5)</a:t>
             </a:r>
           </a:p>
@@ -36871,7 +36462,7 @@
 </p:sld>
 </file>
 
-<file path=ppt/slides/slide12.xml><?xml version="1.0" encoding="utf-8"?>
+<file path=ppt/slides/slide11.xml><?xml version="1.0" encoding="utf-8"?>
 <p:sld xmlns:a="http://schemas.openxmlformats.org/drawingml/2006/main" xmlns:p="http://schemas.openxmlformats.org/presentationml/2006/main" xmlns:r="http://schemas.openxmlformats.org/officeDocument/2006/relationships">
   <p:cSld>
     <p:spTree>
@@ -38723,7 +38314,7 @@
 </p:sld>
 </file>
 
-<file path=ppt/slides/slide13.xml><?xml version="1.0" encoding="utf-8"?>
+<file path=ppt/slides/slide12.xml><?xml version="1.0" encoding="utf-8"?>
 <p:sld xmlns:a="http://schemas.openxmlformats.org/drawingml/2006/main" xmlns:p="http://schemas.openxmlformats.org/presentationml/2006/main" xmlns:r="http://schemas.openxmlformats.org/officeDocument/2006/relationships">
   <p:cSld>
     <p:spTree>
@@ -39015,7 +38606,7 @@
 </p:sld>
 </file>
 
-<file path=ppt/slides/slide14.xml><?xml version="1.0" encoding="utf-8"?>
+<file path=ppt/slides/slide13.xml><?xml version="1.0" encoding="utf-8"?>
 <p:sld xmlns:a="http://schemas.openxmlformats.org/drawingml/2006/main" xmlns:p="http://schemas.openxmlformats.org/presentationml/2006/main" xmlns:r="http://schemas.openxmlformats.org/officeDocument/2006/relationships">
   <p:cSld>
     <p:spTree>
@@ -39346,7 +38937,7 @@
 </p:sld>
 </file>
 
-<file path=ppt/slides/slide15.xml><?xml version="1.0" encoding="utf-8"?>
+<file path=ppt/slides/slide14.xml><?xml version="1.0" encoding="utf-8"?>
 <p:sld xmlns:a="http://schemas.openxmlformats.org/drawingml/2006/main" xmlns:p="http://schemas.openxmlformats.org/presentationml/2006/main" xmlns:r="http://schemas.openxmlformats.org/officeDocument/2006/relationships">
   <p:cSld>
     <p:spTree>
@@ -39995,7 +39586,7 @@
 </p:sld>
 </file>
 
-<file path=ppt/slides/slide16.xml><?xml version="1.0" encoding="utf-8"?>
+<file path=ppt/slides/slide15.xml><?xml version="1.0" encoding="utf-8"?>
 <p:sld xmlns:a="http://schemas.openxmlformats.org/drawingml/2006/main" xmlns:p="http://schemas.openxmlformats.org/presentationml/2006/main" xmlns:r="http://schemas.openxmlformats.org/officeDocument/2006/relationships">
   <p:cSld>
     <p:spTree>
@@ -40181,7 +39772,7 @@
 </p:sld>
 </file>
 
-<file path=ppt/slides/slide17.xml><?xml version="1.0" encoding="utf-8"?>
+<file path=ppt/slides/slide16.xml><?xml version="1.0" encoding="utf-8"?>
 <p:sld xmlns:a="http://schemas.openxmlformats.org/drawingml/2006/main" xmlns:p="http://schemas.openxmlformats.org/presentationml/2006/main" xmlns:r="http://schemas.openxmlformats.org/officeDocument/2006/relationships">
   <p:cSld>
     <p:spTree>
@@ -42138,7 +41729,7 @@
 </p:sld>
 </file>
 
-<file path=ppt/slides/slide18.xml><?xml version="1.0" encoding="utf-8"?>
+<file path=ppt/slides/slide17.xml><?xml version="1.0" encoding="utf-8"?>
 <p:sld xmlns:a="http://schemas.openxmlformats.org/drawingml/2006/main" xmlns:p="http://schemas.openxmlformats.org/presentationml/2006/main" xmlns:r="http://schemas.openxmlformats.org/officeDocument/2006/relationships">
   <p:cSld>
     <p:spTree>
@@ -42584,7 +42175,7 @@
 </p:sld>
 </file>
 
-<file path=ppt/slides/slide19.xml><?xml version="1.0" encoding="utf-8"?>
+<file path=ppt/slides/slide18.xml><?xml version="1.0" encoding="utf-8"?>
 <p:sld xmlns:a="http://schemas.openxmlformats.org/drawingml/2006/main" xmlns:p="http://schemas.openxmlformats.org/presentationml/2006/main" xmlns:r="http://schemas.openxmlformats.org/officeDocument/2006/relationships">
   <p:cSld>
     <p:spTree>
@@ -43005,6 +42596,264 @@
                 </a:solidFill>
               </a:rPr>
               <a:t>Free data: 942,321 IVE trades in the paper's period; BTCUSDT 2020–2026.</a:t>
+            </a:r>
+          </a:p>
+        </p:txBody>
+      </p:sp>
+    </p:spTree>
+  </p:cSld>
+  <p:clrMapOvr>
+    <a:masterClrMapping/>
+  </p:clrMapOvr>
+</p:sld>
+</file>
+
+<file path=ppt/slides/slide19.xml><?xml version="1.0" encoding="utf-8"?>
+<p:sld xmlns:a="http://schemas.openxmlformats.org/drawingml/2006/main" xmlns:p="http://schemas.openxmlformats.org/presentationml/2006/main" xmlns:r="http://schemas.openxmlformats.org/officeDocument/2006/relationships">
+  <p:cSld>
+    <p:spTree>
+      <p:nvGrpSpPr>
+        <p:cNvPr id="1" name=""/>
+        <p:cNvGrpSpPr/>
+        <p:nvPr/>
+      </p:nvGrpSpPr>
+      <p:grpSpPr/>
+      <p:sp>
+        <p:nvSpPr>
+          <p:cNvPr id="2" name="Title 1"/>
+          <p:cNvSpPr>
+            <a:spLocks noGrp="1"/>
+          </p:cNvSpPr>
+          <p:nvPr>
+            <p:ph type="title"/>
+          </p:nvPr>
+        </p:nvSpPr>
+        <p:spPr/>
+        <p:txBody>
+          <a:bodyPr/>
+          <a:lstStyle/>
+          <a:p>
+            <a:r>
+              <a:t>Backup: the paper's predictive claims on every two-year window</a:t>
+            </a:r>
+          </a:p>
+        </p:txBody>
+      </p:sp>
+      <p:sp>
+        <p:nvSpPr>
+          <p:cNvPr id="4" name="Text Placeholder 3"/>
+          <p:cNvSpPr>
+            <a:spLocks noGrp="1"/>
+          </p:cNvSpPr>
+          <p:nvPr>
+            <p:ph type="body" idx="2"/>
+          </p:nvPr>
+        </p:nvSpPr>
+        <p:spPr/>
+        <p:txBody>
+          <a:bodyPr/>
+          <a:lstStyle/>
+          <a:p>
+            <a:r>
+              <a:t>Research Seminar</a:t>
+            </a:r>
+          </a:p>
+        </p:txBody>
+      </p:sp>
+      <p:pic>
+        <p:nvPicPr>
+          <p:cNvPr id="5" name="Picture 4" descr="windows.png"/>
+          <p:cNvPicPr>
+            <a:picLocks noChangeAspect="1"/>
+          </p:cNvPicPr>
+          <p:nvPr/>
+        </p:nvPicPr>
+        <p:blipFill>
+          <a:blip r:embed="rId3"/>
+          <a:stretch>
+            <a:fillRect/>
+          </a:stretch>
+        </p:blipFill>
+        <p:spPr>
+          <a:xfrm>
+            <a:off x="365760" y="2266160"/>
+            <a:ext cx="7680960" cy="2462839"/>
+          </a:xfrm>
+          <a:prstGeom prst="rect">
+            <a:avLst/>
+          </a:prstGeom>
+        </p:spPr>
+      </p:pic>
+      <p:sp>
+        <p:nvSpPr>
+          <p:cNvPr id="6" name="TextBox 5"/>
+          <p:cNvSpPr txBox="1"/>
+          <p:nvPr/>
+        </p:nvSpPr>
+        <p:spPr>
+          <a:xfrm>
+            <a:off x="585216" y="4983480"/>
+            <a:ext cx="7498079" cy="1463040"/>
+          </a:xfrm>
+          <a:prstGeom prst="rect">
+            <a:avLst/>
+          </a:prstGeom>
+          <a:noFill/>
+        </p:spPr>
+        <p:txBody>
+          <a:bodyPr wrap="square" anchor="t" lIns="45720" rIns="45720">
+            <a:spAutoFit/>
+          </a:bodyPr>
+          <a:lstStyle/>
+          <a:p>
+            <a:pPr algn="l">
+              <a:spcAft>
+                <a:spcPts val="500"/>
+              </a:spcAft>
+            </a:pPr>
+            <a:r>
+              <a:rPr sz="1300" b="0">
+                <a:solidFill>
+                  <a:srgbClr val="222222"/>
+                </a:solidFill>
+              </a:rPr>
+              <a:t>• IVE: corr 0.00 to 0.24; P(top quartile | big move) 19% to 76%.</a:t>
+            </a:r>
+          </a:p>
+          <a:p>
+            <a:pPr algn="l">
+              <a:spcAft>
+                <a:spcPts val="500"/>
+              </a:spcAft>
+            </a:pPr>
+            <a:r>
+              <a:rPr sz="1300" b="0">
+                <a:solidFill>
+                  <a:srgbClr val="222222"/>
+                </a:solidFill>
+              </a:rPr>
+              <a:t>• BTC: corr 0.01 to 0.16; P(top quartile | big move) 27% to 48%. Big moves are routine on BTC, so low VPIN scores as many true positives.</a:t>
+            </a:r>
+          </a:p>
+        </p:txBody>
+      </p:sp>
+      <p:sp>
+        <p:nvSpPr>
+          <p:cNvPr id="7" name="TextBox 6"/>
+          <p:cNvSpPr txBox="1"/>
+          <p:nvPr/>
+        </p:nvSpPr>
+        <p:spPr>
+          <a:xfrm>
+            <a:off x="8321040" y="2240280"/>
+            <a:ext cx="3657600" cy="1463040"/>
+          </a:xfrm>
+          <a:prstGeom prst="rect">
+            <a:avLst/>
+          </a:prstGeom>
+          <a:noFill/>
+        </p:spPr>
+        <p:txBody>
+          <a:bodyPr wrap="square" anchor="t" lIns="45720" rIns="45720">
+            <a:spAutoFit/>
+          </a:bodyPr>
+          <a:lstStyle/>
+          <a:p>
+            <a:pPr algn="l">
+              <a:spcAft>
+                <a:spcPts val="600"/>
+              </a:spcAft>
+            </a:pPr>
+            <a:r>
+              <a:rPr sz="1400" b="1">
+                <a:solidFill>
+                  <a:srgbClr val="0F2C68"/>
+                </a:solidFill>
+              </a:rPr>
+              <a:t>Paper reports (E-mini, 2008–11)</a:t>
+            </a:r>
+          </a:p>
+          <a:p>
+            <a:pPr algn="l">
+              <a:spcAft>
+                <a:spcPts val="600"/>
+              </a:spcAft>
+            </a:pPr>
+            <a:r>
+              <a:rPr sz="1300" b="0">
+                <a:solidFill>
+                  <a:srgbClr val="222222"/>
+                </a:solidFill>
+              </a:rPr>
+              <a:t>• corr 0.40; P(top quartile | big move) &gt; 84%</a:t>
+            </a:r>
+          </a:p>
+        </p:txBody>
+      </p:sp>
+      <p:sp>
+        <p:nvSpPr>
+          <p:cNvPr id="8" name="TextBox 7"/>
+          <p:cNvSpPr txBox="1"/>
+          <p:nvPr/>
+        </p:nvSpPr>
+        <p:spPr>
+          <a:xfrm>
+            <a:off x="8321040" y="3840480"/>
+            <a:ext cx="3657600" cy="2560320"/>
+          </a:xfrm>
+          <a:prstGeom prst="rect">
+            <a:avLst/>
+          </a:prstGeom>
+          <a:noFill/>
+        </p:spPr>
+        <p:txBody>
+          <a:bodyPr wrap="square" anchor="t" lIns="45720" rIns="45720">
+            <a:spAutoFit/>
+          </a:bodyPr>
+          <a:lstStyle/>
+          <a:p>
+            <a:pPr algn="l">
+              <a:spcAft>
+                <a:spcPts val="600"/>
+              </a:spcAft>
+            </a:pPr>
+            <a:r>
+              <a:rPr sz="1400" b="1">
+                <a:solidFill>
+                  <a:srgbClr val="0F2C68"/>
+                </a:solidFill>
+              </a:rPr>
+              <a:t>Our reading</a:t>
+            </a:r>
+          </a:p>
+          <a:p>
+            <a:pPr algn="l">
+              <a:spcAft>
+                <a:spcPts val="600"/>
+              </a:spcAft>
+            </a:pPr>
+            <a:r>
+              <a:rPr sz="1300" b="0">
+                <a:solidFill>
+                  <a:srgbClr val="222222"/>
+                </a:solidFill>
+              </a:rPr>
+              <a:t>• No window on either market reaches the paper's numbers.</a:t>
+            </a:r>
+          </a:p>
+          <a:p>
+            <a:pPr algn="l">
+              <a:spcAft>
+                <a:spcPts val="600"/>
+              </a:spcAft>
+            </a:pPr>
+            <a:r>
+              <a:rPr sz="1300" b="0">
+                <a:solidFill>
+                  <a:srgbClr val="222222"/>
+                </a:solidFill>
+              </a:rPr>
+              <a:t>• Our reproduction could detect any correlation ≥ 0.13 (80% power): the gap is not a matter of power.</a:t>
             </a:r>
           </a:p>
         </p:txBody>
@@ -43615,265 +43464,7 @@
           <a:lstStyle/>
           <a:p>
             <a:r>
-              <a:t>Result 4: the paper's predictive claims on every two-year window</a:t>
-            </a:r>
-          </a:p>
-        </p:txBody>
-      </p:sp>
-      <p:sp>
-        <p:nvSpPr>
-          <p:cNvPr id="4" name="Text Placeholder 3"/>
-          <p:cNvSpPr>
-            <a:spLocks noGrp="1"/>
-          </p:cNvSpPr>
-          <p:nvPr>
-            <p:ph type="body" idx="2"/>
-          </p:nvPr>
-        </p:nvSpPr>
-        <p:spPr/>
-        <p:txBody>
-          <a:bodyPr/>
-          <a:lstStyle/>
-          <a:p>
-            <a:r>
-              <a:t>Research Seminar</a:t>
-            </a:r>
-          </a:p>
-        </p:txBody>
-      </p:sp>
-      <p:pic>
-        <p:nvPicPr>
-          <p:cNvPr id="5" name="Picture 4" descr="windows.png"/>
-          <p:cNvPicPr>
-            <a:picLocks noChangeAspect="1"/>
-          </p:cNvPicPr>
-          <p:nvPr/>
-        </p:nvPicPr>
-        <p:blipFill>
-          <a:blip r:embed="rId3"/>
-          <a:stretch>
-            <a:fillRect/>
-          </a:stretch>
-        </p:blipFill>
-        <p:spPr>
-          <a:xfrm>
-            <a:off x="365760" y="2266160"/>
-            <a:ext cx="7680960" cy="2462839"/>
-          </a:xfrm>
-          <a:prstGeom prst="rect">
-            <a:avLst/>
-          </a:prstGeom>
-        </p:spPr>
-      </p:pic>
-      <p:sp>
-        <p:nvSpPr>
-          <p:cNvPr id="6" name="TextBox 5"/>
-          <p:cNvSpPr txBox="1"/>
-          <p:nvPr/>
-        </p:nvSpPr>
-        <p:spPr>
-          <a:xfrm>
-            <a:off x="585216" y="4983480"/>
-            <a:ext cx="7498079" cy="1463040"/>
-          </a:xfrm>
-          <a:prstGeom prst="rect">
-            <a:avLst/>
-          </a:prstGeom>
-          <a:noFill/>
-        </p:spPr>
-        <p:txBody>
-          <a:bodyPr wrap="square" anchor="t" lIns="45720" rIns="45720">
-            <a:spAutoFit/>
-          </a:bodyPr>
-          <a:lstStyle/>
-          <a:p>
-            <a:pPr algn="l">
-              <a:spcAft>
-                <a:spcPts val="500"/>
-              </a:spcAft>
-            </a:pPr>
-            <a:r>
-              <a:rPr sz="1300" b="0">
-                <a:solidFill>
-                  <a:srgbClr val="222222"/>
-                </a:solidFill>
-              </a:rPr>
-              <a:t>• IVE: corr 0.00 to 0.24; P(top quartile | big move) 19% to 76%.</a:t>
-            </a:r>
-          </a:p>
-          <a:p>
-            <a:pPr algn="l">
-              <a:spcAft>
-                <a:spcPts val="500"/>
-              </a:spcAft>
-            </a:pPr>
-            <a:r>
-              <a:rPr sz="1300" b="0">
-                <a:solidFill>
-                  <a:srgbClr val="222222"/>
-                </a:solidFill>
-              </a:rPr>
-              <a:t>• BTC: corr 0.01 to 0.16; P(top quartile | big move) 27% to 48%. Big moves are routine on BTC, so low VPIN scores as many true positives.</a:t>
-            </a:r>
-          </a:p>
-        </p:txBody>
-      </p:sp>
-      <p:sp>
-        <p:nvSpPr>
-          <p:cNvPr id="7" name="TextBox 6"/>
-          <p:cNvSpPr txBox="1"/>
-          <p:nvPr/>
-        </p:nvSpPr>
-        <p:spPr>
-          <a:xfrm>
-            <a:off x="8321040" y="2240280"/>
-            <a:ext cx="3657600" cy="1463040"/>
-          </a:xfrm>
-          <a:prstGeom prst="rect">
-            <a:avLst/>
-          </a:prstGeom>
-          <a:noFill/>
-        </p:spPr>
-        <p:txBody>
-          <a:bodyPr wrap="square" anchor="t" lIns="45720" rIns="45720">
-            <a:spAutoFit/>
-          </a:bodyPr>
-          <a:lstStyle/>
-          <a:p>
-            <a:pPr algn="l">
-              <a:spcAft>
-                <a:spcPts val="600"/>
-              </a:spcAft>
-            </a:pPr>
-            <a:r>
-              <a:rPr sz="1400" b="1">
-                <a:solidFill>
-                  <a:srgbClr val="0F2C68"/>
-                </a:solidFill>
-              </a:rPr>
-              <a:t>Paper reports (E-mini, 2008–11)</a:t>
-            </a:r>
-          </a:p>
-          <a:p>
-            <a:pPr algn="l">
-              <a:spcAft>
-                <a:spcPts val="600"/>
-              </a:spcAft>
-            </a:pPr>
-            <a:r>
-              <a:rPr sz="1300" b="0">
-                <a:solidFill>
-                  <a:srgbClr val="222222"/>
-                </a:solidFill>
-              </a:rPr>
-              <a:t>• corr 0.40; P(top quartile | big move) &gt; 84%</a:t>
-            </a:r>
-          </a:p>
-        </p:txBody>
-      </p:sp>
-      <p:sp>
-        <p:nvSpPr>
-          <p:cNvPr id="8" name="TextBox 7"/>
-          <p:cNvSpPr txBox="1"/>
-          <p:nvPr/>
-        </p:nvSpPr>
-        <p:spPr>
-          <a:xfrm>
-            <a:off x="8321040" y="3840480"/>
-            <a:ext cx="3657600" cy="2560320"/>
-          </a:xfrm>
-          <a:prstGeom prst="rect">
-            <a:avLst/>
-          </a:prstGeom>
-          <a:noFill/>
-        </p:spPr>
-        <p:txBody>
-          <a:bodyPr wrap="square" anchor="t" lIns="45720" rIns="45720">
-            <a:spAutoFit/>
-          </a:bodyPr>
-          <a:lstStyle/>
-          <a:p>
-            <a:pPr algn="l">
-              <a:spcAft>
-                <a:spcPts val="600"/>
-              </a:spcAft>
-            </a:pPr>
-            <a:r>
-              <a:rPr sz="1400" b="1">
-                <a:solidFill>
-                  <a:srgbClr val="0F2C68"/>
-                </a:solidFill>
-              </a:rPr>
-              <a:t>Our reading</a:t>
-            </a:r>
-          </a:p>
-          <a:p>
-            <a:pPr algn="l">
-              <a:spcAft>
-                <a:spcPts val="600"/>
-              </a:spcAft>
-            </a:pPr>
-            <a:r>
-              <a:rPr sz="1300" b="0">
-                <a:solidFill>
-                  <a:srgbClr val="222222"/>
-                </a:solidFill>
-              </a:rPr>
-              <a:t>• No window on either market reaches the paper's numbers.</a:t>
-            </a:r>
-          </a:p>
-          <a:p>
-            <a:pPr algn="l">
-              <a:spcAft>
-                <a:spcPts val="600"/>
-              </a:spcAft>
-            </a:pPr>
-            <a:r>
-              <a:rPr sz="1300" b="0">
-                <a:solidFill>
-                  <a:srgbClr val="222222"/>
-                </a:solidFill>
-              </a:rPr>
-              <a:t>• Our reproduction could detect any correlation ≥ 0.13 (80% power): the gap is not a matter of power.</a:t>
-            </a:r>
-          </a:p>
-        </p:txBody>
-      </p:sp>
-    </p:spTree>
-  </p:cSld>
-  <p:clrMapOvr>
-    <a:masterClrMapping/>
-  </p:clrMapOvr>
-</p:sld>
-</file>
-
-<file path=ppt/slides/slide21.xml><?xml version="1.0" encoding="utf-8"?>
-<p:sld xmlns:a="http://schemas.openxmlformats.org/drawingml/2006/main" xmlns:p="http://schemas.openxmlformats.org/presentationml/2006/main" xmlns:r="http://schemas.openxmlformats.org/officeDocument/2006/relationships">
-  <p:cSld>
-    <p:spTree>
-      <p:nvGrpSpPr>
-        <p:cNvPr id="1" name=""/>
-        <p:cNvGrpSpPr/>
-        <p:nvPr/>
-      </p:nvGrpSpPr>
-      <p:grpSpPr/>
-      <p:sp>
-        <p:nvSpPr>
-          <p:cNvPr id="2" name="Title 1"/>
-          <p:cNvSpPr>
-            <a:spLocks noGrp="1"/>
-          </p:cNvSpPr>
-          <p:nvPr>
-            <p:ph type="title"/>
-          </p:nvPr>
-        </p:nvSpPr>
-        <p:spPr/>
-        <p:txBody>
-          <a:bodyPr/>
-          <a:lstStyle/>
-          <a:p>
-            <a:r>
-              <a:t>Extension 3: a known-answer test of VPIN — design (pre-registered)</a:t>
+              <a:t>Extension 3: a known-answer test of VPIN (pre-registered)</a:t>
             </a:r>
           </a:p>
         </p:txBody>
@@ -43907,8 +43498,8 @@
         </p:nvSpPr>
         <p:spPr>
           <a:xfrm>
-            <a:off x="585216" y="2194560"/>
-            <a:ext cx="5669280" cy="4297680"/>
+            <a:off x="585216" y="2103120"/>
+            <a:ext cx="5852160" cy="1920240"/>
           </a:xfrm>
           <a:prstGeom prst="rect">
             <a:avLst/>
@@ -43923,11 +43514,11 @@
           <a:p>
             <a:pPr algn="l">
               <a:spcAft>
-                <a:spcPts val="800"/>
+                <a:spcPts val="400"/>
               </a:spcAft>
             </a:pPr>
             <a:r>
-              <a:rPr sz="1400" b="0">
+              <a:rPr sz="1200" b="0">
                 <a:solidFill>
                   <a:srgbClr val="222222"/>
                 </a:solidFill>
@@ -43935,7 +43526,7 @@
               <a:t>• </a:t>
             </a:r>
             <a:r>
-              <a:rPr sz="1400" b="1">
+              <a:rPr sz="1200" b="1">
                 <a:solidFill>
                   <a:srgbClr val="222222"/>
                 </a:solidFill>
@@ -43943,7 +43534,7 @@
               <a:t>Gap in the paper:</a:t>
             </a:r>
             <a:r>
-              <a:rPr sz="1400" b="0">
+              <a:rPr sz="1200" b="0">
                 <a:solidFill>
                   <a:srgbClr val="222222"/>
                 </a:solidFill>
@@ -43954,11 +43545,11 @@
           <a:p>
             <a:pPr algn="l">
               <a:spcAft>
-                <a:spcPts val="800"/>
+                <a:spcPts val="400"/>
               </a:spcAft>
             </a:pPr>
             <a:r>
-              <a:rPr sz="1400" b="0">
+              <a:rPr sz="1200" b="0">
                 <a:solidFill>
                   <a:srgbClr val="222222"/>
                 </a:solidFill>
@@ -43966,7 +43557,7 @@
               <a:t>• </a:t>
             </a:r>
             <a:r>
-              <a:rPr sz="1400" b="1">
+              <a:rPr sz="1200" b="1">
                 <a:solidFill>
                   <a:srgbClr val="222222"/>
                 </a:solidFill>
@@ -43974,7 +43565,7 @@
               <a:t>Our model:</a:t>
             </a:r>
             <a:r>
-              <a:rPr sz="1400" b="0">
+              <a:rPr sz="1200" b="0">
                 <a:solidFill>
                   <a:srgbClr val="222222"/>
                 </a:solidFill>
@@ -43985,11 +43576,11 @@
           <a:p>
             <a:pPr algn="l">
               <a:spcAft>
-                <a:spcPts val="800"/>
+                <a:spcPts val="400"/>
               </a:spcAft>
             </a:pPr>
             <a:r>
-              <a:rPr sz="1400" b="0">
+              <a:rPr sz="1200" b="0">
                 <a:solidFill>
                   <a:srgbClr val="222222"/>
                 </a:solidFill>
@@ -43997,7 +43588,7 @@
               <a:t>• </a:t>
             </a:r>
             <a:r>
-              <a:rPr sz="1400" b="1">
+              <a:rPr sz="1200" b="1">
                 <a:solidFill>
                   <a:srgbClr val="222222"/>
                 </a:solidFill>
@@ -44005,7 +43596,7 @@
               <a:t>Worlds:</a:t>
             </a:r>
             <a:r>
-              <a:rPr sz="1400" b="0">
+              <a:rPr sz="1200" b="0">
                 <a:solidFill>
                   <a:srgbClr val="222222"/>
                 </a:solidFill>
@@ -44016,11 +43607,11 @@
           <a:p>
             <a:pPr algn="l">
               <a:spcAft>
-                <a:spcPts val="800"/>
+                <a:spcPts val="400"/>
               </a:spcAft>
             </a:pPr>
             <a:r>
-              <a:rPr sz="1400" b="0">
+              <a:rPr sz="1200" b="0">
                 <a:solidFill>
                   <a:srgbClr val="222222"/>
                 </a:solidFill>
@@ -44028,7 +43619,7 @@
               <a:t>• </a:t>
             </a:r>
             <a:r>
-              <a:rPr sz="1400" b="1">
+              <a:rPr sz="1200" b="1">
                 <a:solidFill>
                   <a:srgbClr val="222222"/>
                 </a:solidFill>
@@ -44036,7 +43627,7 @@
               <a:t>Same pipeline</a:t>
             </a:r>
             <a:r>
-              <a:rPr sz="1400" b="0">
+              <a:rPr sz="1200" b="0">
                 <a:solidFill>
                   <a:srgbClr val="222222"/>
                 </a:solidFill>
@@ -44046,152 +43637,6 @@
           </a:p>
         </p:txBody>
       </p:sp>
-      <p:pic>
-        <p:nvPicPr>
-          <p:cNvPr id="6" name="Picture 5" descr="example_V.png"/>
-          <p:cNvPicPr>
-            <a:picLocks noChangeAspect="1"/>
-          </p:cNvPicPr>
-          <p:nvPr/>
-        </p:nvPicPr>
-        <p:blipFill>
-          <a:blip r:embed="rId3"/>
-          <a:stretch>
-            <a:fillRect/>
-          </a:stretch>
-        </p:blipFill>
-        <p:spPr>
-          <a:xfrm>
-            <a:off x="6400800" y="2763749"/>
-            <a:ext cx="5577840" cy="2244900"/>
-          </a:xfrm>
-          <a:prstGeom prst="rect">
-            <a:avLst/>
-          </a:prstGeom>
-        </p:spPr>
-      </p:pic>
-      <p:sp>
-        <p:nvSpPr>
-          <p:cNvPr id="7" name="TextBox 6"/>
-          <p:cNvSpPr txBox="1"/>
-          <p:nvPr/>
-        </p:nvSpPr>
-        <p:spPr>
-          <a:xfrm>
-            <a:off x="6400800" y="5577840"/>
-            <a:ext cx="5577840" cy="822960"/>
-          </a:xfrm>
-          <a:prstGeom prst="rect">
-            <a:avLst/>
-          </a:prstGeom>
-          <a:noFill/>
-        </p:spPr>
-        <p:txBody>
-          <a:bodyPr wrap="square" anchor="t" lIns="45720" rIns="45720">
-            <a:spAutoFit/>
-          </a:bodyPr>
-          <a:lstStyle/>
-          <a:p>
-            <a:pPr algn="l">
-              <a:spcAft>
-                <a:spcPts val="600"/>
-              </a:spcAft>
-            </a:pPr>
-            <a:r>
-              <a:rPr sz="1100" b="0">
-                <a:solidFill>
-                  <a:srgbClr val="595959"/>
-                </a:solidFill>
-              </a:rPr>
-              <a:t>World V: the paper's VPIN (blue) stays high in volatile blocks while the true informed share (dashed) falls.</a:t>
-            </a:r>
-          </a:p>
-        </p:txBody>
-      </p:sp>
-    </p:spTree>
-  </p:cSld>
-  <p:clrMapOvr>
-    <a:masterClrMapping/>
-  </p:clrMapOvr>
-</p:sld>
-</file>
-
-<file path=ppt/slides/slide22.xml><?xml version="1.0" encoding="utf-8"?>
-<p:sld xmlns:a="http://schemas.openxmlformats.org/drawingml/2006/main" xmlns:p="http://schemas.openxmlformats.org/presentationml/2006/main" xmlns:r="http://schemas.openxmlformats.org/officeDocument/2006/relationships">
-  <p:cSld>
-    <p:spTree>
-      <p:nvGrpSpPr>
-        <p:cNvPr id="1" name=""/>
-        <p:cNvGrpSpPr/>
-        <p:nvPr/>
-      </p:nvGrpSpPr>
-      <p:grpSpPr/>
-      <p:sp>
-        <p:nvSpPr>
-          <p:cNvPr id="2" name="Title 1"/>
-          <p:cNvSpPr>
-            <a:spLocks noGrp="1"/>
-          </p:cNvSpPr>
-          <p:nvPr>
-            <p:ph type="title"/>
-          </p:nvPr>
-        </p:nvSpPr>
-        <p:spPr/>
-        <p:txBody>
-          <a:bodyPr/>
-          <a:lstStyle/>
-          <a:p>
-            <a:r>
-              <a:t>Extension 3: results of the known-answer test</a:t>
-            </a:r>
-          </a:p>
-        </p:txBody>
-      </p:sp>
-      <p:sp>
-        <p:nvSpPr>
-          <p:cNvPr id="4" name="Text Placeholder 3"/>
-          <p:cNvSpPr>
-            <a:spLocks noGrp="1"/>
-          </p:cNvSpPr>
-          <p:nvPr>
-            <p:ph type="body" idx="2"/>
-          </p:nvPr>
-        </p:nvSpPr>
-        <p:spPr/>
-        <p:txBody>
-          <a:bodyPr/>
-          <a:lstStyle/>
-          <a:p>
-            <a:r>
-              <a:t>Research Seminar</a:t>
-            </a:r>
-          </a:p>
-        </p:txBody>
-      </p:sp>
-      <p:pic>
-        <p:nvPicPr>
-          <p:cNvPr id="5" name="Picture 4" descr="metrics.png"/>
-          <p:cNvPicPr>
-            <a:picLocks noChangeAspect="1"/>
-          </p:cNvPicPr>
-          <p:nvPr/>
-        </p:nvPicPr>
-        <p:blipFill>
-          <a:blip r:embed="rId3"/>
-          <a:stretch>
-            <a:fillRect/>
-          </a:stretch>
-        </p:blipFill>
-        <p:spPr>
-          <a:xfrm>
-            <a:off x="365760" y="2156639"/>
-            <a:ext cx="7680960" cy="2407561"/>
-          </a:xfrm>
-          <a:prstGeom prst="rect">
-            <a:avLst/>
-          </a:prstGeom>
-        </p:spPr>
-      </p:pic>
       <p:graphicFrame>
         <p:nvGraphicFramePr>
           <p:cNvPr id="6" name="Table 5"/>
@@ -44201,8 +43646,8 @@
           <p:nvPr/>
         </p:nvGraphicFramePr>
         <p:xfrm>
-          <a:off x="585216" y="4754880"/>
-          <a:ext cx="7406640" cy="1737360"/>
+          <a:off x="585216" y="3886200"/>
+          <a:ext cx="5852160" cy="1737360"/>
         </p:xfrm>
         <a:graphic>
           <a:graphicData uri="http://schemas.openxmlformats.org/drawingml/2006/table">
@@ -44211,10 +43656,10 @@
                 <a:tableStyleId>{5C22544A-7EE6-4342-B048-85BDC9FD1C3A}</a:tableStyleId>
               </a:tblPr>
               <a:tblGrid>
-                <a:gridCol w="548640"/>
-                <a:gridCol w="3566160"/>
-                <a:gridCol w="2011680"/>
-                <a:gridCol w="1280160"/>
+                <a:gridCol w="502920"/>
+                <a:gridCol w="2697480"/>
+                <a:gridCol w="1463040"/>
+                <a:gridCol w="1188720"/>
               </a:tblGrid>
               <a:tr h="347472">
                 <a:tc>
@@ -44658,8 +44103,8 @@
         </p:nvSpPr>
         <p:spPr>
           <a:xfrm>
-            <a:off x="8321040" y="2194560"/>
-            <a:ext cx="3657600" cy="4206240"/>
+            <a:off x="6720840" y="2103120"/>
+            <a:ext cx="5257800" cy="1188720"/>
           </a:xfrm>
           <a:prstGeom prst="rect">
             <a:avLst/>
@@ -44693,7 +44138,7 @@
               </a:spcAft>
             </a:pPr>
             <a:r>
-              <a:rPr sz="1400" b="0">
+              <a:rPr sz="1300" b="0">
                 <a:solidFill>
                   <a:srgbClr val="222222"/>
                 </a:solidFill>
@@ -44701,53 +44146,39 @@
               <a:t>• paper's VPIN </a:t>
             </a:r>
             <a:r>
-              <a:rPr sz="1400" b="1">
+              <a:rPr sz="1300" b="1">
                 <a:solidFill>
                   <a:srgbClr val="222222"/>
                 </a:solidFill>
               </a:rPr>
               <a:t>0.03</a:t>
             </a:r>
-          </a:p>
-          <a:p>
-            <a:pPr algn="l">
-              <a:spcAft>
-                <a:spcPts val="400"/>
-              </a:spcAft>
-            </a:pPr>
             <a:r>
-              <a:rPr sz="1400" b="0">
+              <a:rPr sz="1300" b="0">
                 <a:solidFill>
                   <a:srgbClr val="222222"/>
                 </a:solidFill>
               </a:rPr>
-              <a:t>• true labels </a:t>
+              <a:t> · true labels </a:t>
             </a:r>
             <a:r>
-              <a:rPr sz="1400" b="1">
+              <a:rPr sz="1300" b="1">
                 <a:solidFill>
                   <a:srgbClr val="222222"/>
                 </a:solidFill>
               </a:rPr>
               <a:t>0.96</a:t>
             </a:r>
-          </a:p>
-          <a:p>
-            <a:pPr algn="l">
-              <a:spcAft>
-                <a:spcPts val="1200"/>
-              </a:spcAft>
-            </a:pPr>
             <a:r>
-              <a:rPr sz="1400" b="0">
+              <a:rPr sz="1300" b="0">
                 <a:solidFill>
                   <a:srgbClr val="222222"/>
                 </a:solidFill>
               </a:rPr>
-              <a:t>• one-day σ (fix) </a:t>
+              <a:t> · one-day σ (fix) </a:t>
             </a:r>
             <a:r>
-              <a:rPr sz="1400" b="1">
+              <a:rPr sz="1300" b="1">
                 <a:solidFill>
                   <a:srgbClr val="222222"/>
                 </a:solidFill>
@@ -44768,6 +44199,68 @@
                 </a:solidFill>
               </a:rPr>
               <a:t>• When volatility changes, the paper's VPIN stops measuring informed trading.</a:t>
+            </a:r>
+          </a:p>
+        </p:txBody>
+      </p:sp>
+      <p:pic>
+        <p:nvPicPr>
+          <p:cNvPr id="8" name="Picture 7" descr="example_V.png"/>
+          <p:cNvPicPr>
+            <a:picLocks noChangeAspect="1"/>
+          </p:cNvPicPr>
+          <p:nvPr/>
+        </p:nvPicPr>
+        <p:blipFill>
+          <a:blip r:embed="rId3"/>
+          <a:stretch>
+            <a:fillRect/>
+          </a:stretch>
+        </p:blipFill>
+        <p:spPr>
+          <a:xfrm>
+            <a:off x="6720840" y="3628252"/>
+            <a:ext cx="5257800" cy="2116094"/>
+          </a:xfrm>
+          <a:prstGeom prst="rect">
+            <a:avLst/>
+          </a:prstGeom>
+        </p:spPr>
+      </p:pic>
+      <p:sp>
+        <p:nvSpPr>
+          <p:cNvPr id="9" name="TextBox 8"/>
+          <p:cNvSpPr txBox="1"/>
+          <p:nvPr/>
+        </p:nvSpPr>
+        <p:spPr>
+          <a:xfrm>
+            <a:off x="6720840" y="5989320"/>
+            <a:ext cx="5257800" cy="548640"/>
+          </a:xfrm>
+          <a:prstGeom prst="rect">
+            <a:avLst/>
+          </a:prstGeom>
+          <a:noFill/>
+        </p:spPr>
+        <p:txBody>
+          <a:bodyPr wrap="square" anchor="t" lIns="45720" rIns="45720">
+            <a:spAutoFit/>
+          </a:bodyPr>
+          <a:lstStyle/>
+          <a:p>
+            <a:pPr algn="l">
+              <a:spcAft>
+                <a:spcPts val="600"/>
+              </a:spcAft>
+            </a:pPr>
+            <a:r>
+              <a:rPr sz="1100" b="0">
+                <a:solidFill>
+                  <a:srgbClr val="595959"/>
+                </a:solidFill>
+              </a:rPr>
+              <a:t>World V: the paper's VPIN (blue) stays high in volatile blocks while the true informed share (dashed) falls.</a:t>
             </a:r>
           </a:p>
         </p:txBody>
@@ -44780,7 +44273,129 @@
 </p:sld>
 </file>
 
-<file path=ppt/slides/slide23.xml><?xml version="1.0" encoding="utf-8"?>
+<file path=ppt/slides/slide21.xml><?xml version="1.0" encoding="utf-8"?>
+<p:sld xmlns:a="http://schemas.openxmlformats.org/drawingml/2006/main" xmlns:p="http://schemas.openxmlformats.org/presentationml/2006/main" xmlns:r="http://schemas.openxmlformats.org/officeDocument/2006/relationships">
+  <p:cSld>
+    <p:spTree>
+      <p:nvGrpSpPr>
+        <p:cNvPr id="1" name=""/>
+        <p:cNvGrpSpPr/>
+        <p:nvPr/>
+      </p:nvGrpSpPr>
+      <p:grpSpPr/>
+      <p:sp>
+        <p:nvSpPr>
+          <p:cNvPr id="2" name="Title 1"/>
+          <p:cNvSpPr>
+            <a:spLocks noGrp="1"/>
+          </p:cNvSpPr>
+          <p:nvPr>
+            <p:ph type="title"/>
+          </p:nvPr>
+        </p:nvSpPr>
+        <p:spPr/>
+        <p:txBody>
+          <a:bodyPr/>
+          <a:lstStyle/>
+          <a:p>
+            <a:r>
+              <a:t>Backup: the known-answer test, every metric</a:t>
+            </a:r>
+          </a:p>
+        </p:txBody>
+      </p:sp>
+      <p:sp>
+        <p:nvSpPr>
+          <p:cNvPr id="4" name="Text Placeholder 3"/>
+          <p:cNvSpPr>
+            <a:spLocks noGrp="1"/>
+          </p:cNvSpPr>
+          <p:nvPr>
+            <p:ph type="body" idx="2"/>
+          </p:nvPr>
+        </p:nvSpPr>
+        <p:spPr/>
+        <p:txBody>
+          <a:bodyPr/>
+          <a:lstStyle/>
+          <a:p>
+            <a:r>
+              <a:t>Research Seminar</a:t>
+            </a:r>
+          </a:p>
+        </p:txBody>
+      </p:sp>
+      <p:pic>
+        <p:nvPicPr>
+          <p:cNvPr id="5" name="Picture 4" descr="metrics.png"/>
+          <p:cNvPicPr>
+            <a:picLocks noChangeAspect="1"/>
+          </p:cNvPicPr>
+          <p:nvPr/>
+        </p:nvPicPr>
+        <p:blipFill>
+          <a:blip r:embed="rId3"/>
+          <a:stretch>
+            <a:fillRect/>
+          </a:stretch>
+        </p:blipFill>
+        <p:spPr>
+          <a:xfrm>
+            <a:off x="365759" y="2186299"/>
+            <a:ext cx="11430000" cy="3582680"/>
+          </a:xfrm>
+          <a:prstGeom prst="rect">
+            <a:avLst/>
+          </a:prstGeom>
+        </p:spPr>
+      </p:pic>
+      <p:sp>
+        <p:nvSpPr>
+          <p:cNvPr id="6" name="TextBox 5"/>
+          <p:cNvSpPr txBox="1"/>
+          <p:nvPr/>
+        </p:nvSpPr>
+        <p:spPr>
+          <a:xfrm>
+            <a:off x="585216" y="5897880"/>
+            <a:ext cx="10972800" cy="640080"/>
+          </a:xfrm>
+          <a:prstGeom prst="rect">
+            <a:avLst/>
+          </a:prstGeom>
+          <a:noFill/>
+        </p:spPr>
+        <p:txBody>
+          <a:bodyPr wrap="square" anchor="t" lIns="45720" rIns="45720">
+            <a:spAutoFit/>
+          </a:bodyPr>
+          <a:lstStyle/>
+          <a:p>
+            <a:pPr algn="l">
+              <a:spcAft>
+                <a:spcPts val="600"/>
+              </a:spcAft>
+            </a:pPr>
+            <a:r>
+              <a:rPr sz="1200" b="0">
+                <a:solidFill>
+                  <a:srgbClr val="595959"/>
+                </a:solidFill>
+              </a:rPr>
+              <a:t>Blue: the paper's method (BVC, whole-sample σ); green: true labels; orange: BVC with one-day σ (our fix). Error bars: ± 1.96 Monte Carlo standard errors. Left: false alarms from volatility (world V). Middle: detection of toxic episodes (world T, AUC). Right: the paper's predictive test where informed trading never changes (world V).</a:t>
+            </a:r>
+          </a:p>
+        </p:txBody>
+      </p:sp>
+    </p:spTree>
+  </p:cSld>
+  <p:clrMapOvr>
+    <a:masterClrMapping/>
+  </p:clrMapOvr>
+</p:sld>
+</file>
+
+<file path=ppt/slides/slide22.xml><?xml version="1.0" encoding="utf-8"?>
 <p:sld xmlns:a="http://schemas.openxmlformats.org/drawingml/2006/main" xmlns:p="http://schemas.openxmlformats.org/presentationml/2006/main" xmlns:r="http://schemas.openxmlformats.org/officeDocument/2006/relationships">
   <p:cSld>
     <p:spTree>
@@ -45685,738 +45300,7 @@
 </p:sld>
 </file>
 
-<file path=ppt/slides/slide24.xml><?xml version="1.0" encoding="utf-8"?>
-<p:sld xmlns:a="http://schemas.openxmlformats.org/drawingml/2006/main" xmlns:p="http://schemas.openxmlformats.org/presentationml/2006/main" xmlns:r="http://schemas.openxmlformats.org/officeDocument/2006/relationships">
-  <p:cSld>
-    <p:spTree>
-      <p:nvGrpSpPr>
-        <p:cNvPr id="1" name=""/>
-        <p:cNvGrpSpPr/>
-        <p:nvPr/>
-      </p:nvGrpSpPr>
-      <p:grpSpPr/>
-      <p:sp>
-        <p:nvSpPr>
-          <p:cNvPr id="2" name="Title 1"/>
-          <p:cNvSpPr>
-            <a:spLocks noGrp="1"/>
-          </p:cNvSpPr>
-          <p:nvPr>
-            <p:ph type="title"/>
-          </p:nvPr>
-        </p:nvSpPr>
-        <p:spPr/>
-        <p:txBody>
-          <a:bodyPr/>
-          <a:lstStyle/>
-          <a:p>
-            <a:r>
-              <a:t>Inference: placebo, stability, power and every test</a:t>
-            </a:r>
-          </a:p>
-        </p:txBody>
-      </p:sp>
-      <p:sp>
-        <p:nvSpPr>
-          <p:cNvPr id="4" name="Text Placeholder 3"/>
-          <p:cNvSpPr>
-            <a:spLocks noGrp="1"/>
-          </p:cNvSpPr>
-          <p:nvPr>
-            <p:ph type="body" idx="2"/>
-          </p:nvPr>
-        </p:nvSpPr>
-        <p:spPr/>
-        <p:txBody>
-          <a:bodyPr/>
-          <a:lstStyle/>
-          <a:p>
-            <a:r>
-              <a:t>Research Seminar</a:t>
-            </a:r>
-          </a:p>
-        </p:txBody>
-      </p:sp>
-      <p:sp>
-        <p:nvSpPr>
-          <p:cNvPr id="5" name="TextBox 4"/>
-          <p:cNvSpPr txBox="1"/>
-          <p:nvPr/>
-        </p:nvSpPr>
-        <p:spPr>
-          <a:xfrm>
-            <a:off x="585216" y="2103120"/>
-            <a:ext cx="7315200" cy="365760"/>
-          </a:xfrm>
-          <a:prstGeom prst="rect">
-            <a:avLst/>
-          </a:prstGeom>
-          <a:noFill/>
-        </p:spPr>
-        <p:txBody>
-          <a:bodyPr wrap="square" anchor="t" lIns="45720" rIns="45720">
-            <a:spAutoFit/>
-          </a:bodyPr>
-          <a:lstStyle/>
-          <a:p>
-            <a:pPr algn="l">
-              <a:spcAft>
-                <a:spcPts val="600"/>
-              </a:spcAft>
-            </a:pPr>
-            <a:r>
-              <a:rPr sz="1400" b="1">
-                <a:solidFill>
-                  <a:srgbClr val="0F2C68"/>
-                </a:solidFill>
-              </a:rPr>
-              <a:t>Placebo: VPIN with the direction of every imbalance shuffled</a:t>
-            </a:r>
-          </a:p>
-        </p:txBody>
-      </p:sp>
-      <p:graphicFrame>
-        <p:nvGraphicFramePr>
-          <p:cNvPr id="6" name="Table 5"/>
-          <p:cNvGraphicFramePr>
-            <a:graphicFrameLocks noGrp="1"/>
-          </p:cNvGraphicFramePr>
-          <p:nvPr/>
-        </p:nvGraphicFramePr>
-        <p:xfrm>
-          <a:off x="585216" y="2514600"/>
-          <a:ext cx="7315200" cy="1463040"/>
-        </p:xfrm>
-        <a:graphic>
-          <a:graphicData uri="http://schemas.openxmlformats.org/drawingml/2006/table">
-            <a:tbl>
-              <a:tblPr firstRow="1" bandRow="1">
-                <a:tableStyleId>{5C22544A-7EE6-4342-B048-85BDC9FD1C3A}</a:tableStyleId>
-              </a:tblPr>
-              <a:tblGrid>
-                <a:gridCol w="3291840"/>
-                <a:gridCol w="1280160"/>
-                <a:gridCol w="1828800"/>
-                <a:gridCol w="914400"/>
-              </a:tblGrid>
-              <a:tr h="365760">
-                <a:tc>
-                  <a:txBody>
-                    <a:bodyPr/>
-                    <a:lstStyle/>
-                    <a:p>
-                      <a:r>
-                        <a:rPr sz="1100" b="1">
-                          <a:solidFill>
-                            <a:srgbClr val="FFFFFF"/>
-                          </a:solidFill>
-                        </a:rPr>
-                        <a:t>Sample</a:t>
-                      </a:r>
-                    </a:p>
-                  </a:txBody>
-                  <a:tcPr marL="54864" marR="54864" marT="27432" marB="27432" anchor="ctr">
-                    <a:solidFill>
-                      <a:srgbClr val="0F2C68"/>
-                    </a:solidFill>
-                  </a:tcPr>
-                </a:tc>
-                <a:tc>
-                  <a:txBody>
-                    <a:bodyPr/>
-                    <a:lstStyle/>
-                    <a:p>
-                      <a:r>
-                        <a:rPr sz="1100" b="1">
-                          <a:solidFill>
-                            <a:srgbClr val="FFFFFF"/>
-                          </a:solidFill>
-                        </a:rPr>
-                        <a:t>Corr, real VPIN</a:t>
-                      </a:r>
-                    </a:p>
-                  </a:txBody>
-                  <a:tcPr marL="54864" marR="54864" marT="27432" marB="27432" anchor="ctr">
-                    <a:solidFill>
-                      <a:srgbClr val="0F2C68"/>
-                    </a:solidFill>
-                  </a:tcPr>
-                </a:tc>
-                <a:tc>
-                  <a:txBody>
-                    <a:bodyPr/>
-                    <a:lstStyle/>
-                    <a:p>
-                      <a:r>
-                        <a:rPr sz="1100" b="1">
-                          <a:solidFill>
-                            <a:srgbClr val="FFFFFF"/>
-                          </a:solidFill>
-                        </a:rPr>
-                        <a:t>Corr, direction shuffled</a:t>
-                      </a:r>
-                    </a:p>
-                  </a:txBody>
-                  <a:tcPr marL="54864" marR="54864" marT="27432" marB="27432" anchor="ctr">
-                    <a:solidFill>
-                      <a:srgbClr val="0F2C68"/>
-                    </a:solidFill>
-                  </a:tcPr>
-                </a:tc>
-                <a:tc>
-                  <a:txBody>
-                    <a:bodyPr/>
-                    <a:lstStyle/>
-                    <a:p>
-                      <a:r>
-                        <a:rPr sz="1100" b="1">
-                          <a:solidFill>
-                            <a:srgbClr val="FFFFFF"/>
-                          </a:solidFill>
-                        </a:rPr>
-                        <a:t>Kept</a:t>
-                      </a:r>
-                    </a:p>
-                  </a:txBody>
-                  <a:tcPr marL="54864" marR="54864" marT="27432" marB="27432" anchor="ctr">
-                    <a:solidFill>
-                      <a:srgbClr val="0F2C68"/>
-                    </a:solidFill>
-                  </a:tcPr>
-                </a:tc>
-              </a:tr>
-              <a:tr h="365760">
-                <a:tc>
-                  <a:txBody>
-                    <a:bodyPr/>
-                    <a:lstStyle/>
-                    <a:p>
-                      <a:r>
-                        <a:rPr sz="1100" b="0">
-                          <a:solidFill>
-                            <a:srgbClr val="222222"/>
-                          </a:solidFill>
-                        </a:rPr>
-                        <a:t>IVE 2009-11, paper's method (50, 250)</a:t>
-                      </a:r>
-                    </a:p>
-                  </a:txBody>
-                  <a:tcPr marL="54864" marR="54864" marT="27432" marB="27432" anchor="ctr">
-                    <a:solidFill>
-                      <a:srgbClr val="FFFFFF"/>
-                    </a:solidFill>
-                  </a:tcPr>
-                </a:tc>
-                <a:tc>
-                  <a:txBody>
-                    <a:bodyPr/>
-                    <a:lstStyle/>
-                    <a:p>
-                      <a:r>
-                        <a:rPr sz="1100" b="0">
-                          <a:solidFill>
-                            <a:srgbClr val="222222"/>
-                          </a:solidFill>
-                        </a:rPr>
-                        <a:t>0.078</a:t>
-                      </a:r>
-                    </a:p>
-                  </a:txBody>
-                  <a:tcPr marL="54864" marR="54864" marT="27432" marB="27432" anchor="ctr">
-                    <a:solidFill>
-                      <a:srgbClr val="FFFFFF"/>
-                    </a:solidFill>
-                  </a:tcPr>
-                </a:tc>
-                <a:tc>
-                  <a:txBody>
-                    <a:bodyPr/>
-                    <a:lstStyle/>
-                    <a:p>
-                      <a:r>
-                        <a:rPr sz="1100" b="0">
-                          <a:solidFill>
-                            <a:srgbClr val="222222"/>
-                          </a:solidFill>
-                        </a:rPr>
-                        <a:t>0.078 ± 0.002</a:t>
-                      </a:r>
-                    </a:p>
-                  </a:txBody>
-                  <a:tcPr marL="54864" marR="54864" marT="27432" marB="27432" anchor="ctr">
-                    <a:solidFill>
-                      <a:srgbClr val="FFFFFF"/>
-                    </a:solidFill>
-                  </a:tcPr>
-                </a:tc>
-                <a:tc>
-                  <a:txBody>
-                    <a:bodyPr/>
-                    <a:lstStyle/>
-                    <a:p>
-                      <a:r>
-                        <a:rPr sz="1100" b="0">
-                          <a:solidFill>
-                            <a:srgbClr val="222222"/>
-                          </a:solidFill>
-                        </a:rPr>
-                        <a:t>101%</a:t>
-                      </a:r>
-                    </a:p>
-                  </a:txBody>
-                  <a:tcPr marL="54864" marR="54864" marT="27432" marB="27432" anchor="ctr">
-                    <a:solidFill>
-                      <a:srgbClr val="FFFFFF"/>
-                    </a:solidFill>
-                  </a:tcPr>
-                </a:tc>
-              </a:tr>
-              <a:tr h="365760">
-                <a:tc>
-                  <a:txBody>
-                    <a:bodyPr/>
-                    <a:lstStyle/>
-                    <a:p>
-                      <a:r>
-                        <a:rPr sz="1100" b="0">
-                          <a:solidFill>
-                            <a:srgbClr val="222222"/>
-                          </a:solidFill>
-                        </a:rPr>
-                        <a:t>IVE 2011-26 (50, 250)</a:t>
-                      </a:r>
-                    </a:p>
-                  </a:txBody>
-                  <a:tcPr marL="54864" marR="54864" marT="27432" marB="27432" anchor="ctr">
-                    <a:solidFill>
-                      <a:srgbClr val="EEF2F8"/>
-                    </a:solidFill>
-                  </a:tcPr>
-                </a:tc>
-                <a:tc>
-                  <a:txBody>
-                    <a:bodyPr/>
-                    <a:lstStyle/>
-                    <a:p>
-                      <a:r>
-                        <a:rPr sz="1100" b="0">
-                          <a:solidFill>
-                            <a:srgbClr val="222222"/>
-                          </a:solidFill>
-                        </a:rPr>
-                        <a:t>0.092</a:t>
-                      </a:r>
-                    </a:p>
-                  </a:txBody>
-                  <a:tcPr marL="54864" marR="54864" marT="27432" marB="27432" anchor="ctr">
-                    <a:solidFill>
-                      <a:srgbClr val="EEF2F8"/>
-                    </a:solidFill>
-                  </a:tcPr>
-                </a:tc>
-                <a:tc>
-                  <a:txBody>
-                    <a:bodyPr/>
-                    <a:lstStyle/>
-                    <a:p>
-                      <a:r>
-                        <a:rPr sz="1100" b="0">
-                          <a:solidFill>
-                            <a:srgbClr val="222222"/>
-                          </a:solidFill>
-                        </a:rPr>
-                        <a:t>0.090 ± 0.001</a:t>
-                      </a:r>
-                    </a:p>
-                  </a:txBody>
-                  <a:tcPr marL="54864" marR="54864" marT="27432" marB="27432" anchor="ctr">
-                    <a:solidFill>
-                      <a:srgbClr val="EEF2F8"/>
-                    </a:solidFill>
-                  </a:tcPr>
-                </a:tc>
-                <a:tc>
-                  <a:txBody>
-                    <a:bodyPr/>
-                    <a:lstStyle/>
-                    <a:p>
-                      <a:r>
-                        <a:rPr sz="1100" b="0">
-                          <a:solidFill>
-                            <a:srgbClr val="222222"/>
-                          </a:solidFill>
-                        </a:rPr>
-                        <a:t>98%</a:t>
-                      </a:r>
-                    </a:p>
-                  </a:txBody>
-                  <a:tcPr marL="54864" marR="54864" marT="27432" marB="27432" anchor="ctr">
-                    <a:solidFill>
-                      <a:srgbClr val="EEF2F8"/>
-                    </a:solidFill>
-                  </a:tcPr>
-                </a:tc>
-              </a:tr>
-              <a:tr h="365760">
-                <a:tc>
-                  <a:txBody>
-                    <a:bodyPr/>
-                    <a:lstStyle/>
-                    <a:p>
-                      <a:r>
-                        <a:rPr sz="1100" b="0">
-                          <a:solidFill>
-                            <a:srgbClr val="222222"/>
-                          </a:solidFill>
-                        </a:rPr>
-                        <a:t>BTC 2020-26 (50, 50)</a:t>
-                      </a:r>
-                    </a:p>
-                  </a:txBody>
-                  <a:tcPr marL="54864" marR="54864" marT="27432" marB="27432" anchor="ctr">
-                    <a:solidFill>
-                      <a:srgbClr val="FFFFFF"/>
-                    </a:solidFill>
-                  </a:tcPr>
-                </a:tc>
-                <a:tc>
-                  <a:txBody>
-                    <a:bodyPr/>
-                    <a:lstStyle/>
-                    <a:p>
-                      <a:r>
-                        <a:rPr sz="1100" b="0">
-                          <a:solidFill>
-                            <a:srgbClr val="222222"/>
-                          </a:solidFill>
-                        </a:rPr>
-                        <a:t>0.127</a:t>
-                      </a:r>
-                    </a:p>
-                  </a:txBody>
-                  <a:tcPr marL="54864" marR="54864" marT="27432" marB="27432" anchor="ctr">
-                    <a:solidFill>
-                      <a:srgbClr val="FFFFFF"/>
-                    </a:solidFill>
-                  </a:tcPr>
-                </a:tc>
-                <a:tc>
-                  <a:txBody>
-                    <a:bodyPr/>
-                    <a:lstStyle/>
-                    <a:p>
-                      <a:r>
-                        <a:rPr sz="1100" b="0">
-                          <a:solidFill>
-                            <a:srgbClr val="222222"/>
-                          </a:solidFill>
-                        </a:rPr>
-                        <a:t>0.128 ± 0.001</a:t>
-                      </a:r>
-                    </a:p>
-                  </a:txBody>
-                  <a:tcPr marL="54864" marR="54864" marT="27432" marB="27432" anchor="ctr">
-                    <a:solidFill>
-                      <a:srgbClr val="FFFFFF"/>
-                    </a:solidFill>
-                  </a:tcPr>
-                </a:tc>
-                <a:tc>
-                  <a:txBody>
-                    <a:bodyPr/>
-                    <a:lstStyle/>
-                    <a:p>
-                      <a:r>
-                        <a:rPr sz="1100" b="0">
-                          <a:solidFill>
-                            <a:srgbClr val="222222"/>
-                          </a:solidFill>
-                        </a:rPr>
-                        <a:t>101%</a:t>
-                      </a:r>
-                    </a:p>
-                  </a:txBody>
-                  <a:tcPr marL="54864" marR="54864" marT="27432" marB="27432" anchor="ctr">
-                    <a:solidFill>
-                      <a:srgbClr val="FFFFFF"/>
-                    </a:solidFill>
-                  </a:tcPr>
-                </a:tc>
-              </a:tr>
-            </a:tbl>
-          </a:graphicData>
-        </a:graphic>
-      </p:graphicFrame>
-      <p:sp>
-        <p:nvSpPr>
-          <p:cNvPr id="7" name="TextBox 6"/>
-          <p:cNvSpPr txBox="1"/>
-          <p:nvPr/>
-        </p:nvSpPr>
-        <p:spPr>
-          <a:xfrm>
-            <a:off x="585216" y="4206240"/>
-            <a:ext cx="7315200" cy="2194560"/>
-          </a:xfrm>
-          <a:prstGeom prst="rect">
-            <a:avLst/>
-          </a:prstGeom>
-          <a:noFill/>
-        </p:spPr>
-        <p:txBody>
-          <a:bodyPr wrap="square" anchor="t" lIns="45720" rIns="45720">
-            <a:spAutoFit/>
-          </a:bodyPr>
-          <a:lstStyle/>
-          <a:p>
-            <a:pPr algn="l">
-              <a:spcAft>
-                <a:spcPts val="600"/>
-              </a:spcAft>
-            </a:pPr>
-            <a:r>
-              <a:rPr sz="1300" b="0">
-                <a:solidFill>
-                  <a:srgbClr val="222222"/>
-                </a:solidFill>
-              </a:rPr>
-              <a:t>• </a:t>
-            </a:r>
-            <a:r>
-              <a:rPr sz="1300" b="1">
-                <a:solidFill>
-                  <a:srgbClr val="222222"/>
-                </a:solidFill>
-              </a:rPr>
-              <a:t>The direction of trading carries almost none of VPIN's predictive power:</a:t>
-            </a:r>
-            <a:r>
-              <a:rPr sz="1300" b="0">
-                <a:solidFill>
-                  <a:srgbClr val="222222"/>
-                </a:solidFill>
-              </a:rPr>
-              <a:t> the size of price moves does.</a:t>
-            </a:r>
-          </a:p>
-          <a:p>
-            <a:pPr algn="l">
-              <a:spcAft>
-                <a:spcPts val="600"/>
-              </a:spcAft>
-            </a:pPr>
-            <a:r>
-              <a:rPr sz="1300" b="0">
-                <a:solidFill>
-                  <a:srgbClr val="222222"/>
-                </a:solidFill>
-              </a:rPr>
-              <a:t>• </a:t>
-            </a:r>
-            <a:r>
-              <a:rPr sz="1300" b="1">
-                <a:solidFill>
-                  <a:srgbClr val="222222"/>
-                </a:solidFill>
-              </a:rPr>
-              <a:t>Leave one year out:</a:t>
-            </a:r>
-            <a:r>
-              <a:rPr sz="1300" b="0">
-                <a:solidFill>
-                  <a:srgbClr val="222222"/>
-                </a:solidFill>
-              </a:rPr>
-              <a:t> 0 sign flips across 5 signal–sample pairs.</a:t>
-            </a:r>
-          </a:p>
-          <a:p>
-            <a:pPr algn="l">
-              <a:spcAft>
-                <a:spcPts val="600"/>
-              </a:spcAft>
-            </a:pPr>
-            <a:r>
-              <a:rPr sz="1300" b="0">
-                <a:solidFill>
-                  <a:srgbClr val="222222"/>
-                </a:solidFill>
-              </a:rPr>
-              <a:t>• </a:t>
-            </a:r>
-            <a:r>
-              <a:rPr sz="1300" b="1">
-                <a:solidFill>
-                  <a:srgbClr val="222222"/>
-                </a:solidFill>
-              </a:rPr>
-              <a:t>Power:</a:t>
-            </a:r>
-            <a:r>
-              <a:rPr sz="1300" b="0">
-                <a:solidFill>
-                  <a:srgbClr val="222222"/>
-                </a:solidFill>
-              </a:rPr>
-              <a:t> the reproduction detects any correlation ≥ 0.13; the paper's 0.40 would not be missed.</a:t>
-            </a:r>
-          </a:p>
-        </p:txBody>
-      </p:sp>
-      <p:sp>
-        <p:nvSpPr>
-          <p:cNvPr id="8" name="TextBox 7"/>
-          <p:cNvSpPr txBox="1"/>
-          <p:nvPr/>
-        </p:nvSpPr>
-        <p:spPr>
-          <a:xfrm>
-            <a:off x="8138160" y="2103120"/>
-            <a:ext cx="3840480" cy="4297680"/>
-          </a:xfrm>
-          <a:prstGeom prst="rect">
-            <a:avLst/>
-          </a:prstGeom>
-          <a:noFill/>
-        </p:spPr>
-        <p:txBody>
-          <a:bodyPr wrap="square" anchor="t" lIns="45720" rIns="45720">
-            <a:spAutoFit/>
-          </a:bodyPr>
-          <a:lstStyle/>
-          <a:p>
-            <a:pPr algn="l">
-              <a:spcAft>
-                <a:spcPts val="500"/>
-              </a:spcAft>
-            </a:pPr>
-            <a:r>
-              <a:rPr sz="1400" b="1">
-                <a:solidFill>
-                  <a:srgbClr val="0F2C68"/>
-                </a:solidFill>
-              </a:rPr>
-              <a:t>Ledger of every test</a:t>
-            </a:r>
-          </a:p>
-          <a:p>
-            <a:pPr algn="l">
-              <a:spcAft>
-                <a:spcPts val="500"/>
-              </a:spcAft>
-            </a:pPr>
-            <a:r>
-              <a:rPr sz="1300" b="0">
-                <a:solidFill>
-                  <a:srgbClr val="222222"/>
-                </a:solidFill>
-              </a:rPr>
-              <a:t>• 26 tests behind our claims</a:t>
-            </a:r>
-          </a:p>
-          <a:p>
-            <a:pPr algn="l">
-              <a:spcAft>
-                <a:spcPts val="500"/>
-              </a:spcAft>
-            </a:pPr>
-            <a:r>
-              <a:rPr sz="1300" b="0">
-                <a:solidFill>
-                  <a:srgbClr val="222222"/>
-                </a:solidFill>
-              </a:rPr>
-              <a:t>• supported after Benjamini–Hochberg: </a:t>
-            </a:r>
-            <a:r>
-              <a:rPr sz="1300" b="1">
-                <a:solidFill>
-                  <a:srgbClr val="222222"/>
-                </a:solidFill>
-              </a:rPr>
-              <a:t>17</a:t>
-            </a:r>
-          </a:p>
-          <a:p>
-            <a:pPr algn="l">
-              <a:spcAft>
-                <a:spcPts val="500"/>
-              </a:spcAft>
-            </a:pPr>
-            <a:r>
-              <a:rPr sz="1300" b="0">
-                <a:solidFill>
-                  <a:srgbClr val="222222"/>
-                </a:solidFill>
-              </a:rPr>
-              <a:t>• after Bonferroni: </a:t>
-            </a:r>
-            <a:r>
-              <a:rPr sz="1300" b="1">
-                <a:solidFill>
-                  <a:srgbClr val="222222"/>
-                </a:solidFill>
-              </a:rPr>
-              <a:t>13</a:t>
-            </a:r>
-          </a:p>
-          <a:p>
-            <a:pPr algn="l">
-              <a:spcAft>
-                <a:spcPts val="500"/>
-              </a:spcAft>
-            </a:pPr>
-            <a:r>
-              <a:rPr sz="1300" b="0">
-                <a:solidFill>
-                  <a:srgbClr val="222222"/>
-                </a:solidFill>
-              </a:rPr>
-              <a:t>• significant but on the wrong side: </a:t>
-            </a:r>
-            <a:r>
-              <a:rPr sz="1300" b="1">
-                <a:solidFill>
-                  <a:srgbClr val="222222"/>
-                </a:solidFill>
-              </a:rPr>
-              <a:t>3</a:t>
-            </a:r>
-            <a:r>
-              <a:rPr sz="1300" b="0">
-                <a:solidFill>
-                  <a:srgbClr val="222222"/>
-                </a:solidFill>
-              </a:rPr>
-              <a:t> (reported as not supported)</a:t>
-            </a:r>
-          </a:p>
-          <a:p>
-            <a:pPr algn="l">
-              <a:spcAft>
-                <a:spcPts val="500"/>
-              </a:spcAft>
-            </a:pPr>
-            <a:r>
-              <a:rPr sz="1200" b="0">
-                <a:solidFill>
-                  <a:srgbClr val="595959"/>
-                </a:solidFill>
-              </a:rPr>
-              <a:t>• New tests pre-registered before running; every later change logged.</a:t>
-            </a:r>
-          </a:p>
-        </p:txBody>
-      </p:sp>
-    </p:spTree>
-  </p:cSld>
-  <p:clrMapOvr>
-    <a:masterClrMapping/>
-  </p:clrMapOvr>
-</p:sld>
-</file>
-
-<file path=ppt/slides/slide25.xml><?xml version="1.0" encoding="utf-8"?>
+<file path=ppt/slides/slide23.xml><?xml version="1.0" encoding="utf-8"?>
 <p:sld xmlns:a="http://schemas.openxmlformats.org/drawingml/2006/main" xmlns:p="http://schemas.openxmlformats.org/presentationml/2006/main" xmlns:r="http://schemas.openxmlformats.org/officeDocument/2006/relationships">
   <p:cSld>
     <p:spTree>
@@ -46477,7 +45361,7 @@
         <p:spPr>
           <a:xfrm>
             <a:off x="585216" y="2148840"/>
-            <a:ext cx="11155680" cy="4297680"/>
+            <a:ext cx="6675120" cy="4343400"/>
           </a:xfrm>
           <a:prstGeom prst="rect">
             <a:avLst/>
@@ -46492,11 +45376,11 @@
           <a:p>
             <a:pPr algn="l">
               <a:spcAft>
-                <a:spcPts val="1000"/>
+                <a:spcPts val="700"/>
               </a:spcAft>
             </a:pPr>
             <a:r>
-              <a:rPr sz="1500" b="0">
+              <a:rPr sz="1300" b="0">
                 <a:solidFill>
                   <a:srgbClr val="222222"/>
                 </a:solidFill>
@@ -46504,7 +45388,7 @@
               <a:t>• </a:t>
             </a:r>
             <a:r>
-              <a:rPr sz="1500" b="1">
+              <a:rPr sz="1300" b="1">
                 <a:solidFill>
                   <a:srgbClr val="222222"/>
                 </a:solidFill>
@@ -46512,7 +45396,7 @@
               <a:t>1. Closes the paper's validation gap.</a:t>
             </a:r>
             <a:r>
-              <a:rPr sz="1500" b="0">
+              <a:rPr sz="1300" b="0">
                 <a:solidFill>
                   <a:srgbClr val="222222"/>
                 </a:solidFill>
@@ -46523,11 +45407,11 @@
           <a:p>
             <a:pPr algn="l">
               <a:spcAft>
-                <a:spcPts val="1000"/>
+                <a:spcPts val="700"/>
               </a:spcAft>
             </a:pPr>
             <a:r>
-              <a:rPr sz="1500" b="0">
+              <a:rPr sz="1300" b="0">
                 <a:solidFill>
                   <a:srgbClr val="222222"/>
                 </a:solidFill>
@@ -46535,7 +45419,7 @@
               <a:t>• </a:t>
             </a:r>
             <a:r>
-              <a:rPr sz="1500" b="1">
+              <a:rPr sz="1300" b="1">
                 <a:solidFill>
                   <a:srgbClr val="222222"/>
                 </a:solidFill>
@@ -46543,7 +45427,7 @@
               <a:t>2. Locates where VPIN's predictive power comes from.</a:t>
             </a:r>
             <a:r>
-              <a:rPr sz="1500" b="0">
+              <a:rPr sz="1300" b="0">
                 <a:solidFill>
                   <a:srgbClr val="222222"/>
                 </a:solidFill>
@@ -46554,11 +45438,11 @@
           <a:p>
             <a:pPr algn="l">
               <a:spcAft>
-                <a:spcPts val="1000"/>
+                <a:spcPts val="700"/>
               </a:spcAft>
             </a:pPr>
             <a:r>
-              <a:rPr sz="1500" b="0">
+              <a:rPr sz="1300" b="0">
                 <a:solidFill>
                   <a:srgbClr val="222222"/>
                 </a:solidFill>
@@ -46566,7 +45450,7 @@
               <a:t>• </a:t>
             </a:r>
             <a:r>
-              <a:rPr sz="1500" b="1">
+              <a:rPr sz="1300" b="1">
                 <a:solidFill>
                   <a:srgbClr val="222222"/>
                 </a:solidFill>
@@ -46574,7 +45458,7 @@
               <a:t>3. A fix that works where it can be checked.</a:t>
             </a:r>
             <a:r>
-              <a:rPr sz="1500" b="0">
+              <a:rPr sz="1300" b="0">
                 <a:solidFill>
                   <a:srgbClr val="222222"/>
                 </a:solidFill>
@@ -46585,11 +45469,11 @@
           <a:p>
             <a:pPr algn="l">
               <a:spcAft>
-                <a:spcPts val="1000"/>
+                <a:spcPts val="700"/>
               </a:spcAft>
             </a:pPr>
             <a:r>
-              <a:rPr sz="1500" b="0">
+              <a:rPr sz="1300" b="0">
                 <a:solidFill>
                   <a:srgbClr val="222222"/>
                 </a:solidFill>
@@ -46597,7 +45481,7 @@
               <a:t>• </a:t>
             </a:r>
             <a:r>
-              <a:rPr sz="1500" b="1">
+              <a:rPr sz="1300" b="1">
                 <a:solidFill>
                   <a:srgbClr val="222222"/>
                 </a:solidFill>
@@ -46605,7 +45489,7 @@
               <a:t>4. An honest evaluation.</a:t>
             </a:r>
             <a:r>
-              <a:rPr sz="1500" b="0">
+              <a:rPr sz="1300" b="0">
                 <a:solidFill>
                   <a:srgbClr val="222222"/>
                 </a:solidFill>
@@ -46616,16 +45500,636 @@
           <a:p>
             <a:pPr algn="l">
               <a:spcAft>
-                <a:spcPts val="1000"/>
+                <a:spcPts val="700"/>
+              </a:spcAft>
+            </a:pPr>
+            <a:r>
+              <a:rPr sz="1100" b="0">
+                <a:solidFill>
+                  <a:srgbClr val="595959"/>
+                </a:solidFill>
+              </a:rPr>
+              <a:t>Confirms on new data: Andersen &amp; Bondarenko (2014, 2015); Chakrabarty, Pascual &amp; Shkilko (2015).</a:t>
+            </a:r>
+          </a:p>
+        </p:txBody>
+      </p:sp>
+      <p:sp>
+        <p:nvSpPr>
+          <p:cNvPr id="6" name="TextBox 5"/>
+          <p:cNvSpPr txBox="1"/>
+          <p:nvPr/>
+        </p:nvSpPr>
+        <p:spPr>
+          <a:xfrm>
+            <a:off x="7498079" y="2103120"/>
+            <a:ext cx="4480560" cy="365760"/>
+          </a:xfrm>
+          <a:prstGeom prst="rect">
+            <a:avLst/>
+          </a:prstGeom>
+          <a:noFill/>
+        </p:spPr>
+        <p:txBody>
+          <a:bodyPr wrap="square" anchor="t" lIns="45720" rIns="45720">
+            <a:spAutoFit/>
+          </a:bodyPr>
+          <a:lstStyle/>
+          <a:p>
+            <a:pPr algn="l">
+              <a:spcAft>
+                <a:spcPts val="600"/>
+              </a:spcAft>
+            </a:pPr>
+            <a:r>
+              <a:rPr sz="1300" b="1">
+                <a:solidFill>
+                  <a:srgbClr val="0F2C68"/>
+                </a:solidFill>
+              </a:rPr>
+              <a:t>Placebo: direction of every imbalance shuffled</a:t>
+            </a:r>
+          </a:p>
+        </p:txBody>
+      </p:sp>
+      <p:graphicFrame>
+        <p:nvGraphicFramePr>
+          <p:cNvPr id="7" name="Table 6"/>
+          <p:cNvGraphicFramePr>
+            <a:graphicFrameLocks noGrp="1"/>
+          </p:cNvGraphicFramePr>
+          <p:nvPr/>
+        </p:nvGraphicFramePr>
+        <p:xfrm>
+          <a:off x="7498079" y="2468880"/>
+          <a:ext cx="4480560" cy="1188720"/>
+        </p:xfrm>
+        <a:graphic>
+          <a:graphicData uri="http://schemas.openxmlformats.org/drawingml/2006/table">
+            <a:tbl>
+              <a:tblPr firstRow="1" bandRow="1">
+                <a:tableStyleId>{5C22544A-7EE6-4342-B048-85BDC9FD1C3A}</a:tableStyleId>
+              </a:tblPr>
+              <a:tblGrid>
+                <a:gridCol w="1600200"/>
+                <a:gridCol w="777240"/>
+                <a:gridCol w="1463040"/>
+                <a:gridCol w="640080"/>
+              </a:tblGrid>
+              <a:tr h="297180">
+                <a:tc>
+                  <a:txBody>
+                    <a:bodyPr/>
+                    <a:lstStyle/>
+                    <a:p>
+                      <a:r>
+                        <a:rPr sz="1000" b="1">
+                          <a:solidFill>
+                            <a:srgbClr val="FFFFFF"/>
+                          </a:solidFill>
+                        </a:rPr>
+                        <a:t>Sample</a:t>
+                      </a:r>
+                    </a:p>
+                  </a:txBody>
+                  <a:tcPr marL="54864" marR="54864" marT="27432" marB="27432" anchor="ctr">
+                    <a:solidFill>
+                      <a:srgbClr val="0F2C68"/>
+                    </a:solidFill>
+                  </a:tcPr>
+                </a:tc>
+                <a:tc>
+                  <a:txBody>
+                    <a:bodyPr/>
+                    <a:lstStyle/>
+                    <a:p>
+                      <a:r>
+                        <a:rPr sz="1000" b="1">
+                          <a:solidFill>
+                            <a:srgbClr val="FFFFFF"/>
+                          </a:solidFill>
+                        </a:rPr>
+                        <a:t>Corr, real VPIN</a:t>
+                      </a:r>
+                    </a:p>
+                  </a:txBody>
+                  <a:tcPr marL="54864" marR="54864" marT="27432" marB="27432" anchor="ctr">
+                    <a:solidFill>
+                      <a:srgbClr val="0F2C68"/>
+                    </a:solidFill>
+                  </a:tcPr>
+                </a:tc>
+                <a:tc>
+                  <a:txBody>
+                    <a:bodyPr/>
+                    <a:lstStyle/>
+                    <a:p>
+                      <a:r>
+                        <a:rPr sz="1000" b="1">
+                          <a:solidFill>
+                            <a:srgbClr val="FFFFFF"/>
+                          </a:solidFill>
+                        </a:rPr>
+                        <a:t>Corr, direction shuffled</a:t>
+                      </a:r>
+                    </a:p>
+                  </a:txBody>
+                  <a:tcPr marL="54864" marR="54864" marT="27432" marB="27432" anchor="ctr">
+                    <a:solidFill>
+                      <a:srgbClr val="0F2C68"/>
+                    </a:solidFill>
+                  </a:tcPr>
+                </a:tc>
+                <a:tc>
+                  <a:txBody>
+                    <a:bodyPr/>
+                    <a:lstStyle/>
+                    <a:p>
+                      <a:r>
+                        <a:rPr sz="1000" b="1">
+                          <a:solidFill>
+                            <a:srgbClr val="FFFFFF"/>
+                          </a:solidFill>
+                        </a:rPr>
+                        <a:t>Kept</a:t>
+                      </a:r>
+                    </a:p>
+                  </a:txBody>
+                  <a:tcPr marL="54864" marR="54864" marT="27432" marB="27432" anchor="ctr">
+                    <a:solidFill>
+                      <a:srgbClr val="0F2C68"/>
+                    </a:solidFill>
+                  </a:tcPr>
+                </a:tc>
+              </a:tr>
+              <a:tr h="297180">
+                <a:tc>
+                  <a:txBody>
+                    <a:bodyPr/>
+                    <a:lstStyle/>
+                    <a:p>
+                      <a:r>
+                        <a:rPr sz="1000" b="0">
+                          <a:solidFill>
+                            <a:srgbClr val="222222"/>
+                          </a:solidFill>
+                        </a:rPr>
+                        <a:t>IVE 2009-11, paper's method (50, 250)</a:t>
+                      </a:r>
+                    </a:p>
+                  </a:txBody>
+                  <a:tcPr marL="54864" marR="54864" marT="27432" marB="27432" anchor="ctr">
+                    <a:solidFill>
+                      <a:srgbClr val="FFFFFF"/>
+                    </a:solidFill>
+                  </a:tcPr>
+                </a:tc>
+                <a:tc>
+                  <a:txBody>
+                    <a:bodyPr/>
+                    <a:lstStyle/>
+                    <a:p>
+                      <a:r>
+                        <a:rPr sz="1000" b="0">
+                          <a:solidFill>
+                            <a:srgbClr val="222222"/>
+                          </a:solidFill>
+                        </a:rPr>
+                        <a:t>0.078</a:t>
+                      </a:r>
+                    </a:p>
+                  </a:txBody>
+                  <a:tcPr marL="54864" marR="54864" marT="27432" marB="27432" anchor="ctr">
+                    <a:solidFill>
+                      <a:srgbClr val="FFFFFF"/>
+                    </a:solidFill>
+                  </a:tcPr>
+                </a:tc>
+                <a:tc>
+                  <a:txBody>
+                    <a:bodyPr/>
+                    <a:lstStyle/>
+                    <a:p>
+                      <a:r>
+                        <a:rPr sz="1000" b="0">
+                          <a:solidFill>
+                            <a:srgbClr val="222222"/>
+                          </a:solidFill>
+                        </a:rPr>
+                        <a:t>0.078 ± 0.002</a:t>
+                      </a:r>
+                    </a:p>
+                  </a:txBody>
+                  <a:tcPr marL="54864" marR="54864" marT="27432" marB="27432" anchor="ctr">
+                    <a:solidFill>
+                      <a:srgbClr val="FFFFFF"/>
+                    </a:solidFill>
+                  </a:tcPr>
+                </a:tc>
+                <a:tc>
+                  <a:txBody>
+                    <a:bodyPr/>
+                    <a:lstStyle/>
+                    <a:p>
+                      <a:r>
+                        <a:rPr sz="1000" b="0">
+                          <a:solidFill>
+                            <a:srgbClr val="222222"/>
+                          </a:solidFill>
+                        </a:rPr>
+                        <a:t>101%</a:t>
+                      </a:r>
+                    </a:p>
+                  </a:txBody>
+                  <a:tcPr marL="54864" marR="54864" marT="27432" marB="27432" anchor="ctr">
+                    <a:solidFill>
+                      <a:srgbClr val="FFFFFF"/>
+                    </a:solidFill>
+                  </a:tcPr>
+                </a:tc>
+              </a:tr>
+              <a:tr h="297180">
+                <a:tc>
+                  <a:txBody>
+                    <a:bodyPr/>
+                    <a:lstStyle/>
+                    <a:p>
+                      <a:r>
+                        <a:rPr sz="1000" b="0">
+                          <a:solidFill>
+                            <a:srgbClr val="222222"/>
+                          </a:solidFill>
+                        </a:rPr>
+                        <a:t>IVE 2011-26 (50, 250)</a:t>
+                      </a:r>
+                    </a:p>
+                  </a:txBody>
+                  <a:tcPr marL="54864" marR="54864" marT="27432" marB="27432" anchor="ctr">
+                    <a:solidFill>
+                      <a:srgbClr val="EEF2F8"/>
+                    </a:solidFill>
+                  </a:tcPr>
+                </a:tc>
+                <a:tc>
+                  <a:txBody>
+                    <a:bodyPr/>
+                    <a:lstStyle/>
+                    <a:p>
+                      <a:r>
+                        <a:rPr sz="1000" b="0">
+                          <a:solidFill>
+                            <a:srgbClr val="222222"/>
+                          </a:solidFill>
+                        </a:rPr>
+                        <a:t>0.092</a:t>
+                      </a:r>
+                    </a:p>
+                  </a:txBody>
+                  <a:tcPr marL="54864" marR="54864" marT="27432" marB="27432" anchor="ctr">
+                    <a:solidFill>
+                      <a:srgbClr val="EEF2F8"/>
+                    </a:solidFill>
+                  </a:tcPr>
+                </a:tc>
+                <a:tc>
+                  <a:txBody>
+                    <a:bodyPr/>
+                    <a:lstStyle/>
+                    <a:p>
+                      <a:r>
+                        <a:rPr sz="1000" b="0">
+                          <a:solidFill>
+                            <a:srgbClr val="222222"/>
+                          </a:solidFill>
+                        </a:rPr>
+                        <a:t>0.090 ± 0.001</a:t>
+                      </a:r>
+                    </a:p>
+                  </a:txBody>
+                  <a:tcPr marL="54864" marR="54864" marT="27432" marB="27432" anchor="ctr">
+                    <a:solidFill>
+                      <a:srgbClr val="EEF2F8"/>
+                    </a:solidFill>
+                  </a:tcPr>
+                </a:tc>
+                <a:tc>
+                  <a:txBody>
+                    <a:bodyPr/>
+                    <a:lstStyle/>
+                    <a:p>
+                      <a:r>
+                        <a:rPr sz="1000" b="0">
+                          <a:solidFill>
+                            <a:srgbClr val="222222"/>
+                          </a:solidFill>
+                        </a:rPr>
+                        <a:t>98%</a:t>
+                      </a:r>
+                    </a:p>
+                  </a:txBody>
+                  <a:tcPr marL="54864" marR="54864" marT="27432" marB="27432" anchor="ctr">
+                    <a:solidFill>
+                      <a:srgbClr val="EEF2F8"/>
+                    </a:solidFill>
+                  </a:tcPr>
+                </a:tc>
+              </a:tr>
+              <a:tr h="297180">
+                <a:tc>
+                  <a:txBody>
+                    <a:bodyPr/>
+                    <a:lstStyle/>
+                    <a:p>
+                      <a:r>
+                        <a:rPr sz="1000" b="0">
+                          <a:solidFill>
+                            <a:srgbClr val="222222"/>
+                          </a:solidFill>
+                        </a:rPr>
+                        <a:t>BTC 2020-26 (50, 50)</a:t>
+                      </a:r>
+                    </a:p>
+                  </a:txBody>
+                  <a:tcPr marL="54864" marR="54864" marT="27432" marB="27432" anchor="ctr">
+                    <a:solidFill>
+                      <a:srgbClr val="FFFFFF"/>
+                    </a:solidFill>
+                  </a:tcPr>
+                </a:tc>
+                <a:tc>
+                  <a:txBody>
+                    <a:bodyPr/>
+                    <a:lstStyle/>
+                    <a:p>
+                      <a:r>
+                        <a:rPr sz="1000" b="0">
+                          <a:solidFill>
+                            <a:srgbClr val="222222"/>
+                          </a:solidFill>
+                        </a:rPr>
+                        <a:t>0.127</a:t>
+                      </a:r>
+                    </a:p>
+                  </a:txBody>
+                  <a:tcPr marL="54864" marR="54864" marT="27432" marB="27432" anchor="ctr">
+                    <a:solidFill>
+                      <a:srgbClr val="FFFFFF"/>
+                    </a:solidFill>
+                  </a:tcPr>
+                </a:tc>
+                <a:tc>
+                  <a:txBody>
+                    <a:bodyPr/>
+                    <a:lstStyle/>
+                    <a:p>
+                      <a:r>
+                        <a:rPr sz="1000" b="0">
+                          <a:solidFill>
+                            <a:srgbClr val="222222"/>
+                          </a:solidFill>
+                        </a:rPr>
+                        <a:t>0.128 ± 0.001</a:t>
+                      </a:r>
+                    </a:p>
+                  </a:txBody>
+                  <a:tcPr marL="54864" marR="54864" marT="27432" marB="27432" anchor="ctr">
+                    <a:solidFill>
+                      <a:srgbClr val="FFFFFF"/>
+                    </a:solidFill>
+                  </a:tcPr>
+                </a:tc>
+                <a:tc>
+                  <a:txBody>
+                    <a:bodyPr/>
+                    <a:lstStyle/>
+                    <a:p>
+                      <a:r>
+                        <a:rPr sz="1000" b="0">
+                          <a:solidFill>
+                            <a:srgbClr val="222222"/>
+                          </a:solidFill>
+                        </a:rPr>
+                        <a:t>101%</a:t>
+                      </a:r>
+                    </a:p>
+                  </a:txBody>
+                  <a:tcPr marL="54864" marR="54864" marT="27432" marB="27432" anchor="ctr">
+                    <a:solidFill>
+                      <a:srgbClr val="FFFFFF"/>
+                    </a:solidFill>
+                  </a:tcPr>
+                </a:tc>
+              </a:tr>
+            </a:tbl>
+          </a:graphicData>
+        </a:graphic>
+      </p:graphicFrame>
+      <p:sp>
+        <p:nvSpPr>
+          <p:cNvPr id="8" name="TextBox 7"/>
+          <p:cNvSpPr txBox="1"/>
+          <p:nvPr/>
+        </p:nvSpPr>
+        <p:spPr>
+          <a:xfrm>
+            <a:off x="7498079" y="3931920"/>
+            <a:ext cx="4480560" cy="2560320"/>
+          </a:xfrm>
+          <a:prstGeom prst="rect">
+            <a:avLst/>
+          </a:prstGeom>
+          <a:noFill/>
+        </p:spPr>
+        <p:txBody>
+          <a:bodyPr wrap="square" anchor="t" lIns="45720" rIns="45720">
+            <a:spAutoFit/>
+          </a:bodyPr>
+          <a:lstStyle/>
+          <a:p>
+            <a:pPr algn="l">
+              <a:spcAft>
+                <a:spcPts val="400"/>
               </a:spcAft>
             </a:pPr>
             <a:r>
               <a:rPr sz="1200" b="0">
                 <a:solidFill>
+                  <a:srgbClr val="222222"/>
+                </a:solidFill>
+              </a:rPr>
+              <a:t>• </a:t>
+            </a:r>
+            <a:r>
+              <a:rPr sz="1200" b="1">
+                <a:solidFill>
+                  <a:srgbClr val="222222"/>
+                </a:solidFill>
+              </a:rPr>
+              <a:t>The direction of trading carries almost none of VPIN's predictive power:</a:t>
+            </a:r>
+            <a:r>
+              <a:rPr sz="1200" b="0">
+                <a:solidFill>
+                  <a:srgbClr val="222222"/>
+                </a:solidFill>
+              </a:rPr>
+              <a:t> the size of price moves does.</a:t>
+            </a:r>
+          </a:p>
+          <a:p>
+            <a:pPr algn="l">
+              <a:spcAft>
+                <a:spcPts val="400"/>
+              </a:spcAft>
+            </a:pPr>
+            <a:r>
+              <a:rPr sz="1200" b="0">
+                <a:solidFill>
+                  <a:srgbClr val="222222"/>
+                </a:solidFill>
+              </a:rPr>
+              <a:t>• </a:t>
+            </a:r>
+            <a:r>
+              <a:rPr sz="1200" b="1">
+                <a:solidFill>
+                  <a:srgbClr val="222222"/>
+                </a:solidFill>
+              </a:rPr>
+              <a:t>Leave one year out:</a:t>
+            </a:r>
+            <a:r>
+              <a:rPr sz="1200" b="0">
+                <a:solidFill>
+                  <a:srgbClr val="222222"/>
+                </a:solidFill>
+              </a:rPr>
+              <a:t> 0 sign flips across 5 signal–sample pairs.</a:t>
+            </a:r>
+          </a:p>
+          <a:p>
+            <a:pPr algn="l">
+              <a:spcAft>
+                <a:spcPts val="400"/>
+              </a:spcAft>
+            </a:pPr>
+            <a:r>
+              <a:rPr sz="1200" b="0">
+                <a:solidFill>
+                  <a:srgbClr val="222222"/>
+                </a:solidFill>
+              </a:rPr>
+              <a:t>• </a:t>
+            </a:r>
+            <a:r>
+              <a:rPr sz="1200" b="1">
+                <a:solidFill>
+                  <a:srgbClr val="222222"/>
+                </a:solidFill>
+              </a:rPr>
+              <a:t>Power:</a:t>
+            </a:r>
+            <a:r>
+              <a:rPr sz="1200" b="0">
+                <a:solidFill>
+                  <a:srgbClr val="222222"/>
+                </a:solidFill>
+              </a:rPr>
+              <a:t> the reproduction detects any correlation ≥ 0.13; the paper's 0.40 would not be missed.</a:t>
+            </a:r>
+          </a:p>
+          <a:p>
+            <a:pPr algn="l">
+              <a:spcAft>
+                <a:spcPts val="400"/>
+              </a:spcAft>
+            </a:pPr>
+            <a:r>
+              <a:rPr sz="1200" b="0">
+                <a:solidFill>
+                  <a:srgbClr val="222222"/>
+                </a:solidFill>
+              </a:rPr>
+              <a:t>• </a:t>
+            </a:r>
+            <a:r>
+              <a:rPr sz="1200" b="1">
+                <a:solidFill>
+                  <a:srgbClr val="222222"/>
+                </a:solidFill>
+              </a:rPr>
+              <a:t>Ledger:</a:t>
+            </a:r>
+            <a:r>
+              <a:rPr sz="1200" b="0">
+                <a:solidFill>
+                  <a:srgbClr val="222222"/>
+                </a:solidFill>
+              </a:rPr>
+              <a:t> 26 tests behind our claims; supported after Benjamini–Hochberg </a:t>
+            </a:r>
+            <a:r>
+              <a:rPr sz="1200" b="1">
+                <a:solidFill>
+                  <a:srgbClr val="222222"/>
+                </a:solidFill>
+              </a:rPr>
+              <a:t>17</a:t>
+            </a:r>
+            <a:r>
+              <a:rPr sz="1200" b="0">
+                <a:solidFill>
+                  <a:srgbClr val="222222"/>
+                </a:solidFill>
+              </a:rPr>
+              <a:t>, after Bonferroni </a:t>
+            </a:r>
+            <a:r>
+              <a:rPr sz="1200" b="1">
+                <a:solidFill>
+                  <a:srgbClr val="222222"/>
+                </a:solidFill>
+              </a:rPr>
+              <a:t>13</a:t>
+            </a:r>
+            <a:r>
+              <a:rPr sz="1200" b="0">
+                <a:solidFill>
+                  <a:srgbClr val="222222"/>
+                </a:solidFill>
+              </a:rPr>
+              <a:t>; significant but on the wrong side </a:t>
+            </a:r>
+            <a:r>
+              <a:rPr sz="1200" b="1">
+                <a:solidFill>
+                  <a:srgbClr val="222222"/>
+                </a:solidFill>
+              </a:rPr>
+              <a:t>3</a:t>
+            </a:r>
+            <a:r>
+              <a:rPr sz="1200" b="0">
+                <a:solidFill>
+                  <a:srgbClr val="222222"/>
+                </a:solidFill>
+              </a:rPr>
+              <a:t> (reported as not supported).</a:t>
+            </a:r>
+          </a:p>
+          <a:p>
+            <a:pPr algn="l">
+              <a:spcAft>
+                <a:spcPts val="400"/>
+              </a:spcAft>
+            </a:pPr>
+            <a:r>
+              <a:rPr sz="1100" b="0">
+                <a:solidFill>
                   <a:srgbClr val="595959"/>
                 </a:solidFill>
               </a:rPr>
-              <a:t>Confirms on new data: Andersen &amp; Bondarenko (2014, 2015); Chakrabarty, Pascual &amp; Shkilko (2015).</a:t>
+              <a:t>• New tests pre-registered before running; every later change logged.</a:t>
             </a:r>
           </a:p>
         </p:txBody>
@@ -46638,7 +46142,7 @@
 </p:sld>
 </file>
 
-<file path=ppt/slides/slide26.xml><?xml version="1.0" encoding="utf-8"?>
+<file path=ppt/slides/slide24.xml><?xml version="1.0" encoding="utf-8"?>
 <p:sld xmlns:a="http://schemas.openxmlformats.org/drawingml/2006/main" xmlns:p="http://schemas.openxmlformats.org/presentationml/2006/main" xmlns:r="http://schemas.openxmlformats.org/officeDocument/2006/relationships">
   <p:cSld>
     <p:spTree>
@@ -47438,7 +46942,7 @@
           <a:lstStyle/>
           <a:p>
             <a:r>
-              <a:t>What is estimated, what is chosen, what is evaluated</a:t>
+              <a:t>Data, and what is estimated, chosen and evaluated</a:t>
             </a:r>
           </a:p>
         </p:txBody>
@@ -47473,8 +46977,8 @@
           <p:nvPr/>
         </p:nvGraphicFramePr>
         <p:xfrm>
-          <a:off x="585216" y="2194560"/>
-          <a:ext cx="11018520" cy="3108960"/>
+          <a:off x="585216" y="2057400"/>
+          <a:ext cx="11018520" cy="1005840"/>
         </p:xfrm>
         <a:graphic>
           <a:graphicData uri="http://schemas.openxmlformats.org/drawingml/2006/table">
@@ -47483,18 +46987,305 @@
                 <a:tableStyleId>{5C22544A-7EE6-4342-B048-85BDC9FD1C3A}</a:tableStyleId>
               </a:tblPr>
               <a:tblGrid>
-                <a:gridCol w="2377440"/>
-                <a:gridCol w="5120640"/>
-                <a:gridCol w="3520440"/>
+                <a:gridCol w="2011680"/>
+                <a:gridCol w="4251960"/>
+                <a:gridCol w="4754880"/>
               </a:tblGrid>
-              <a:tr h="518160">
+              <a:tr h="251460">
                 <a:tc>
                   <a:txBody>
                     <a:bodyPr/>
                     <a:lstStyle/>
                     <a:p>
                       <a:r>
-                        <a:rPr sz="1200" b="1">
+                        <a:rPr sz="1100" b="1">
+                          <a:solidFill>
+                            <a:srgbClr val="FFFFFF"/>
+                          </a:solidFill>
+                        </a:rPr>
+                        <a:t>Data</a:t>
+                      </a:r>
+                    </a:p>
+                  </a:txBody>
+                  <a:tcPr marL="54864" marR="54864" marT="27432" marB="27432" anchor="ctr">
+                    <a:solidFill>
+                      <a:srgbClr val="0F2C68"/>
+                    </a:solidFill>
+                  </a:tcPr>
+                </a:tc>
+                <a:tc>
+                  <a:txBody>
+                    <a:bodyPr/>
+                    <a:lstStyle/>
+                    <a:p>
+                      <a:r>
+                        <a:rPr sz="1100" b="1">
+                          <a:solidFill>
+                            <a:srgbClr val="FFFFFF"/>
+                          </a:solidFill>
+                        </a:rPr>
+                        <a:t>Paper</a:t>
+                      </a:r>
+                    </a:p>
+                  </a:txBody>
+                  <a:tcPr marL="54864" marR="54864" marT="27432" marB="27432" anchor="ctr">
+                    <a:solidFill>
+                      <a:srgbClr val="0F2C68"/>
+                    </a:solidFill>
+                  </a:tcPr>
+                </a:tc>
+                <a:tc>
+                  <a:txBody>
+                    <a:bodyPr/>
+                    <a:lstStyle/>
+                    <a:p>
+                      <a:r>
+                        <a:rPr sz="1100" b="1">
+                          <a:solidFill>
+                            <a:srgbClr val="FFFFFF"/>
+                          </a:solidFill>
+                        </a:rPr>
+                        <a:t>Ours</a:t>
+                      </a:r>
+                    </a:p>
+                  </a:txBody>
+                  <a:tcPr marL="54864" marR="54864" marT="27432" marB="27432" anchor="ctr">
+                    <a:solidFill>
+                      <a:srgbClr val="0F2C68"/>
+                    </a:solidFill>
+                  </a:tcPr>
+                </a:tc>
+              </a:tr>
+              <a:tr h="251460">
+                <a:tc>
+                  <a:txBody>
+                    <a:bodyPr/>
+                    <a:lstStyle/>
+                    <a:p>
+                      <a:r>
+                        <a:rPr sz="1100" b="0">
+                          <a:solidFill>
+                            <a:srgbClr val="222222"/>
+                          </a:solidFill>
+                        </a:rPr>
+                        <a:t>Market and hours</a:t>
+                      </a:r>
+                    </a:p>
+                  </a:txBody>
+                  <a:tcPr marL="54864" marR="54864" marT="27432" marB="27432" anchor="ctr">
+                    <a:solidFill>
+                      <a:srgbClr val="FFFFFF"/>
+                    </a:solidFill>
+                  </a:tcPr>
+                </a:tc>
+                <a:tc>
+                  <a:txBody>
+                    <a:bodyPr/>
+                    <a:lstStyle/>
+                    <a:p>
+                      <a:r>
+                        <a:rPr sz="1100" b="0">
+                          <a:solidFill>
+                            <a:srgbClr val="222222"/>
+                          </a:solidFill>
+                        </a:rPr>
+                        <a:t>E-mini S&amp;P 500 and WTI crude futures; almost 24 hours</a:t>
+                      </a:r>
+                    </a:p>
+                  </a:txBody>
+                  <a:tcPr marL="54864" marR="54864" marT="27432" marB="27432" anchor="ctr">
+                    <a:solidFill>
+                      <a:srgbClr val="FFFFFF"/>
+                    </a:solidFill>
+                  </a:tcPr>
+                </a:tc>
+                <a:tc>
+                  <a:txBody>
+                    <a:bodyPr/>
+                    <a:lstStyle/>
+                    <a:p>
+                      <a:r>
+                        <a:rPr sz="1100" b="0">
+                          <a:solidFill>
+                            <a:srgbClr val="222222"/>
+                          </a:solidFill>
+                        </a:rPr>
+                        <a:t>IVE (S&amp;P 500 Value ETF) ticks with quotes, 09:30–16:00 New York; BTCUSDT for extensions</a:t>
+                      </a:r>
+                    </a:p>
+                  </a:txBody>
+                  <a:tcPr marL="54864" marR="54864" marT="27432" marB="27432" anchor="ctr">
+                    <a:solidFill>
+                      <a:srgbClr val="FFFFFF"/>
+                    </a:solidFill>
+                  </a:tcPr>
+                </a:tc>
+              </a:tr>
+              <a:tr h="251460">
+                <a:tc>
+                  <a:txBody>
+                    <a:bodyPr/>
+                    <a:lstStyle/>
+                    <a:p>
+                      <a:r>
+                        <a:rPr sz="1100" b="0">
+                          <a:solidFill>
+                            <a:srgbClr val="222222"/>
+                          </a:solidFill>
+                        </a:rPr>
+                        <a:t>Period</a:t>
+                      </a:r>
+                    </a:p>
+                  </a:txBody>
+                  <a:tcPr marL="54864" marR="54864" marT="27432" marB="27432" anchor="ctr">
+                    <a:solidFill>
+                      <a:srgbClr val="EEF2F8"/>
+                    </a:solidFill>
+                  </a:tcPr>
+                </a:tc>
+                <a:tc>
+                  <a:txBody>
+                    <a:bodyPr/>
+                    <a:lstStyle/>
+                    <a:p>
+                      <a:r>
+                        <a:rPr sz="1100" b="0">
+                          <a:solidFill>
+                            <a:srgbClr val="222222"/>
+                          </a:solidFill>
+                        </a:rPr>
+                        <a:t>Jan 2008 – Aug 2011 (incl. 2008 crisis)</a:t>
+                      </a:r>
+                    </a:p>
+                  </a:txBody>
+                  <a:tcPr marL="54864" marR="54864" marT="27432" marB="27432" anchor="ctr">
+                    <a:solidFill>
+                      <a:srgbClr val="EEF2F8"/>
+                    </a:solidFill>
+                  </a:tcPr>
+                </a:tc>
+                <a:tc>
+                  <a:txBody>
+                    <a:bodyPr/>
+                    <a:lstStyle/>
+                    <a:p>
+                      <a:r>
+                        <a:rPr sz="1100" b="0">
+                          <a:solidFill>
+                            <a:srgbClr val="222222"/>
+                          </a:solidFill>
+                        </a:rPr>
+                        <a:t>2009-09-28 – 2011-08-15; out of sample to Sep 2026</a:t>
+                      </a:r>
+                    </a:p>
+                  </a:txBody>
+                  <a:tcPr marL="54864" marR="54864" marT="27432" marB="27432" anchor="ctr">
+                    <a:solidFill>
+                      <a:srgbClr val="EEF2F8"/>
+                    </a:solidFill>
+                  </a:tcPr>
+                </a:tc>
+              </a:tr>
+              <a:tr h="251460">
+                <a:tc>
+                  <a:txBody>
+                    <a:bodyPr/>
+                    <a:lstStyle/>
+                    <a:p>
+                      <a:r>
+                        <a:rPr sz="1100" b="0">
+                          <a:solidFill>
+                            <a:srgbClr val="222222"/>
+                          </a:solidFill>
+                        </a:rPr>
+                        <a:t>Classification, settings</a:t>
+                      </a:r>
+                    </a:p>
+                  </a:txBody>
+                  <a:tcPr marL="54864" marR="54864" marT="27432" marB="27432" anchor="ctr">
+                    <a:solidFill>
+                      <a:srgbClr val="FFFFFF"/>
+                    </a:solidFill>
+                  </a:tcPr>
+                </a:tc>
+                <a:tc>
+                  <a:txBody>
+                    <a:bodyPr/>
+                    <a:lstStyle/>
+                    <a:p>
+                      <a:r>
+                        <a:rPr sz="1100" b="0">
+                          <a:solidFill>
+                            <a:srgbClr val="222222"/>
+                          </a:solidFill>
+                        </a:rPr>
+                        <a:t>bulk, one-minute bars; V = ADV/50, n = 50, whole-sample σ and CDF</a:t>
+                      </a:r>
+                    </a:p>
+                  </a:txBody>
+                  <a:tcPr marL="54864" marR="54864" marT="27432" marB="27432" anchor="ctr">
+                    <a:solidFill>
+                      <a:srgbClr val="FFFFFF"/>
+                    </a:solidFill>
+                  </a:tcPr>
+                </a:tc>
+                <a:tc>
+                  <a:txBody>
+                    <a:bodyPr/>
+                    <a:lstStyle/>
+                    <a:p>
+                      <a:r>
+                        <a:rPr sz="1100" b="0">
+                          <a:solidFill>
+                            <a:srgbClr val="222222"/>
+                          </a:solidFill>
+                        </a:rPr>
+                        <a:t>identical, plus 10-second bars and Lee-Ready</a:t>
+                      </a:r>
+                    </a:p>
+                  </a:txBody>
+                  <a:tcPr marL="54864" marR="54864" marT="27432" marB="27432" anchor="ctr">
+                    <a:solidFill>
+                      <a:srgbClr val="FFFFFF"/>
+                    </a:solidFill>
+                  </a:tcPr>
+                </a:tc>
+              </a:tr>
+            </a:tbl>
+          </a:graphicData>
+        </a:graphic>
+      </p:graphicFrame>
+      <p:graphicFrame>
+        <p:nvGraphicFramePr>
+          <p:cNvPr id="6" name="Table 5"/>
+          <p:cNvGraphicFramePr>
+            <a:graphicFrameLocks noGrp="1"/>
+          </p:cNvGraphicFramePr>
+          <p:nvPr/>
+        </p:nvGraphicFramePr>
+        <p:xfrm>
+          <a:off x="585216" y="3474720"/>
+          <a:ext cx="11018520" cy="1645920"/>
+        </p:xfrm>
+        <a:graphic>
+          <a:graphicData uri="http://schemas.openxmlformats.org/drawingml/2006/table">
+            <a:tbl>
+              <a:tblPr firstRow="1" bandRow="1">
+                <a:tableStyleId>{5C22544A-7EE6-4342-B048-85BDC9FD1C3A}</a:tableStyleId>
+              </a:tblPr>
+              <a:tblGrid>
+                <a:gridCol w="2011680"/>
+                <a:gridCol w="5532120"/>
+                <a:gridCol w="3474720"/>
+              </a:tblGrid>
+              <a:tr h="274320">
+                <a:tc>
+                  <a:txBody>
+                    <a:bodyPr/>
+                    <a:lstStyle/>
+                    <a:p>
+                      <a:r>
+                        <a:rPr sz="1100" b="1">
                           <a:solidFill>
                             <a:srgbClr val="FFFFFF"/>
                           </a:solidFill>
@@ -47515,7 +47306,7 @@
                     <a:lstStyle/>
                     <a:p>
                       <a:r>
-                        <a:rPr sz="1200" b="1">
+                        <a:rPr sz="1100" b="1">
                           <a:solidFill>
                             <a:srgbClr val="FFFFFF"/>
                           </a:solidFill>
@@ -47536,7 +47327,7 @@
                     <a:lstStyle/>
                     <a:p>
                       <a:r>
-                        <a:rPr sz="1200" b="1">
+                        <a:rPr sz="1100" b="1">
                           <a:solidFill>
                             <a:srgbClr val="FFFFFF"/>
                           </a:solidFill>
@@ -47552,14 +47343,14 @@
                   </a:tcPr>
                 </a:tc>
               </a:tr>
-              <a:tr h="518160">
+              <a:tr h="274320">
                 <a:tc>
                   <a:txBody>
                     <a:bodyPr/>
                     <a:lstStyle/>
                     <a:p>
                       <a:r>
-                        <a:rPr sz="1200" b="0">
+                        <a:rPr sz="1100" b="0">
                           <a:solidFill>
                             <a:srgbClr val="222222"/>
                           </a:solidFill>
@@ -47580,7 +47371,7 @@
                     <a:lstStyle/>
                     <a:p>
                       <a:r>
-                        <a:rPr sz="1200" b="0">
+                        <a:rPr sz="1100" b="0">
                           <a:solidFill>
                             <a:srgbClr val="222222"/>
                           </a:solidFill>
@@ -47601,7 +47392,7 @@
                     <a:lstStyle/>
                     <a:p>
                       <a:r>
-                        <a:rPr sz="1200" b="0">
+                        <a:rPr sz="1100" b="0">
                           <a:solidFill>
                             <a:srgbClr val="222222"/>
                           </a:solidFill>
@@ -47617,14 +47408,14 @@
                   </a:tcPr>
                 </a:tc>
               </a:tr>
-              <a:tr h="518160">
+              <a:tr h="274320">
                 <a:tc>
                   <a:txBody>
                     <a:bodyPr/>
                     <a:lstStyle/>
                     <a:p>
                       <a:r>
-                        <a:rPr sz="1200" b="0">
+                        <a:rPr sz="1100" b="0">
                           <a:solidFill>
                             <a:srgbClr val="222222"/>
                           </a:solidFill>
@@ -47645,7 +47436,7 @@
                     <a:lstStyle/>
                     <a:p>
                       <a:r>
-                        <a:rPr sz="1200" b="0">
+                        <a:rPr sz="1100" b="0">
                           <a:solidFill>
                             <a:srgbClr val="222222"/>
                           </a:solidFill>
@@ -47666,7 +47457,7 @@
                     <a:lstStyle/>
                     <a:p>
                       <a:r>
-                        <a:rPr sz="1200" b="0">
+                        <a:rPr sz="1100" b="0">
                           <a:solidFill>
                             <a:srgbClr val="222222"/>
                           </a:solidFill>
@@ -47682,14 +47473,14 @@
                   </a:tcPr>
                 </a:tc>
               </a:tr>
-              <a:tr h="518160">
+              <a:tr h="274320">
                 <a:tc>
                   <a:txBody>
                     <a:bodyPr/>
                     <a:lstStyle/>
                     <a:p>
                       <a:r>
-                        <a:rPr sz="1200" b="0">
+                        <a:rPr sz="1100" b="0">
                           <a:solidFill>
                             <a:srgbClr val="222222"/>
                           </a:solidFill>
@@ -47710,7 +47501,7 @@
                     <a:lstStyle/>
                     <a:p>
                       <a:r>
-                        <a:rPr sz="1200" b="0">
+                        <a:rPr sz="1100" b="0">
                           <a:solidFill>
                             <a:srgbClr val="222222"/>
                           </a:solidFill>
@@ -47731,7 +47522,7 @@
                     <a:lstStyle/>
                     <a:p>
                       <a:r>
-                        <a:rPr sz="1200" b="0">
+                        <a:rPr sz="1100" b="0">
                           <a:solidFill>
                             <a:srgbClr val="222222"/>
                           </a:solidFill>
@@ -47747,14 +47538,14 @@
                   </a:tcPr>
                 </a:tc>
               </a:tr>
-              <a:tr h="518160">
+              <a:tr h="274320">
                 <a:tc>
                   <a:txBody>
                     <a:bodyPr/>
                     <a:lstStyle/>
                     <a:p>
                       <a:r>
-                        <a:rPr sz="1200" b="0">
+                        <a:rPr sz="1100" b="0">
                           <a:solidFill>
                             <a:srgbClr val="222222"/>
                           </a:solidFill>
@@ -47775,7 +47566,7 @@
                     <a:lstStyle/>
                     <a:p>
                       <a:r>
-                        <a:rPr sz="1200" b="0">
+                        <a:rPr sz="1100" b="0">
                           <a:solidFill>
                             <a:srgbClr val="222222"/>
                           </a:solidFill>
@@ -47796,7 +47587,7 @@
                     <a:lstStyle/>
                     <a:p>
                       <a:r>
-                        <a:rPr sz="1200" b="0">
+                        <a:rPr sz="1100" b="0">
                           <a:solidFill>
                             <a:srgbClr val="222222"/>
                           </a:solidFill>
@@ -47812,14 +47603,14 @@
                   </a:tcPr>
                 </a:tc>
               </a:tr>
-              <a:tr h="518160">
+              <a:tr h="274320">
                 <a:tc>
                   <a:txBody>
                     <a:bodyPr/>
                     <a:lstStyle/>
                     <a:p>
                       <a:r>
-                        <a:rPr sz="1200" b="0">
+                        <a:rPr sz="1100" b="0">
                           <a:solidFill>
                             <a:srgbClr val="222222"/>
                           </a:solidFill>
@@ -47840,7 +47631,7 @@
                     <a:lstStyle/>
                     <a:p>
                       <a:r>
-                        <a:rPr sz="1200" b="0">
+                        <a:rPr sz="1100" b="0">
                           <a:solidFill>
                             <a:srgbClr val="222222"/>
                           </a:solidFill>
@@ -47861,7 +47652,7 @@
                     <a:lstStyle/>
                     <a:p>
                       <a:r>
-                        <a:rPr sz="1200" b="0">
+                        <a:rPr sz="1100" b="0">
                           <a:solidFill>
                             <a:srgbClr val="222222"/>
                           </a:solidFill>
@@ -47883,14 +47674,14 @@
       </p:graphicFrame>
       <p:sp>
         <p:nvSpPr>
-          <p:cNvPr id="6" name="TextBox 5"/>
+          <p:cNvPr id="7" name="TextBox 6"/>
           <p:cNvSpPr txBox="1"/>
           <p:nvPr/>
         </p:nvSpPr>
         <p:spPr>
           <a:xfrm>
-            <a:off x="585216" y="5486400"/>
-            <a:ext cx="10972800" cy="914400"/>
+            <a:off x="585216" y="5715000"/>
+            <a:ext cx="10972800" cy="1005840"/>
           </a:xfrm>
           <a:prstGeom prst="rect">
             <a:avLst/>
@@ -47905,11 +47696,58 @@
           <a:p>
             <a:pPr algn="l">
               <a:spcAft>
-                <a:spcPts val="600"/>
+                <a:spcPts val="400"/>
               </a:spcAft>
             </a:pPr>
             <a:r>
-              <a:rPr sz="1400" b="0">
+              <a:rPr sz="1100" b="0">
+                <a:solidFill>
+                  <a:srgbClr val="595959"/>
+                </a:solidFill>
+              </a:rPr>
+              <a:t>• Also removed: 42 IVE trades at prices like $0.08 that the exchanges </a:t>
+            </a:r>
+            <a:r>
+              <a:rPr sz="1100" b="1">
+                <a:solidFill>
+                  <a:srgbClr val="595959"/>
+                </a:solidFill>
+              </a:rPr>
+              <a:t>cancelled</a:t>
+            </a:r>
+            <a:r>
+              <a:rPr sz="1100" b="0">
+                <a:solidFill>
+                  <a:srgbClr val="595959"/>
+                </a:solidFill>
+              </a:rPr>
+              <a:t> on 6 May 2010. 29% of IVE one-minute bars have no price change; bulk classification splits them 50/50. </a:t>
+            </a:r>
+            <a:r>
+              <a:rPr sz="1100" b="1">
+                <a:solidFill>
+                  <a:srgbClr val="595959"/>
+                </a:solidFill>
+              </a:rPr>
+              <a:t>±</a:t>
+            </a:r>
+            <a:r>
+              <a:rPr sz="1100" b="0">
+                <a:solidFill>
+                  <a:srgbClr val="595959"/>
+                </a:solidFill>
+              </a:rPr>
+              <a:t> on our numbers: block bootstrap over calendar months (1,000 replications), because VPIN windows overlap and volatility clusters.</a:t>
+            </a:r>
+          </a:p>
+          <a:p>
+            <a:pPr algn="l">
+              <a:spcAft>
+                <a:spcPts val="400"/>
+              </a:spcAft>
+            </a:pPr>
+            <a:r>
+              <a:rPr sz="1200" b="0">
                 <a:solidFill>
                   <a:srgbClr val="0F2C68"/>
                 </a:solidFill>
@@ -47917,7 +47755,7 @@
               <a:t>• </a:t>
             </a:r>
             <a:r>
-              <a:rPr sz="1400" b="1">
+              <a:rPr sz="1200" b="1">
                 <a:solidFill>
                   <a:srgbClr val="0F2C68"/>
                 </a:solidFill>
@@ -47925,7 +47763,7 @@
               <a:t>VPIN has no training objective.</a:t>
             </a:r>
             <a:r>
-              <a:rPr sz="1400" b="0">
+              <a:rPr sz="1200" b="0">
                 <a:solidFill>
                   <a:srgbClr val="0F2C68"/>
                 </a:solidFill>
@@ -47944,568 +47782,6 @@
 </file>
 
 <file path=ppt/slides/slide7.xml><?xml version="1.0" encoding="utf-8"?>
-<p:sld xmlns:a="http://schemas.openxmlformats.org/drawingml/2006/main" xmlns:p="http://schemas.openxmlformats.org/presentationml/2006/main" xmlns:r="http://schemas.openxmlformats.org/officeDocument/2006/relationships">
-  <p:cSld>
-    <p:spTree>
-      <p:nvGrpSpPr>
-        <p:cNvPr id="1" name=""/>
-        <p:cNvGrpSpPr/>
-        <p:nvPr/>
-      </p:nvGrpSpPr>
-      <p:grpSpPr/>
-      <p:sp>
-        <p:nvSpPr>
-          <p:cNvPr id="2" name="Title 1"/>
-          <p:cNvSpPr>
-            <a:spLocks noGrp="1"/>
-          </p:cNvSpPr>
-          <p:nvPr>
-            <p:ph type="title"/>
-          </p:nvPr>
-        </p:nvSpPr>
-        <p:spPr/>
-        <p:txBody>
-          <a:bodyPr/>
-          <a:lstStyle/>
-          <a:p>
-            <a:r>
-              <a:t>Data and our replication setup</a:t>
-            </a:r>
-          </a:p>
-        </p:txBody>
-      </p:sp>
-      <p:sp>
-        <p:nvSpPr>
-          <p:cNvPr id="4" name="Text Placeholder 3"/>
-          <p:cNvSpPr>
-            <a:spLocks noGrp="1"/>
-          </p:cNvSpPr>
-          <p:nvPr>
-            <p:ph type="body" idx="2"/>
-          </p:nvPr>
-        </p:nvSpPr>
-        <p:spPr/>
-        <p:txBody>
-          <a:bodyPr/>
-          <a:lstStyle/>
-          <a:p>
-            <a:r>
-              <a:t>Research Seminar</a:t>
-            </a:r>
-          </a:p>
-        </p:txBody>
-      </p:sp>
-      <p:graphicFrame>
-        <p:nvGraphicFramePr>
-          <p:cNvPr id="5" name="Table 4"/>
-          <p:cNvGraphicFramePr>
-            <a:graphicFrameLocks noGrp="1"/>
-          </p:cNvGraphicFramePr>
-          <p:nvPr/>
-        </p:nvGraphicFramePr>
-        <p:xfrm>
-          <a:off x="585216" y="2240280"/>
-          <a:ext cx="11018520" cy="2377440"/>
-        </p:xfrm>
-        <a:graphic>
-          <a:graphicData uri="http://schemas.openxmlformats.org/drawingml/2006/table">
-            <a:tbl>
-              <a:tblPr firstRow="1" bandRow="1">
-                <a:tableStyleId>{5C22544A-7EE6-4342-B048-85BDC9FD1C3A}</a:tableStyleId>
-              </a:tblPr>
-              <a:tblGrid>
-                <a:gridCol w="2377440"/>
-                <a:gridCol w="3840480"/>
-                <a:gridCol w="4800600"/>
-              </a:tblGrid>
-              <a:tr h="396240">
-                <a:tc>
-                  <a:txBody>
-                    <a:bodyPr/>
-                    <a:lstStyle/>
-                    <a:p>
-                      <a:r>
-                        <a:rPr sz="1300" b="1">
-                          <a:solidFill>
-                            <a:srgbClr val="FFFFFF"/>
-                          </a:solidFill>
-                        </a:rPr>
-                        <a:t>Set-up</a:t>
-                      </a:r>
-                    </a:p>
-                  </a:txBody>
-                  <a:tcPr marL="54864" marR="54864" marT="27432" marB="27432" anchor="ctr">
-                    <a:solidFill>
-                      <a:srgbClr val="0F2C68"/>
-                    </a:solidFill>
-                  </a:tcPr>
-                </a:tc>
-                <a:tc>
-                  <a:txBody>
-                    <a:bodyPr/>
-                    <a:lstStyle/>
-                    <a:p>
-                      <a:r>
-                        <a:rPr sz="1300" b="1">
-                          <a:solidFill>
-                            <a:srgbClr val="FFFFFF"/>
-                          </a:solidFill>
-                        </a:rPr>
-                        <a:t>Paper</a:t>
-                      </a:r>
-                    </a:p>
-                  </a:txBody>
-                  <a:tcPr marL="54864" marR="54864" marT="27432" marB="27432" anchor="ctr">
-                    <a:solidFill>
-                      <a:srgbClr val="0F2C68"/>
-                    </a:solidFill>
-                  </a:tcPr>
-                </a:tc>
-                <a:tc>
-                  <a:txBody>
-                    <a:bodyPr/>
-                    <a:lstStyle/>
-                    <a:p>
-                      <a:r>
-                        <a:rPr sz="1300" b="1">
-                          <a:solidFill>
-                            <a:srgbClr val="FFFFFF"/>
-                          </a:solidFill>
-                        </a:rPr>
-                        <a:t>Ours</a:t>
-                      </a:r>
-                    </a:p>
-                  </a:txBody>
-                  <a:tcPr marL="54864" marR="54864" marT="27432" marB="27432" anchor="ctr">
-                    <a:solidFill>
-                      <a:srgbClr val="0F2C68"/>
-                    </a:solidFill>
-                  </a:tcPr>
-                </a:tc>
-              </a:tr>
-              <a:tr h="396240">
-                <a:tc>
-                  <a:txBody>
-                    <a:bodyPr/>
-                    <a:lstStyle/>
-                    <a:p>
-                      <a:r>
-                        <a:rPr sz="1300" b="0">
-                          <a:solidFill>
-                            <a:srgbClr val="222222"/>
-                          </a:solidFill>
-                        </a:rPr>
-                        <a:t>Market</a:t>
-                      </a:r>
-                    </a:p>
-                  </a:txBody>
-                  <a:tcPr marL="54864" marR="54864" marT="27432" marB="27432" anchor="ctr">
-                    <a:solidFill>
-                      <a:srgbClr val="FFFFFF"/>
-                    </a:solidFill>
-                  </a:tcPr>
-                </a:tc>
-                <a:tc>
-                  <a:txBody>
-                    <a:bodyPr/>
-                    <a:lstStyle/>
-                    <a:p>
-                      <a:r>
-                        <a:rPr sz="1300" b="0">
-                          <a:solidFill>
-                            <a:srgbClr val="222222"/>
-                          </a:solidFill>
-                        </a:rPr>
-                        <a:t>E-mini S&amp;P 500 and WTI crude futures</a:t>
-                      </a:r>
-                    </a:p>
-                  </a:txBody>
-                  <a:tcPr marL="54864" marR="54864" marT="27432" marB="27432" anchor="ctr">
-                    <a:solidFill>
-                      <a:srgbClr val="FFFFFF"/>
-                    </a:solidFill>
-                  </a:tcPr>
-                </a:tc>
-                <a:tc>
-                  <a:txBody>
-                    <a:bodyPr/>
-                    <a:lstStyle/>
-                    <a:p>
-                      <a:r>
-                        <a:rPr sz="1300" b="0">
-                          <a:solidFill>
-                            <a:srgbClr val="222222"/>
-                          </a:solidFill>
-                        </a:rPr>
-                        <a:t>IVE (S&amp;P 500 Value ETF) ticks with quotes; BTCUSDT for extensions</a:t>
-                      </a:r>
-                    </a:p>
-                  </a:txBody>
-                  <a:tcPr marL="54864" marR="54864" marT="27432" marB="27432" anchor="ctr">
-                    <a:solidFill>
-                      <a:srgbClr val="FFFFFF"/>
-                    </a:solidFill>
-                  </a:tcPr>
-                </a:tc>
-              </a:tr>
-              <a:tr h="396240">
-                <a:tc>
-                  <a:txBody>
-                    <a:bodyPr/>
-                    <a:lstStyle/>
-                    <a:p>
-                      <a:r>
-                        <a:rPr sz="1300" b="0">
-                          <a:solidFill>
-                            <a:srgbClr val="222222"/>
-                          </a:solidFill>
-                        </a:rPr>
-                        <a:t>Period</a:t>
-                      </a:r>
-                    </a:p>
-                  </a:txBody>
-                  <a:tcPr marL="54864" marR="54864" marT="27432" marB="27432" anchor="ctr">
-                    <a:solidFill>
-                      <a:srgbClr val="EEF2F8"/>
-                    </a:solidFill>
-                  </a:tcPr>
-                </a:tc>
-                <a:tc>
-                  <a:txBody>
-                    <a:bodyPr/>
-                    <a:lstStyle/>
-                    <a:p>
-                      <a:r>
-                        <a:rPr sz="1300" b="0">
-                          <a:solidFill>
-                            <a:srgbClr val="222222"/>
-                          </a:solidFill>
-                        </a:rPr>
-                        <a:t>Jan 2008 – Aug 2011 (incl. 2008 crisis)</a:t>
-                      </a:r>
-                    </a:p>
-                  </a:txBody>
-                  <a:tcPr marL="54864" marR="54864" marT="27432" marB="27432" anchor="ctr">
-                    <a:solidFill>
-                      <a:srgbClr val="EEF2F8"/>
-                    </a:solidFill>
-                  </a:tcPr>
-                </a:tc>
-                <a:tc>
-                  <a:txBody>
-                    <a:bodyPr/>
-                    <a:lstStyle/>
-                    <a:p>
-                      <a:r>
-                        <a:rPr sz="1300" b="0">
-                          <a:solidFill>
-                            <a:srgbClr val="222222"/>
-                          </a:solidFill>
-                        </a:rPr>
-                        <a:t>2009-09-28 – 2011-08-15; out of sample to Sep 2026</a:t>
-                      </a:r>
-                    </a:p>
-                  </a:txBody>
-                  <a:tcPr marL="54864" marR="54864" marT="27432" marB="27432" anchor="ctr">
-                    <a:solidFill>
-                      <a:srgbClr val="EEF2F8"/>
-                    </a:solidFill>
-                  </a:tcPr>
-                </a:tc>
-              </a:tr>
-              <a:tr h="396240">
-                <a:tc>
-                  <a:txBody>
-                    <a:bodyPr/>
-                    <a:lstStyle/>
-                    <a:p>
-                      <a:r>
-                        <a:rPr sz="1300" b="0">
-                          <a:solidFill>
-                            <a:srgbClr val="222222"/>
-                          </a:solidFill>
-                        </a:rPr>
-                        <a:t>Trading hours</a:t>
-                      </a:r>
-                    </a:p>
-                  </a:txBody>
-                  <a:tcPr marL="54864" marR="54864" marT="27432" marB="27432" anchor="ctr">
-                    <a:solidFill>
-                      <a:srgbClr val="FFFFFF"/>
-                    </a:solidFill>
-                  </a:tcPr>
-                </a:tc>
-                <a:tc>
-                  <a:txBody>
-                    <a:bodyPr/>
-                    <a:lstStyle/>
-                    <a:p>
-                      <a:r>
-                        <a:rPr sz="1300" b="0">
-                          <a:solidFill>
-                            <a:srgbClr val="222222"/>
-                          </a:solidFill>
-                        </a:rPr>
-                        <a:t>almost 24 hours</a:t>
-                      </a:r>
-                    </a:p>
-                  </a:txBody>
-                  <a:tcPr marL="54864" marR="54864" marT="27432" marB="27432" anchor="ctr">
-                    <a:solidFill>
-                      <a:srgbClr val="FFFFFF"/>
-                    </a:solidFill>
-                  </a:tcPr>
-                </a:tc>
-                <a:tc>
-                  <a:txBody>
-                    <a:bodyPr/>
-                    <a:lstStyle/>
-                    <a:p>
-                      <a:r>
-                        <a:rPr sz="1300" b="0">
-                          <a:solidFill>
-                            <a:srgbClr val="222222"/>
-                          </a:solidFill>
-                        </a:rPr>
-                        <a:t>09:30–16:00 New York</a:t>
-                      </a:r>
-                    </a:p>
-                  </a:txBody>
-                  <a:tcPr marL="54864" marR="54864" marT="27432" marB="27432" anchor="ctr">
-                    <a:solidFill>
-                      <a:srgbClr val="FFFFFF"/>
-                    </a:solidFill>
-                  </a:tcPr>
-                </a:tc>
-              </a:tr>
-              <a:tr h="396240">
-                <a:tc>
-                  <a:txBody>
-                    <a:bodyPr/>
-                    <a:lstStyle/>
-                    <a:p>
-                      <a:r>
-                        <a:rPr sz="1300" b="0">
-                          <a:solidFill>
-                            <a:srgbClr val="222222"/>
-                          </a:solidFill>
-                        </a:rPr>
-                        <a:t>Classification</a:t>
-                      </a:r>
-                    </a:p>
-                  </a:txBody>
-                  <a:tcPr marL="54864" marR="54864" marT="27432" marB="27432" anchor="ctr">
-                    <a:solidFill>
-                      <a:srgbClr val="EEF2F8"/>
-                    </a:solidFill>
-                  </a:tcPr>
-                </a:tc>
-                <a:tc>
-                  <a:txBody>
-                    <a:bodyPr/>
-                    <a:lstStyle/>
-                    <a:p>
-                      <a:r>
-                        <a:rPr sz="1300" b="0">
-                          <a:solidFill>
-                            <a:srgbClr val="222222"/>
-                          </a:solidFill>
-                        </a:rPr>
-                        <a:t>bulk, one-minute bars</a:t>
-                      </a:r>
-                    </a:p>
-                  </a:txBody>
-                  <a:tcPr marL="54864" marR="54864" marT="27432" marB="27432" anchor="ctr">
-                    <a:solidFill>
-                      <a:srgbClr val="EEF2F8"/>
-                    </a:solidFill>
-                  </a:tcPr>
-                </a:tc>
-                <a:tc>
-                  <a:txBody>
-                    <a:bodyPr/>
-                    <a:lstStyle/>
-                    <a:p>
-                      <a:r>
-                        <a:rPr sz="1300" b="0">
-                          <a:solidFill>
-                            <a:srgbClr val="222222"/>
-                          </a:solidFill>
-                        </a:rPr>
-                        <a:t>same, plus 10-second bars and Lee-Ready</a:t>
-                      </a:r>
-                    </a:p>
-                  </a:txBody>
-                  <a:tcPr marL="54864" marR="54864" marT="27432" marB="27432" anchor="ctr">
-                    <a:solidFill>
-                      <a:srgbClr val="EEF2F8"/>
-                    </a:solidFill>
-                  </a:tcPr>
-                </a:tc>
-              </a:tr>
-              <a:tr h="396240">
-                <a:tc>
-                  <a:txBody>
-                    <a:bodyPr/>
-                    <a:lstStyle/>
-                    <a:p>
-                      <a:r>
-                        <a:rPr sz="1300" b="0">
-                          <a:solidFill>
-                            <a:srgbClr val="222222"/>
-                          </a:solidFill>
-                        </a:rPr>
-                        <a:t>Settings</a:t>
-                      </a:r>
-                    </a:p>
-                  </a:txBody>
-                  <a:tcPr marL="54864" marR="54864" marT="27432" marB="27432" anchor="ctr">
-                    <a:solidFill>
-                      <a:srgbClr val="FFFFFF"/>
-                    </a:solidFill>
-                  </a:tcPr>
-                </a:tc>
-                <a:tc>
-                  <a:txBody>
-                    <a:bodyPr/>
-                    <a:lstStyle/>
-                    <a:p>
-                      <a:r>
-                        <a:rPr sz="1300" b="0">
-                          <a:solidFill>
-                            <a:srgbClr val="222222"/>
-                          </a:solidFill>
-                        </a:rPr>
-                        <a:t>V = ADV/50, n = 50, whole-sample σ and CDF</a:t>
-                      </a:r>
-                    </a:p>
-                  </a:txBody>
-                  <a:tcPr marL="54864" marR="54864" marT="27432" marB="27432" anchor="ctr">
-                    <a:solidFill>
-                      <a:srgbClr val="FFFFFF"/>
-                    </a:solidFill>
-                  </a:tcPr>
-                </a:tc>
-                <a:tc>
-                  <a:txBody>
-                    <a:bodyPr/>
-                    <a:lstStyle/>
-                    <a:p>
-                      <a:r>
-                        <a:rPr sz="1300" b="0">
-                          <a:solidFill>
-                            <a:srgbClr val="222222"/>
-                          </a:solidFill>
-                        </a:rPr>
-                        <a:t>identical</a:t>
-                      </a:r>
-                    </a:p>
-                  </a:txBody>
-                  <a:tcPr marL="54864" marR="54864" marT="27432" marB="27432" anchor="ctr">
-                    <a:solidFill>
-                      <a:srgbClr val="FFFFFF"/>
-                    </a:solidFill>
-                  </a:tcPr>
-                </a:tc>
-              </a:tr>
-            </a:tbl>
-          </a:graphicData>
-        </a:graphic>
-      </p:graphicFrame>
-      <p:sp>
-        <p:nvSpPr>
-          <p:cNvPr id="6" name="TextBox 5"/>
-          <p:cNvSpPr txBox="1"/>
-          <p:nvPr/>
-        </p:nvSpPr>
-        <p:spPr>
-          <a:xfrm>
-            <a:off x="585216" y="4937760"/>
-            <a:ext cx="10972800" cy="1463040"/>
-          </a:xfrm>
-          <a:prstGeom prst="rect">
-            <a:avLst/>
-          </a:prstGeom>
-          <a:noFill/>
-        </p:spPr>
-        <p:txBody>
-          <a:bodyPr wrap="square" anchor="t" lIns="45720" rIns="45720">
-            <a:spAutoFit/>
-          </a:bodyPr>
-          <a:lstStyle/>
-          <a:p>
-            <a:pPr algn="l">
-              <a:spcAft>
-                <a:spcPts val="600"/>
-              </a:spcAft>
-            </a:pPr>
-            <a:r>
-              <a:rPr sz="1300" b="0">
-                <a:solidFill>
-                  <a:srgbClr val="595959"/>
-                </a:solidFill>
-              </a:rPr>
-              <a:t>• Main deviations: ETF instead of futures; regular hours only; our sample starts in Sep 2009 (no 2008 crisis); 42 IVE trades at prices like $0.08 that the exchanges </a:t>
-            </a:r>
-            <a:r>
-              <a:rPr sz="1300" b="1">
-                <a:solidFill>
-                  <a:srgbClr val="595959"/>
-                </a:solidFill>
-              </a:rPr>
-              <a:t>cancelled</a:t>
-            </a:r>
-            <a:r>
-              <a:rPr sz="1300" b="0">
-                <a:solidFill>
-                  <a:srgbClr val="595959"/>
-                </a:solidFill>
-              </a:rPr>
-              <a:t> on 6 May 2010 are removed. 29% of IVE one-minute bars have no price change, and bulk classification splits them 50/50.</a:t>
-            </a:r>
-          </a:p>
-          <a:p>
-            <a:pPr algn="l">
-              <a:spcAft>
-                <a:spcPts val="600"/>
-              </a:spcAft>
-            </a:pPr>
-            <a:r>
-              <a:rPr sz="1300" b="0">
-                <a:solidFill>
-                  <a:srgbClr val="595959"/>
-                </a:solidFill>
-              </a:rPr>
-              <a:t>• </a:t>
-            </a:r>
-            <a:r>
-              <a:rPr sz="1300" b="1">
-                <a:solidFill>
-                  <a:srgbClr val="595959"/>
-                </a:solidFill>
-              </a:rPr>
-              <a:t>±</a:t>
-            </a:r>
-            <a:r>
-              <a:rPr sz="1300" b="0">
-                <a:solidFill>
-                  <a:srgbClr val="595959"/>
-                </a:solidFill>
-              </a:rPr>
-              <a:t> on our numbers: block bootstrap over calendar months (1,000 replications), because VPIN windows overlap and volatility clusters.</a:t>
-            </a:r>
-          </a:p>
-        </p:txBody>
-      </p:sp>
-    </p:spTree>
-  </p:cSld>
-  <p:clrMapOvr>
-    <a:masterClrMapping/>
-  </p:clrMapOvr>
-</p:sld>
-</file>
-
-<file path=ppt/slides/slide8.xml><?xml version="1.0" encoding="utf-8"?>
 <p:sld xmlns:a="http://schemas.openxmlformats.org/drawingml/2006/main" xmlns:p="http://schemas.openxmlformats.org/presentationml/2006/main" xmlns:r="http://schemas.openxmlformats.org/officeDocument/2006/relationships">
   <p:cSld>
     <p:spTree>
@@ -48821,7 +48097,7 @@
 </p:sld>
 </file>
 
-<file path=ppt/slides/slide9.xml><?xml version="1.0" encoding="utf-8"?>
+<file path=ppt/slides/slide8.xml><?xml version="1.0" encoding="utf-8"?>
 <p:sld xmlns:a="http://schemas.openxmlformats.org/drawingml/2006/main" xmlns:p="http://schemas.openxmlformats.org/presentationml/2006/main" xmlns:r="http://schemas.openxmlformats.org/officeDocument/2006/relationships">
   <p:cSld>
     <p:spTree>
@@ -48847,7 +48123,7 @@
           <a:lstStyle/>
           <a:p>
             <a:r>
-              <a:t>Result 2: the volume clock and the stability of VPIN</a:t>
+              <a:t>Backup: the volume clock and the stability of VPIN</a:t>
             </a:r>
           </a:p>
         </p:txBody>
@@ -49991,6 +49267,303 @@
                 </a:solidFill>
               </a:rPr>
               <a:t> restarting the buckets 0, 1, …, 999 bars later changes VPIN by 3.7% of its mean on IVE; the paper reports 6.5% for the E-mini.</a:t>
+            </a:r>
+          </a:p>
+        </p:txBody>
+      </p:sp>
+    </p:spTree>
+  </p:cSld>
+  <p:clrMapOvr>
+    <a:masterClrMapping/>
+  </p:clrMapOvr>
+</p:sld>
+</file>
+
+<file path=ppt/slides/slide9.xml><?xml version="1.0" encoding="utf-8"?>
+<p:sld xmlns:a="http://schemas.openxmlformats.org/drawingml/2006/main" xmlns:p="http://schemas.openxmlformats.org/presentationml/2006/main" xmlns:r="http://schemas.openxmlformats.org/officeDocument/2006/relationships">
+  <p:cSld>
+    <p:spTree>
+      <p:nvGrpSpPr>
+        <p:cNvPr id="1" name=""/>
+        <p:cNvGrpSpPr/>
+        <p:nvPr/>
+      </p:nvGrpSpPr>
+      <p:grpSpPr/>
+      <p:sp>
+        <p:nvSpPr>
+          <p:cNvPr id="2" name="Title 1"/>
+          <p:cNvSpPr>
+            <a:spLocks noGrp="1"/>
+          </p:cNvSpPr>
+          <p:nvPr>
+            <p:ph type="title"/>
+          </p:nvPr>
+        </p:nvSpPr>
+        <p:spPr/>
+        <p:txBody>
+          <a:bodyPr/>
+          <a:lstStyle/>
+          <a:p>
+            <a:r>
+              <a:t>Result 2: does VPIN predict the next bucket's volatility?</a:t>
+            </a:r>
+          </a:p>
+        </p:txBody>
+      </p:sp>
+      <p:sp>
+        <p:nvSpPr>
+          <p:cNvPr id="4" name="Text Placeholder 3"/>
+          <p:cNvSpPr>
+            <a:spLocks noGrp="1"/>
+          </p:cNvSpPr>
+          <p:nvPr>
+            <p:ph type="body" idx="2"/>
+          </p:nvPr>
+        </p:nvSpPr>
+        <p:spPr/>
+        <p:txBody>
+          <a:bodyPr/>
+          <a:lstStyle/>
+          <a:p>
+            <a:r>
+              <a:t>Research Seminar</a:t>
+            </a:r>
+          </a:p>
+        </p:txBody>
+      </p:sp>
+      <p:pic>
+        <p:nvPicPr>
+          <p:cNvPr id="5" name="Picture 4" descr="paper_fig10.png"/>
+          <p:cNvPicPr>
+            <a:picLocks noChangeAspect="1"/>
+          </p:cNvPicPr>
+          <p:nvPr/>
+        </p:nvPicPr>
+        <p:blipFill>
+          <a:blip r:embed="rId3"/>
+          <a:stretch>
+            <a:fillRect/>
+          </a:stretch>
+        </p:blipFill>
+        <p:spPr>
+          <a:xfrm>
+            <a:off x="365760" y="2180953"/>
+            <a:ext cx="5120640" cy="3501933"/>
+          </a:xfrm>
+          <a:prstGeom prst="rect">
+            <a:avLst/>
+          </a:prstGeom>
+        </p:spPr>
+      </p:pic>
+      <p:sp>
+        <p:nvSpPr>
+          <p:cNvPr id="6" name="TextBox 5"/>
+          <p:cNvSpPr txBox="1"/>
+          <p:nvPr/>
+        </p:nvSpPr>
+        <p:spPr>
+          <a:xfrm>
+            <a:off x="365760" y="5715000"/>
+            <a:ext cx="5120640" cy="640080"/>
+          </a:xfrm>
+          <a:prstGeom prst="rect">
+            <a:avLst/>
+          </a:prstGeom>
+          <a:noFill/>
+        </p:spPr>
+        <p:txBody>
+          <a:bodyPr wrap="square" anchor="t" lIns="45720" rIns="45720">
+            <a:spAutoFit/>
+          </a:bodyPr>
+          <a:lstStyle/>
+          <a:p>
+            <a:pPr algn="ctr">
+              <a:spcAft>
+                <a:spcPts val="600"/>
+              </a:spcAft>
+            </a:pPr>
+            <a:r>
+              <a:rPr sz="1200" b="0">
+                <a:solidFill>
+                  <a:srgbClr val="595959"/>
+                </a:solidFill>
+              </a:rPr>
+              <a:t>Paper (E-mini): 0.40 at (50, 250), 95% CI [0.392, 0.408] (iid)</a:t>
+            </a:r>
+          </a:p>
+        </p:txBody>
+      </p:sp>
+      <p:pic>
+        <p:nvPicPr>
+          <p:cNvPr id="7" name="Picture 6" descr="fig10_correlation.png"/>
+          <p:cNvPicPr>
+            <a:picLocks noChangeAspect="1"/>
+          </p:cNvPicPr>
+          <p:nvPr/>
+        </p:nvPicPr>
+        <p:blipFill>
+          <a:blip r:embed="rId4"/>
+          <a:stretch>
+            <a:fillRect/>
+          </a:stretch>
+        </p:blipFill>
+        <p:spPr>
+          <a:xfrm>
+            <a:off x="5669280" y="2358513"/>
+            <a:ext cx="4206240" cy="3146812"/>
+          </a:xfrm>
+          <a:prstGeom prst="rect">
+            <a:avLst/>
+          </a:prstGeom>
+        </p:spPr>
+      </p:pic>
+      <p:sp>
+        <p:nvSpPr>
+          <p:cNvPr id="8" name="TextBox 7"/>
+          <p:cNvSpPr txBox="1"/>
+          <p:nvPr/>
+        </p:nvSpPr>
+        <p:spPr>
+          <a:xfrm>
+            <a:off x="5669280" y="5715000"/>
+            <a:ext cx="4206240" cy="640080"/>
+          </a:xfrm>
+          <a:prstGeom prst="rect">
+            <a:avLst/>
+          </a:prstGeom>
+          <a:noFill/>
+        </p:spPr>
+        <p:txBody>
+          <a:bodyPr wrap="square" anchor="t" lIns="45720" rIns="45720">
+            <a:spAutoFit/>
+          </a:bodyPr>
+          <a:lstStyle/>
+          <a:p>
+            <a:pPr algn="ctr">
+              <a:spcAft>
+                <a:spcPts val="600"/>
+              </a:spcAft>
+            </a:pPr>
+            <a:r>
+              <a:rPr sz="1200" b="0">
+                <a:solidFill>
+                  <a:srgbClr val="595959"/>
+                </a:solidFill>
+              </a:rPr>
+              <a:t>Ours (IVE): 0.08 ± 0.05 at (50, 250), 95% CI [0.04, 0.22]</a:t>
+            </a:r>
+          </a:p>
+        </p:txBody>
+      </p:sp>
+      <p:sp>
+        <p:nvSpPr>
+          <p:cNvPr id="9" name="TextBox 8"/>
+          <p:cNvSpPr txBox="1"/>
+          <p:nvPr/>
+        </p:nvSpPr>
+        <p:spPr>
+          <a:xfrm>
+            <a:off x="9966960" y="2148840"/>
+            <a:ext cx="2103120" cy="4297680"/>
+          </a:xfrm>
+          <a:prstGeom prst="rect">
+            <a:avLst/>
+          </a:prstGeom>
+          <a:noFill/>
+        </p:spPr>
+        <p:txBody>
+          <a:bodyPr wrap="square" anchor="t" lIns="45720" rIns="45720">
+            <a:spAutoFit/>
+          </a:bodyPr>
+          <a:lstStyle/>
+          <a:p>
+            <a:pPr algn="l">
+              <a:spcAft>
+                <a:spcPts val="600"/>
+              </a:spcAft>
+            </a:pPr>
+            <a:r>
+              <a:rPr sz="1400" b="1">
+                <a:solidFill>
+                  <a:srgbClr val="0F2C68"/>
+                </a:solidFill>
+              </a:rPr>
+              <a:t>On IVE</a:t>
+            </a:r>
+          </a:p>
+          <a:p>
+            <a:pPr algn="l">
+              <a:spcAft>
+                <a:spcPts val="1000"/>
+              </a:spcAft>
+            </a:pPr>
+            <a:r>
+              <a:rPr sz="1200" b="0">
+                <a:solidFill>
+                  <a:srgbClr val="222222"/>
+                </a:solidFill>
+              </a:rPr>
+              <a:t>Same sign; 0.40 is outside our interval.</a:t>
+            </a:r>
+          </a:p>
+          <a:p>
+            <a:pPr algn="l">
+              <a:spcAft>
+                <a:spcPts val="600"/>
+              </a:spcAft>
+            </a:pPr>
+            <a:r>
+              <a:rPr sz="1400" b="1">
+                <a:solidFill>
+                  <a:srgbClr val="0F2C68"/>
+                </a:solidFill>
+              </a:rPr>
+              <a:t>About the ±</a:t>
+            </a:r>
+          </a:p>
+          <a:p>
+            <a:pPr algn="l">
+              <a:spcAft>
+                <a:spcPts val="1000"/>
+              </a:spcAft>
+            </a:pPr>
+            <a:r>
+              <a:rPr sz="1200" b="0">
+                <a:solidFill>
+                  <a:srgbClr val="222222"/>
+                </a:solidFill>
+              </a:rPr>
+              <a:t>An iid interval would give ours as [0.07, 0.09]: overlapping windows make it far too narrow.</a:t>
+            </a:r>
+          </a:p>
+          <a:p>
+            <a:pPr algn="l">
+              <a:spcAft>
+                <a:spcPts val="600"/>
+              </a:spcAft>
+            </a:pPr>
+            <a:r>
+              <a:rPr sz="1400" b="1">
+                <a:solidFill>
+                  <a:srgbClr val="0F2C68"/>
+                </a:solidFill>
+              </a:rPr>
+              <a:t>On every window</a:t>
+            </a:r>
+          </a:p>
+          <a:p>
+            <a:pPr algn="l">
+              <a:spcAft>
+                <a:spcPts val="600"/>
+              </a:spcAft>
+            </a:pPr>
+            <a:r>
+              <a:rPr sz="1200" b="0">
+                <a:solidFill>
+                  <a:srgbClr val="222222"/>
+                </a:solidFill>
+              </a:rPr>
+              <a:t>None of 41 two-year windows (IVE, BTC) reaches the paper's 0.40, nor its &gt; 84% for big moves; we could detect ≥ 0.13.</a:t>
             </a:r>
           </a:p>
         </p:txBody>

</xml_diff>

<commit_message>
Add group 8 and the team's surnames to the title slide, guide and README
</commit_message>
<xml_diff>
--- a/docs/presentation.pptx
+++ b/docs/presentation.pptx
@@ -1565,7 +1565,7 @@
           <a:lstStyle/>
           <a:p>
             <a:r>
-              <a:t>Fill in the group number and names. Timing (15 min): problem 2 · method 3 · results and reproduction 5 · critique 3 · next steps 2. Then 10 minutes of questions.</a:t>
+              <a:t>Timing (15 min): problem 2 · method 3 · results and reproduction 5 · critique 3 · next steps 2. Then 10 minutes of questions.</a:t>
             </a:r>
           </a:p>
         </p:txBody>
@@ -36078,7 +36078,7 @@
           <a:lstStyle/>
           <a:p>
             <a:r>
-              <a:t>Group N</a:t>
+              <a:t>Group 8</a:t>
             </a:r>
           </a:p>
         </p:txBody>
@@ -36152,7 +36152,7 @@
                   <a:srgbClr val="595959"/>
                 </a:solidFill>
               </a:rPr>
-              <a:t>Name Surname · Name Surname · Name Surname</a:t>
+              <a:t>Nazarov · Doroshenko · Burlakov · Daunov · Sergeev</a:t>
             </a:r>
           </a:p>
         </p:txBody>

</xml_diff>

<commit_message>
Add a speaker script; show only the claims that hold on the scorecard slide
- scripts/make_speaker_script.py writes docs/speaker_script.pdf: for every
  slide, the text to say, each formula and method explained symbol by
  symbol, and likely questions with answers. Numbers come from results/
  and slide numbers from the deck; the build fails if a slide has no
  section or the spoken text runs past 15 minutes.
- make_guide.py: render() and verify() take a footer label and CSS so the
  script can reuse them; the guide itself is unchanged.
- Scorecard slide: rows whose verdict is inconclusive or not reproduced
  are left off (SCORECARD_HIDDEN) and the rest renumbered. They remain on
  the Result 1 slide, the Tables 4-5 backup, the README and the guide;
  the slide notes say where.
- README links the speaker script and lists its build step.
</commit_message>
<xml_diff>
--- a/docs/presentation.pptx
+++ b/docs/presentation.pptx
@@ -1705,7 +1705,7 @@
           <a:lstStyle/>
           <a:p>
             <a:r>
-              <a:t>Summary. Left: what the paper reports. Right: what we find on IVE, with ± and a verdict that uses only our own data: reproduced if the paper's value is inside our 95% interval and the effect's direction is significant; inconclusive if inside but not significant; weaker if outside but the direction holds; not reproduced otherwise. Rule in scripts/make_report.py. Sources: results/report/scorecard_*.csv.</a:t>
+              <a:t>Summary. Left: what the paper reports. Right: what we find on IVE, with ± and a verdict that uses only our own data: reproduced if the paper's value is inside our 95% interval and the effect's direction is significant; weaker if outside but the direction holds. Rule in scripts/make_report.py. Not on this slide, if asked: the flash crash with 10-second bars and with Lee-Ready (not reproduced; Result 1 slide) and Table 5 at (10, 350) (inconclusive; Tables 4 and 5 backup). The README and the guide keep every row. Sources: results/report/scorecard_*.csv.</a:t>
             </a:r>
           </a:p>
         </p:txBody>
@@ -36562,7 +36562,7 @@
         </p:nvGraphicFramePr>
         <p:xfrm>
           <a:off x="365760" y="2377440"/>
-          <a:ext cx="7040880" cy="4114800"/>
+          <a:ext cx="7040880" cy="3072384"/>
         </p:xfrm>
         <a:graphic>
           <a:graphicData uri="http://schemas.openxmlformats.org/drawingml/2006/table">
@@ -36575,7 +36575,7 @@
                 <a:gridCol w="5257800"/>
                 <a:gridCol w="1463040"/>
               </a:tblGrid>
-              <a:tr h="374072">
+              <a:tr h="384048">
                 <a:tc>
                   <a:txBody>
                     <a:bodyPr/>
@@ -36640,7 +36640,7 @@
                   </a:tcPr>
                 </a:tc>
               </a:tr>
-              <a:tr h="374072">
+              <a:tr h="384048">
                 <a:tc>
                   <a:txBody>
                     <a:bodyPr/>
@@ -36705,7 +36705,7 @@
                   </a:tcPr>
                 </a:tc>
               </a:tr>
-              <a:tr h="374072">
+              <a:tr h="384048">
                 <a:tc>
                   <a:txBody>
                     <a:bodyPr/>
@@ -36770,7 +36770,7 @@
                   </a:tcPr>
                 </a:tc>
               </a:tr>
-              <a:tr h="374072">
+              <a:tr h="384048">
                 <a:tc>
                   <a:txBody>
                     <a:bodyPr/>
@@ -36835,7 +36835,7 @@
                   </a:tcPr>
                 </a:tc>
               </a:tr>
-              <a:tr h="374072">
+              <a:tr h="384048">
                 <a:tc>
                   <a:txBody>
                     <a:bodyPr/>
@@ -36848,136 +36848,6 @@
                           </a:solidFill>
                         </a:rPr>
                         <a:t>4</a:t>
-                      </a:r>
-                    </a:p>
-                  </a:txBody>
-                  <a:tcPr marL="54864" marR="54864" marT="27432" marB="27432" anchor="ctr">
-                    <a:solidFill>
-                      <a:srgbClr val="EEF2F8"/>
-                    </a:solidFill>
-                  </a:tcPr>
-                </a:tc>
-                <a:tc>
-                  <a:txBody>
-                    <a:bodyPr/>
-                    <a:lstStyle/>
-                    <a:p>
-                      <a:r>
-                        <a:rPr sz="1000" b="0">
-                          <a:solidFill>
-                            <a:srgbClr val="222222"/>
-                          </a:solidFill>
-                        </a:rPr>
-                        <a:t>... BVC, 10-second bars</a:t>
-                      </a:r>
-                    </a:p>
-                  </a:txBody>
-                  <a:tcPr marL="54864" marR="54864" marT="27432" marB="27432" anchor="ctr">
-                    <a:solidFill>
-                      <a:srgbClr val="EEF2F8"/>
-                    </a:solidFill>
-                  </a:tcPr>
-                </a:tc>
-                <a:tc>
-                  <a:txBody>
-                    <a:bodyPr/>
-                    <a:lstStyle/>
-                    <a:p>
-                      <a:r>
-                        <a:rPr sz="1000" b="0">
-                          <a:solidFill>
-                            <a:srgbClr val="222222"/>
-                          </a:solidFill>
-                        </a:rPr>
-                        <a:t>≥ 2 h</a:t>
-                      </a:r>
-                    </a:p>
-                  </a:txBody>
-                  <a:tcPr marL="54864" marR="54864" marT="27432" marB="27432" anchor="ctr">
-                    <a:solidFill>
-                      <a:srgbClr val="EEF2F8"/>
-                    </a:solidFill>
-                  </a:tcPr>
-                </a:tc>
-              </a:tr>
-              <a:tr h="374072">
-                <a:tc>
-                  <a:txBody>
-                    <a:bodyPr/>
-                    <a:lstStyle/>
-                    <a:p>
-                      <a:r>
-                        <a:rPr sz="1000" b="0">
-                          <a:solidFill>
-                            <a:srgbClr val="222222"/>
-                          </a:solidFill>
-                        </a:rPr>
-                        <a:t>5</a:t>
-                      </a:r>
-                    </a:p>
-                  </a:txBody>
-                  <a:tcPr marL="54864" marR="54864" marT="27432" marB="27432" anchor="ctr">
-                    <a:solidFill>
-                      <a:srgbClr val="FFFFFF"/>
-                    </a:solidFill>
-                  </a:tcPr>
-                </a:tc>
-                <a:tc>
-                  <a:txBody>
-                    <a:bodyPr/>
-                    <a:lstStyle/>
-                    <a:p>
-                      <a:r>
-                        <a:rPr sz="1000" b="0">
-                          <a:solidFill>
-                            <a:srgbClr val="222222"/>
-                          </a:solidFill>
-                        </a:rPr>
-                        <a:t>... Lee-Ready, trade by trade</a:t>
-                      </a:r>
-                    </a:p>
-                  </a:txBody>
-                  <a:tcPr marL="54864" marR="54864" marT="27432" marB="27432" anchor="ctr">
-                    <a:solidFill>
-                      <a:srgbClr val="FFFFFF"/>
-                    </a:solidFill>
-                  </a:tcPr>
-                </a:tc>
-                <a:tc>
-                  <a:txBody>
-                    <a:bodyPr/>
-                    <a:lstStyle/>
-                    <a:p>
-                      <a:r>
-                        <a:rPr sz="1000" b="0">
-                          <a:solidFill>
-                            <a:srgbClr val="222222"/>
-                          </a:solidFill>
-                        </a:rPr>
-                        <a:t>≥ 2 h</a:t>
-                      </a:r>
-                    </a:p>
-                  </a:txBody>
-                  <a:tcPr marL="54864" marR="54864" marT="27432" marB="27432" anchor="ctr">
-                    <a:solidFill>
-                      <a:srgbClr val="FFFFFF"/>
-                    </a:solidFill>
-                  </a:tcPr>
-                </a:tc>
-              </a:tr>
-              <a:tr h="374072">
-                <a:tc>
-                  <a:txBody>
-                    <a:bodyPr/>
-                    <a:lstStyle/>
-                    <a:p>
-                      <a:r>
-                        <a:rPr sz="1000" b="0">
-                          <a:solidFill>
-                            <a:srgbClr val="222222"/>
-                          </a:solidFill>
-                        </a:rPr>
-                        <a:t>6</a:t>
                       </a:r>
                     </a:p>
                   </a:txBody>
@@ -37030,7 +36900,7 @@
                   </a:tcPr>
                 </a:tc>
               </a:tr>
-              <a:tr h="374072">
+              <a:tr h="384048">
                 <a:tc>
                   <a:txBody>
                     <a:bodyPr/>
@@ -37042,7 +36912,7 @@
                             <a:srgbClr val="222222"/>
                           </a:solidFill>
                         </a:rPr>
-                        <a:t>7</a:t>
+                        <a:t>5</a:t>
                       </a:r>
                     </a:p>
                   </a:txBody>
@@ -37095,7 +36965,7 @@
                   </a:tcPr>
                 </a:tc>
               </a:tr>
-              <a:tr h="374072">
+              <a:tr h="384048">
                 <a:tc>
                   <a:txBody>
                     <a:bodyPr/>
@@ -37107,7 +36977,7 @@
                             <a:srgbClr val="222222"/>
                           </a:solidFill>
                         </a:rPr>
-                        <a:t>8</a:t>
+                        <a:t>6</a:t>
                       </a:r>
                     </a:p>
                   </a:txBody>
@@ -37160,7 +37030,7 @@
                   </a:tcPr>
                 </a:tc>
               </a:tr>
-              <a:tr h="374072">
+              <a:tr h="384048">
                 <a:tc>
                   <a:txBody>
                     <a:bodyPr/>
@@ -37172,7 +37042,7 @@
                             <a:srgbClr val="222222"/>
                           </a:solidFill>
                         </a:rPr>
-                        <a:t>9</a:t>
+                        <a:t>7</a:t>
                       </a:r>
                     </a:p>
                   </a:txBody>
@@ -37225,71 +37095,6 @@
                   </a:tcPr>
                 </a:tc>
               </a:tr>
-              <a:tr h="374080">
-                <a:tc>
-                  <a:txBody>
-                    <a:bodyPr/>
-                    <a:lstStyle/>
-                    <a:p>
-                      <a:r>
-                        <a:rPr sz="1000" b="0">
-                          <a:solidFill>
-                            <a:srgbClr val="222222"/>
-                          </a:solidFill>
-                        </a:rPr>
-                        <a:t>10</a:t>
-                      </a:r>
-                    </a:p>
-                  </a:txBody>
-                  <a:tcPr marL="54864" marR="54864" marT="27432" marB="27432" anchor="ctr">
-                    <a:solidFill>
-                      <a:srgbClr val="EEF2F8"/>
-                    </a:solidFill>
-                  </a:tcPr>
-                </a:tc>
-                <a:tc>
-                  <a:txBody>
-                    <a:bodyPr/>
-                    <a:lstStyle/>
-                    <a:p>
-                      <a:r>
-                        <a:rPr sz="1000" b="0">
-                          <a:solidFill>
-                            <a:srgbClr val="222222"/>
-                          </a:solidFill>
-                        </a:rPr>
-                        <a:t>... at (10, 350)</a:t>
-                      </a:r>
-                    </a:p>
-                  </a:txBody>
-                  <a:tcPr marL="54864" marR="54864" marT="27432" marB="27432" anchor="ctr">
-                    <a:solidFill>
-                      <a:srgbClr val="EEF2F8"/>
-                    </a:solidFill>
-                  </a:tcPr>
-                </a:tc>
-                <a:tc>
-                  <a:txBody>
-                    <a:bodyPr/>
-                    <a:lstStyle/>
-                    <a:p>
-                      <a:r>
-                        <a:rPr sz="1000" b="0">
-                          <a:solidFill>
-                            <a:srgbClr val="222222"/>
-                          </a:solidFill>
-                        </a:rPr>
-                        <a:t>78.6%</a:t>
-                      </a:r>
-                    </a:p>
-                  </a:txBody>
-                  <a:tcPr marL="54864" marR="54864" marT="27432" marB="27432" anchor="ctr">
-                    <a:solidFill>
-                      <a:srgbClr val="EEF2F8"/>
-                    </a:solidFill>
-                  </a:tcPr>
-                </a:tc>
-              </a:tr>
             </a:tbl>
           </a:graphicData>
         </a:graphic>
@@ -37342,7 +37147,7 @@
         </p:nvGraphicFramePr>
         <p:xfrm>
           <a:off x="7543800" y="2377440"/>
-          <a:ext cx="4343400" cy="4114800"/>
+          <a:ext cx="4343400" cy="3072384"/>
         </p:xfrm>
         <a:graphic>
           <a:graphicData uri="http://schemas.openxmlformats.org/drawingml/2006/table">
@@ -37356,7 +37161,7 @@
                 <a:gridCol w="1188720"/>
                 <a:gridCol w="1371600"/>
               </a:tblGrid>
-              <a:tr h="374072">
+              <a:tr h="384048">
                 <a:tc>
                   <a:txBody>
                     <a:bodyPr/>
@@ -37442,7 +37247,7 @@
                   </a:tcPr>
                 </a:tc>
               </a:tr>
-              <a:tr h="374072">
+              <a:tr h="384048">
                 <a:tc>
                   <a:txBody>
                     <a:bodyPr/>
@@ -37528,7 +37333,7 @@
                   </a:tcPr>
                 </a:tc>
               </a:tr>
-              <a:tr h="374072">
+              <a:tr h="384048">
                 <a:tc>
                   <a:txBody>
                     <a:bodyPr/>
@@ -37614,7 +37419,7 @@
                   </a:tcPr>
                 </a:tc>
               </a:tr>
-              <a:tr h="374072">
+              <a:tr h="384048">
                 <a:tc>
                   <a:txBody>
                     <a:bodyPr/>
@@ -37700,7 +37505,7 @@
                   </a:tcPr>
                 </a:tc>
               </a:tr>
-              <a:tr h="374072">
+              <a:tr h="384048">
                 <a:tc>
                   <a:txBody>
                     <a:bodyPr/>
@@ -37713,178 +37518,6 @@
                           </a:solidFill>
                         </a:rPr>
                         <a:t>4</a:t>
-                      </a:r>
-                    </a:p>
-                  </a:txBody>
-                  <a:tcPr marL="54864" marR="54864" marT="27432" marB="27432" anchor="ctr">
-                    <a:solidFill>
-                      <a:srgbClr val="EEF2F8"/>
-                    </a:solidFill>
-                  </a:tcPr>
-                </a:tc>
-                <a:tc>
-                  <a:txBody>
-                    <a:bodyPr/>
-                    <a:lstStyle/>
-                    <a:p>
-                      <a:r>
-                        <a:rPr sz="1000" b="0">
-                          <a:solidFill>
-                            <a:srgbClr val="222222"/>
-                          </a:solidFill>
-                        </a:rPr>
-                        <a:t>only during the fall</a:t>
-                      </a:r>
-                    </a:p>
-                  </a:txBody>
-                  <a:tcPr marL="54864" marR="54864" marT="27432" marB="27432" anchor="ctr">
-                    <a:solidFill>
-                      <a:srgbClr val="EEF2F8"/>
-                    </a:solidFill>
-                  </a:tcPr>
-                </a:tc>
-                <a:tc>
-                  <a:txBody>
-                    <a:bodyPr/>
-                    <a:lstStyle/>
-                    <a:p>
-                      <a:r>
-                        <a:rPr sz="1000" b="0">
-                          <a:solidFill>
-                            <a:srgbClr val="222222"/>
-                          </a:solidFill>
-                        </a:rPr>
-                        <a:t>–</a:t>
-                      </a:r>
-                    </a:p>
-                  </a:txBody>
-                  <a:tcPr marL="54864" marR="54864" marT="27432" marB="27432" anchor="ctr">
-                    <a:solidFill>
-                      <a:srgbClr val="EEF2F8"/>
-                    </a:solidFill>
-                  </a:tcPr>
-                </a:tc>
-                <a:tc>
-                  <a:txBody>
-                    <a:bodyPr/>
-                    <a:lstStyle/>
-                    <a:p>
-                      <a:r>
-                        <a:rPr sz="1000" b="1">
-                          <a:solidFill>
-                            <a:srgbClr val="FFFFFF"/>
-                          </a:solidFill>
-                        </a:rPr>
-                        <a:t>not reproduced</a:t>
-                      </a:r>
-                    </a:p>
-                  </a:txBody>
-                  <a:tcPr marL="54864" marR="54864" marT="27432" marB="27432" anchor="ctr">
-                    <a:solidFill>
-                      <a:srgbClr val="C0392B"/>
-                    </a:solidFill>
-                  </a:tcPr>
-                </a:tc>
-              </a:tr>
-              <a:tr h="374072">
-                <a:tc>
-                  <a:txBody>
-                    <a:bodyPr/>
-                    <a:lstStyle/>
-                    <a:p>
-                      <a:r>
-                        <a:rPr sz="1000" b="0">
-                          <a:solidFill>
-                            <a:srgbClr val="222222"/>
-                          </a:solidFill>
-                        </a:rPr>
-                        <a:t>5</a:t>
-                      </a:r>
-                    </a:p>
-                  </a:txBody>
-                  <a:tcPr marL="54864" marR="54864" marT="27432" marB="27432" anchor="ctr">
-                    <a:solidFill>
-                      <a:srgbClr val="FFFFFF"/>
-                    </a:solidFill>
-                  </a:tcPr>
-                </a:tc>
-                <a:tc>
-                  <a:txBody>
-                    <a:bodyPr/>
-                    <a:lstStyle/>
-                    <a:p>
-                      <a:r>
-                        <a:rPr sz="1000" b="0">
-                          <a:solidFill>
-                            <a:srgbClr val="222222"/>
-                          </a:solidFill>
-                        </a:rPr>
-                        <a:t>never (max CDF 0.85)</a:t>
-                      </a:r>
-                    </a:p>
-                  </a:txBody>
-                  <a:tcPr marL="54864" marR="54864" marT="27432" marB="27432" anchor="ctr">
-                    <a:solidFill>
-                      <a:srgbClr val="FFFFFF"/>
-                    </a:solidFill>
-                  </a:tcPr>
-                </a:tc>
-                <a:tc>
-                  <a:txBody>
-                    <a:bodyPr/>
-                    <a:lstStyle/>
-                    <a:p>
-                      <a:r>
-                        <a:rPr sz="1000" b="0">
-                          <a:solidFill>
-                            <a:srgbClr val="222222"/>
-                          </a:solidFill>
-                        </a:rPr>
-                        <a:t>–</a:t>
-                      </a:r>
-                    </a:p>
-                  </a:txBody>
-                  <a:tcPr marL="54864" marR="54864" marT="27432" marB="27432" anchor="ctr">
-                    <a:solidFill>
-                      <a:srgbClr val="FFFFFF"/>
-                    </a:solidFill>
-                  </a:tcPr>
-                </a:tc>
-                <a:tc>
-                  <a:txBody>
-                    <a:bodyPr/>
-                    <a:lstStyle/>
-                    <a:p>
-                      <a:r>
-                        <a:rPr sz="1000" b="1">
-                          <a:solidFill>
-                            <a:srgbClr val="FFFFFF"/>
-                          </a:solidFill>
-                        </a:rPr>
-                        <a:t>not reproduced</a:t>
-                      </a:r>
-                    </a:p>
-                  </a:txBody>
-                  <a:tcPr marL="54864" marR="54864" marT="27432" marB="27432" anchor="ctr">
-                    <a:solidFill>
-                      <a:srgbClr val="C0392B"/>
-                    </a:solidFill>
-                  </a:tcPr>
-                </a:tc>
-              </a:tr>
-              <a:tr h="374072">
-                <a:tc>
-                  <a:txBody>
-                    <a:bodyPr/>
-                    <a:lstStyle/>
-                    <a:p>
-                      <a:r>
-                        <a:rPr sz="1000" b="0">
-                          <a:solidFill>
-                            <a:srgbClr val="222222"/>
-                          </a:solidFill>
-                        </a:rPr>
-                        <a:t>6</a:t>
                       </a:r>
                     </a:p>
                   </a:txBody>
@@ -37958,7 +37591,7 @@
                   </a:tcPr>
                 </a:tc>
               </a:tr>
-              <a:tr h="374072">
+              <a:tr h="384048">
                 <a:tc>
                   <a:txBody>
                     <a:bodyPr/>
@@ -37970,7 +37603,7 @@
                             <a:srgbClr val="222222"/>
                           </a:solidFill>
                         </a:rPr>
-                        <a:t>7</a:t>
+                        <a:t>5</a:t>
                       </a:r>
                     </a:p>
                   </a:txBody>
@@ -38044,7 +37677,7 @@
                   </a:tcPr>
                 </a:tc>
               </a:tr>
-              <a:tr h="374072">
+              <a:tr h="384048">
                 <a:tc>
                   <a:txBody>
                     <a:bodyPr/>
@@ -38056,7 +37689,7 @@
                             <a:srgbClr val="222222"/>
                           </a:solidFill>
                         </a:rPr>
-                        <a:t>8</a:t>
+                        <a:t>6</a:t>
                       </a:r>
                     </a:p>
                   </a:txBody>
@@ -38130,7 +37763,7 @@
                   </a:tcPr>
                 </a:tc>
               </a:tr>
-              <a:tr h="374072">
+              <a:tr h="384048">
                 <a:tc>
                   <a:txBody>
                     <a:bodyPr/>
@@ -38142,7 +37775,7 @@
                             <a:srgbClr val="222222"/>
                           </a:solidFill>
                         </a:rPr>
-                        <a:t>9</a:t>
+                        <a:t>7</a:t>
                       </a:r>
                     </a:p>
                   </a:txBody>
@@ -38212,92 +37845,6 @@
                   <a:tcPr marL="54864" marR="54864" marT="27432" marB="27432" anchor="ctr">
                     <a:solidFill>
                       <a:srgbClr val="EB8C3C"/>
-                    </a:solidFill>
-                  </a:tcPr>
-                </a:tc>
-              </a:tr>
-              <a:tr h="374080">
-                <a:tc>
-                  <a:txBody>
-                    <a:bodyPr/>
-                    <a:lstStyle/>
-                    <a:p>
-                      <a:r>
-                        <a:rPr sz="1000" b="0">
-                          <a:solidFill>
-                            <a:srgbClr val="222222"/>
-                          </a:solidFill>
-                        </a:rPr>
-                        <a:t>10</a:t>
-                      </a:r>
-                    </a:p>
-                  </a:txBody>
-                  <a:tcPr marL="54864" marR="54864" marT="27432" marB="27432" anchor="ctr">
-                    <a:solidFill>
-                      <a:srgbClr val="EEF2F8"/>
-                    </a:solidFill>
-                  </a:tcPr>
-                </a:tc>
-                <a:tc>
-                  <a:txBody>
-                    <a:bodyPr/>
-                    <a:lstStyle/>
-                    <a:p>
-                      <a:r>
-                        <a:rPr sz="1000" b="0">
-                          <a:solidFill>
-                            <a:srgbClr val="222222"/>
-                          </a:solidFill>
-                        </a:rPr>
-                        <a:t>60% ± 12%</a:t>
-                      </a:r>
-                    </a:p>
-                  </a:txBody>
-                  <a:tcPr marL="54864" marR="54864" marT="27432" marB="27432" anchor="ctr">
-                    <a:solidFill>
-                      <a:srgbClr val="EEF2F8"/>
-                    </a:solidFill>
-                  </a:tcPr>
-                </a:tc>
-                <a:tc>
-                  <a:txBody>
-                    <a:bodyPr/>
-                    <a:lstStyle/>
-                    <a:p>
-                      <a:r>
-                        <a:rPr sz="1000" b="0">
-                          <a:solidFill>
-                            <a:srgbClr val="222222"/>
-                          </a:solidFill>
-                        </a:rPr>
-                        <a:t>[37%, 85%]</a:t>
-                      </a:r>
-                    </a:p>
-                  </a:txBody>
-                  <a:tcPr marL="54864" marR="54864" marT="27432" marB="27432" anchor="ctr">
-                    <a:solidFill>
-                      <a:srgbClr val="EEF2F8"/>
-                    </a:solidFill>
-                  </a:tcPr>
-                </a:tc>
-                <a:tc>
-                  <a:txBody>
-                    <a:bodyPr/>
-                    <a:lstStyle/>
-                    <a:p>
-                      <a:r>
-                        <a:rPr sz="1000" b="1">
-                          <a:solidFill>
-                            <a:srgbClr val="FFFFFF"/>
-                          </a:solidFill>
-                        </a:rPr>
-                        <a:t>inconclusive</a:t>
-                      </a:r>
-                    </a:p>
-                  </a:txBody>
-                  <a:tcPr marL="54864" marR="54864" marT="27432" marB="27432" anchor="ctr">
-                    <a:solidFill>
-                      <a:srgbClr val="595959"/>
                     </a:solidFill>
                   </a:tcPr>
                 </a:tc>

</xml_diff>